<commit_message>
Spell out the LASSO acronym in slides, narration, and report
Co-Authored-By: Claude Fable 5 <noreply@anthropic.com>
</commit_message>
<xml_diff>
--- a/submission/MBDL_Seminar_Presentation.pptx
+++ b/submission/MBDL_Seminar_Presentation.pptx
@@ -1147,7 +1147,7 @@
           <a:lstStyle/>
           <a:p>
             <a:r>
-              <a:t>Let us define the problem. We want to recover a sparse vector x-star of dimension n, but we only observe m linear measurements, with m smaller than n, possibly with noise. This inverse problem is underdetermined — infinitely many signals explain the same measurements. The sparsity assumption is what makes it solvable, and this situation appears everywhere: MRI acceleration, radar, hyperspectral imaging. The standard formulation is the LASSO: a trade-off between fidelity to the measurements and an L1 norm that promotes sparsity. Our metrics are NMSE in decibels for synthetic signals, plus PSNR and SSIM for images.</a:t>
+              <a:t>Let us define the problem. We want to recover a sparse vector x-star of dimension n, but we only observe m linear measurements, with m smaller than n, possibly with noise. This inverse problem is underdetermined — infinitely many signals explain the same measurements. The sparsity assumption is what makes it solvable, and this situation appears everywhere: MRI acceleration, radar, hyperspectral imaging. The standard formulation is the LASSO — Least Absolute Shrinkage and Selection Operator — a trade-off between fidelity to the measurements and an L1 norm that promotes sparsity. Our metrics are NMSE in decibels for synthetic signals, plus PSNR and SSIM for images.</a:t>
             </a:r>
           </a:p>
         </p:txBody>
@@ -13820,7 +13820,42 @@
       </p:pic>
       <p:sp>
         <p:nvSpPr>
-          <p:cNvPr id="12" name="Rectangle 11"/>
+          <p:cNvPr id="12" name="TextBox 11"/>
+          <p:cNvSpPr txBox="1"/>
+          <p:nvPr/>
+        </p:nvSpPr>
+        <p:spPr>
+          <a:xfrm>
+            <a:off x="502920" y="5074920"/>
+            <a:ext cx="5943600" cy="274320"/>
+          </a:xfrm>
+          <a:prstGeom prst="rect">
+            <a:avLst/>
+          </a:prstGeom>
+          <a:noFill/>
+        </p:spPr>
+        <p:txBody>
+          <a:bodyPr wrap="square">
+            <a:spAutoFit/>
+          </a:bodyPr>
+          <a:lstStyle/>
+          <a:p>
+            <a:pPr algn="l"/>
+            <a:r>
+              <a:rPr sz="1200" b="0" i="1">
+                <a:solidFill>
+                  <a:srgbClr val="4A5568"/>
+                </a:solidFill>
+                <a:latin typeface="Calibri"/>
+              </a:rPr>
+              <a:t>LASSO = Least Absolute Shrinkage and Selection Operator (Tibshirani, 1996)</a:t>
+            </a:r>
+          </a:p>
+        </p:txBody>
+      </p:sp>
+      <p:sp>
+        <p:nvSpPr>
+          <p:cNvPr id="13" name="Rectangle 12"/>
           <p:cNvSpPr/>
           <p:nvPr/>
         </p:nvSpPr>
@@ -13863,7 +13898,7 @@
       </p:sp>
       <p:sp>
         <p:nvSpPr>
-          <p:cNvPr id="13" name="TextBox 12"/>
+          <p:cNvPr id="14" name="TextBox 13"/>
           <p:cNvSpPr txBox="1"/>
           <p:nvPr/>
         </p:nvSpPr>
@@ -13898,7 +13933,7 @@
       </p:sp>
       <p:pic>
         <p:nvPicPr>
-          <p:cNvPr id="14" name="Picture 13" descr="image.png"/>
+          <p:cNvPr id="15" name="Picture 14" descr="image.png"/>
           <p:cNvPicPr>
             <a:picLocks noChangeAspect="1"/>
           </p:cNvPicPr>
@@ -13922,7 +13957,7 @@
       </p:pic>
       <p:sp>
         <p:nvSpPr>
-          <p:cNvPr id="15" name="TextBox 14"/>
+          <p:cNvPr id="16" name="TextBox 15"/>
           <p:cNvSpPr txBox="1"/>
           <p:nvPr/>
         </p:nvSpPr>
@@ -13957,7 +13992,7 @@
       </p:sp>
       <p:sp>
         <p:nvSpPr>
-          <p:cNvPr id="16" name="TextBox 15"/>
+          <p:cNvPr id="17" name="TextBox 16"/>
           <p:cNvSpPr txBox="1"/>
           <p:nvPr/>
         </p:nvSpPr>
@@ -13992,7 +14027,7 @@
       </p:sp>
       <p:sp>
         <p:nvSpPr>
-          <p:cNvPr id="17" name="TextBox 16"/>
+          <p:cNvPr id="18" name="TextBox 17"/>
           <p:cNvSpPr txBox="1"/>
           <p:nvPr/>
         </p:nvSpPr>
@@ -14027,7 +14062,7 @@
       </p:sp>
       <p:sp>
         <p:nvSpPr>
-          <p:cNvPr id="18" name="Rectangle 17"/>
+          <p:cNvPr id="19" name="Rectangle 18"/>
           <p:cNvSpPr/>
           <p:nvPr/>
         </p:nvSpPr>
@@ -14072,7 +14107,7 @@
       </p:sp>
       <p:sp>
         <p:nvSpPr>
-          <p:cNvPr id="19" name="Rectangle 18"/>
+          <p:cNvPr id="20" name="Rectangle 19"/>
           <p:cNvSpPr/>
           <p:nvPr/>
         </p:nvSpPr>
@@ -14115,7 +14150,7 @@
       </p:sp>
       <p:sp>
         <p:nvSpPr>
-          <p:cNvPr id="20" name="TextBox 19"/>
+          <p:cNvPr id="21" name="TextBox 20"/>
           <p:cNvSpPr txBox="1"/>
           <p:nvPr/>
         </p:nvSpPr>

</xml_diff>

<commit_message>
Center text in accent cards and define ISTA/FISTA acronyms on slide 4
Co-Authored-By: Claude Fable 5 <noreply@anthropic.com>
</commit_message>
<xml_diff>
--- a/submission/MBDL_Seminar_Presentation.pptx
+++ b/submission/MBDL_Seminar_Presentation.pptx
@@ -1217,7 +1217,7 @@
           <a:lstStyle/>
           <a:p>
             <a:r>
-              <a:t>ISTA is proximal gradient descent on the LASSO objective. Each iteration takes a gradient step on the data-fidelity term, and then applies soft-thresholding, which shrinks small entries to zero. FISTA adds Nesterov momentum and improves the convergence rate from order one-over-k to one-over-k-squared. But here is the key point: after only sixteen iterations, ISTA reaches just minus 5.3 dB, and FISTA minus 11. Reaching minus 20 dB takes hundreds of iterations. So the question is: how do we make sixteen steps really count?</a:t>
+              <a:t>ISTA — the Iterative Shrinkage-Thresholding Algorithm — is proximal gradient descent on the LASSO objective. Each iteration takes a gradient step on the data-fidelity term, and then applies soft-thresholding, which shrinks small entries to zero. FISTA — the fast variant of ISTA — adds Nesterov momentum and improves the convergence rate from order one-over-k to one-over-k-squared. But here is the key point: after only sixteen iterations, ISTA reaches just minus 5.3 dB, and FISTA minus 11. Reaching minus 20 dB takes hundreds of iterations. So the question is: how do we make sixteen steps really count?</a:t>
             </a:r>
           </a:p>
         </p:txBody>
@@ -5892,7 +5892,7 @@
         <p:spPr>
           <a:xfrm>
             <a:off x="7461504" y="4361688"/>
-            <a:ext cx="4242816" cy="1536192"/>
+            <a:ext cx="4242816" cy="1426464"/>
           </a:xfrm>
           <a:prstGeom prst="rect">
             <a:avLst/>
@@ -5900,16 +5900,12 @@
           <a:noFill/>
         </p:spPr>
         <p:txBody>
-          <a:bodyPr wrap="square">
+          <a:bodyPr wrap="square" anchor="ctr">
             <a:spAutoFit/>
           </a:bodyPr>
           <a:lstStyle/>
-          <a:p/>
           <a:p>
             <a:pPr>
-              <a:spcBef>
-                <a:spcPts val="200"/>
-              </a:spcBef>
               <a:defRPr sz="1300">
                 <a:solidFill>
                   <a:srgbClr val="1A1A2E"/>
@@ -8196,7 +8192,7 @@
         <p:spPr>
           <a:xfrm>
             <a:off x="7278624" y="1801368"/>
-            <a:ext cx="4425696" cy="1490472"/>
+            <a:ext cx="4425696" cy="1380744"/>
           </a:xfrm>
           <a:prstGeom prst="rect">
             <a:avLst/>
@@ -8384,7 +8380,7 @@
         <p:spPr>
           <a:xfrm>
             <a:off x="7278624" y="3538728"/>
-            <a:ext cx="4425696" cy="1490472"/>
+            <a:ext cx="4425696" cy="1380744"/>
           </a:xfrm>
           <a:prstGeom prst="rect">
             <a:avLst/>
@@ -8892,7 +8888,7 @@
         <p:spPr>
           <a:xfrm>
             <a:off x="694944" y="5184648"/>
-            <a:ext cx="5195163" cy="1261872"/>
+            <a:ext cx="5195163" cy="1152144"/>
           </a:xfrm>
           <a:prstGeom prst="rect">
             <a:avLst/>
@@ -9032,7 +9028,7 @@
         <p:spPr>
           <a:xfrm>
             <a:off x="6356451" y="5184648"/>
-            <a:ext cx="5195163" cy="1261872"/>
+            <a:ext cx="5195163" cy="1152144"/>
           </a:xfrm>
           <a:prstGeom prst="rect">
             <a:avLst/>
@@ -9444,7 +9440,7 @@
         <p:spPr>
           <a:xfrm>
             <a:off x="694944" y="5687568"/>
-            <a:ext cx="10856671" cy="850392"/>
+            <a:ext cx="10856671" cy="740664"/>
           </a:xfrm>
           <a:prstGeom prst="rect">
             <a:avLst/>
@@ -9452,16 +9448,12 @@
           <a:noFill/>
         </p:spPr>
         <p:txBody>
-          <a:bodyPr wrap="square">
+          <a:bodyPr wrap="square" anchor="ctr">
             <a:spAutoFit/>
           </a:bodyPr>
           <a:lstStyle/>
-          <a:p/>
           <a:p>
             <a:pPr>
-              <a:spcBef>
-                <a:spcPts val="200"/>
-              </a:spcBef>
               <a:defRPr sz="1400">
                 <a:solidFill>
                   <a:srgbClr val="1A1A2E"/>
@@ -10694,7 +10686,7 @@
         <p:spPr>
           <a:xfrm>
             <a:off x="6364224" y="4270248"/>
-            <a:ext cx="5385816" cy="1627632"/>
+            <a:ext cx="5385816" cy="1517904"/>
           </a:xfrm>
           <a:prstGeom prst="rect">
             <a:avLst/>
@@ -12733,7 +12725,7 @@
         <p:spPr>
           <a:xfrm>
             <a:off x="694944" y="3904488"/>
-            <a:ext cx="3289706" cy="896112"/>
+            <a:ext cx="3289706" cy="786384"/>
           </a:xfrm>
           <a:prstGeom prst="rect">
             <a:avLst/>
@@ -12889,7 +12881,7 @@
         <p:spPr>
           <a:xfrm>
             <a:off x="4423562" y="3904488"/>
-            <a:ext cx="3289706" cy="896112"/>
+            <a:ext cx="3289706" cy="786384"/>
           </a:xfrm>
           <a:prstGeom prst="rect">
             <a:avLst/>
@@ -13045,7 +13037,7 @@
         <p:spPr>
           <a:xfrm>
             <a:off x="8152180" y="3904488"/>
-            <a:ext cx="3289706" cy="896112"/>
+            <a:ext cx="3289706" cy="786384"/>
           </a:xfrm>
           <a:prstGeom prst="rect">
             <a:avLst/>
@@ -14157,7 +14149,7 @@
         <p:spPr>
           <a:xfrm>
             <a:off x="6867144" y="4361688"/>
-            <a:ext cx="4700016" cy="804672"/>
+            <a:ext cx="4700016" cy="694944"/>
           </a:xfrm>
           <a:prstGeom prst="rect">
             <a:avLst/>
@@ -14165,16 +14157,12 @@
           <a:noFill/>
         </p:spPr>
         <p:txBody>
-          <a:bodyPr wrap="square">
+          <a:bodyPr wrap="square" anchor="ctr">
             <a:spAutoFit/>
           </a:bodyPr>
           <a:lstStyle/>
-          <a:p/>
           <a:p>
             <a:pPr>
-              <a:spcBef>
-                <a:spcPts val="200"/>
-              </a:spcBef>
               <a:defRPr sz="1500">
                 <a:solidFill>
                   <a:srgbClr val="1A1A2E"/>
@@ -14874,7 +14862,7 @@
         <p:spPr>
           <a:xfrm>
             <a:off x="7781544" y="3904488"/>
-            <a:ext cx="3968496" cy="1078992"/>
+            <a:ext cx="3968496" cy="969264"/>
           </a:xfrm>
           <a:prstGeom prst="rect">
             <a:avLst/>
@@ -14882,11 +14870,23 @@
           <a:noFill/>
         </p:spPr>
         <p:txBody>
-          <a:bodyPr wrap="square">
+          <a:bodyPr wrap="square" anchor="ctr">
             <a:spAutoFit/>
           </a:bodyPr>
           <a:lstStyle/>
-          <a:p/>
+          <a:p>
+            <a:pPr>
+              <a:defRPr sz="1500">
+                <a:solidFill>
+                  <a:srgbClr val="1A1A2E"/>
+                </a:solidFill>
+                <a:latin typeface="Calibri"/>
+              </a:defRPr>
+            </a:pPr>
+            <a:r>
+              <a:t>At K=16 iterations both methods are far from converged.</a:t>
+            </a:r>
+          </a:p>
           <a:p>
             <a:pPr>
               <a:spcBef>
@@ -14900,7 +14900,7 @@
               </a:defRPr>
             </a:pPr>
             <a:r>
-              <a:t>At K=16 iterations both methods are far from converged.</a:t>
+              <a:t>ISTA needs 200+ iterations for −20 dB.</a:t>
             </a:r>
           </a:p>
           <a:p>
@@ -14915,9 +14915,6 @@
                 <a:latin typeface="Calibri"/>
               </a:defRPr>
             </a:pPr>
-            <a:r>
-              <a:t>ISTA needs 200+ iterations for −20 dB.</a:t>
-            </a:r>
           </a:p>
           <a:p>
             <a:pPr>
@@ -14931,21 +14928,43 @@
                 <a:latin typeface="Calibri"/>
               </a:defRPr>
             </a:pPr>
-          </a:p>
-          <a:p>
-            <a:pPr>
-              <a:spcBef>
-                <a:spcPts val="200"/>
-              </a:spcBef>
-              <a:defRPr sz="1500">
-                <a:solidFill>
-                  <a:srgbClr val="1A1A2E"/>
+            <a:r>
+              <a:t>Can we make 16 steps count?</a:t>
+            </a:r>
+          </a:p>
+        </p:txBody>
+      </p:sp>
+      <p:sp>
+        <p:nvSpPr>
+          <p:cNvPr id="15" name="TextBox 14"/>
+          <p:cNvSpPr txBox="1"/>
+          <p:nvPr/>
+        </p:nvSpPr>
+        <p:spPr>
+          <a:xfrm>
+            <a:off x="502920" y="5257800"/>
+            <a:ext cx="11185855" cy="274320"/>
+          </a:xfrm>
+          <a:prstGeom prst="rect">
+            <a:avLst/>
+          </a:prstGeom>
+          <a:noFill/>
+        </p:spPr>
+        <p:txBody>
+          <a:bodyPr wrap="square">
+            <a:spAutoFit/>
+          </a:bodyPr>
+          <a:lstStyle/>
+          <a:p>
+            <a:pPr algn="l"/>
+            <a:r>
+              <a:rPr sz="1200" b="0" i="1">
+                <a:solidFill>
+                  <a:srgbClr val="4A5568"/>
                 </a:solidFill>
                 <a:latin typeface="Calibri"/>
-              </a:defRPr>
-            </a:pPr>
-            <a:r>
-              <a:t>Can we make 16 steps count?</a:t>
+              </a:rPr>
+              <a:t>ISTA = Iterative Shrinkage-Thresholding Algorithm;   FISTA = Fast ISTA (Beck &amp; Teboulle, 2009)</a:t>
             </a:r>
           </a:p>
         </p:txBody>
@@ -15788,7 +15807,7 @@
         <p:spPr>
           <a:xfrm>
             <a:off x="694944" y="4910328"/>
-            <a:ext cx="10856671" cy="896112"/>
+            <a:ext cx="10856671" cy="786384"/>
           </a:xfrm>
           <a:prstGeom prst="rect">
             <a:avLst/>
@@ -15796,16 +15815,12 @@
           <a:noFill/>
         </p:spPr>
         <p:txBody>
-          <a:bodyPr wrap="square">
+          <a:bodyPr wrap="square" anchor="ctr">
             <a:spAutoFit/>
           </a:bodyPr>
           <a:lstStyle/>
-          <a:p/>
           <a:p>
             <a:pPr>
-              <a:spcBef>
-                <a:spcPts val="200"/>
-              </a:spcBef>
               <a:defRPr sz="1500">
                 <a:solidFill>
                   <a:srgbClr val="1A1A2E"/>
@@ -18829,7 +18844,7 @@
         <p:spPr>
           <a:xfrm>
             <a:off x="7461504" y="3995928"/>
-            <a:ext cx="4242816" cy="1856232"/>
+            <a:ext cx="4242816" cy="1746504"/>
           </a:xfrm>
           <a:prstGeom prst="rect">
             <a:avLst/>
@@ -20131,7 +20146,7 @@
         <p:spPr>
           <a:xfrm>
             <a:off x="8787384" y="4361688"/>
-            <a:ext cx="2962656" cy="1490472"/>
+            <a:ext cx="2962656" cy="1380744"/>
           </a:xfrm>
           <a:prstGeom prst="rect">
             <a:avLst/>
@@ -20139,16 +20154,12 @@
           <a:noFill/>
         </p:spPr>
         <p:txBody>
-          <a:bodyPr wrap="square">
+          <a:bodyPr wrap="square" anchor="ctr">
             <a:spAutoFit/>
           </a:bodyPr>
           <a:lstStyle/>
-          <a:p/>
           <a:p>
             <a:pPr>
-              <a:spcBef>
-                <a:spcPts val="200"/>
-              </a:spcBef>
               <a:defRPr sz="1200">
                 <a:solidFill>
                   <a:srgbClr val="1A1A2E"/>

</xml_diff>

<commit_message>
Add error-percentage columns to slides 4/6, clarify FISTA t_k
- new Error [%] column (10^(dB/10)*100) on the baselines and MBDL-ladder
  tables; narration explains -5.3 dB = ~30% residual energy and
  HyperLISTA -61.4 dB = 0.00007%
- fista.py docstring rewritten to match Beck & Teboulle exactly:
  momentum coefficient is (t_k - 1)/t_{k+1}, with an explanation of the
  auxiliary t_k sequence

Co-Authored-By: Claude Fable 5 <noreply@anthropic.com>
</commit_message>
<xml_diff>
--- a/submission/MBDL_Seminar_Presentation.pptx
+++ b/submission/MBDL_Seminar_Presentation.pptx
@@ -1217,7 +1217,7 @@
           <a:lstStyle/>
           <a:p>
             <a:r>
-              <a:t>ISTA — the Iterative Shrinkage-Thresholding Algorithm — is proximal gradient descent on the LASSO objective. Each iteration takes a gradient step on the data-fidelity term, and then applies soft-thresholding, which shrinks small entries to zero. FISTA — the fast variant of ISTA — adds Nesterov momentum and improves the convergence rate from order one-over-k to one-over-k-squared. But here is the key point: after only sixteen iterations, ISTA reaches just minus 5.3 dB, and FISTA minus 11. Reaching minus 20 dB takes hundreds of iterations. So the question is: how do we make sixteen steps really count?</a:t>
+              <a:t>ISTA — the Iterative Shrinkage-Thresholding Algorithm — is proximal gradient descent on the LASSO objective. Each iteration takes a gradient step on the data-fidelity term, and then applies soft-thresholding, which shrinks small entries to zero. FISTA — the fast variant of ISTA — adds Nesterov momentum and improves the convergence rate from order one-over-k to one-over-k-squared. The t-k in the formula is just an auxiliary scalar sequence: it starts at one and grows with k, so the momentum coefficient starts at zero and approaches one — this specific schedule is exactly what gives the faster rate. But here is the key point: after only sixteen iterations, ISTA reaches just minus 5.3 dB — meaning about 30 percent of the signal energy is still error — and FISTA minus 11, about 8 percent. Reaching minus 20 dB takes hundreds of iterations. So the question is: how do we make sixteen steps really count?</a:t>
             </a:r>
           </a:p>
         </p:txBody>
@@ -1357,7 +1357,7 @@
           <a:lstStyle/>
           <a:p>
             <a:r>
-              <a:t>Now the MBDL ladder — more structure, fewer parameters. LISTA learns everything: six million parameters, minus 20 dB. ALISTA shows that the weight matrix does not need to be learned at all: it can be computed analytically from A, leaving only per-layer step sizes and thresholds — 32 parameters, and minus 30 dB. HyperLISTA takes this to the extreme: only three scalars. The threshold, the momentum, and the support selection are computed adaptively from the residual at every layer, using the formulas on the slide. And notice — there is no backpropagation at all: the three scalars are found by a simple grid search. The result: minus 61 dB, the best of all. More structure, fewer parameters, better performance — this is the MBDL principle in action.</a:t>
+              <a:t>Now the MBDL ladder — more structure, fewer parameters. LISTA learns everything: six million parameters, minus 20 dB. ALISTA shows that the weight matrix does not need to be learned at all: it can be computed analytically from A, leaving only per-layer step sizes and thresholds — 32 parameters, and minus 30 dB. HyperLISTA takes this to the extreme: only three scalars. The threshold, the momentum, and the support selection are computed adaptively from the residual at every layer, using the formulas on the slide. And notice — there is no backpropagation at all: the three scalars are found by a simple grid search. The result: minus 61 dB — less than one ten-thousandth of a percent of residual error — the best of all. More structure, fewer parameters, better performance — this is the MBDL principle in action.</a:t>
             </a:r>
           </a:p>
         </p:txBody>
@@ -14544,7 +14544,7 @@
         </p:nvGraphicFramePr>
         <p:xfrm>
           <a:off x="502920" y="3794760"/>
-          <a:ext cx="6675120" cy="905256"/>
+          <a:ext cx="6858000" cy="905256"/>
         </p:xfrm>
         <a:graphic>
           <a:graphicData uri="http://schemas.openxmlformats.org/drawingml/2006/table">
@@ -14553,9 +14553,10 @@
                 <a:tableStyleId>{5C22544A-7EE6-4342-B048-85BDC9FD1C3A}</a:tableStyleId>
               </a:tblPr>
               <a:tblGrid>
-                <a:gridCol w="2743200"/>
-                <a:gridCol w="2286000"/>
-                <a:gridCol w="1645920"/>
+                <a:gridCol w="2011680"/>
+                <a:gridCol w="1828800"/>
+                <a:gridCol w="1920240"/>
+                <a:gridCol w="1097280"/>
               </a:tblGrid>
               <a:tr h="301752">
                 <a:tc>
@@ -14597,6 +14598,30 @@
                       </a:pPr>
                       <a:r>
                         <a:t>NMSE @ K=16</a:t>
+                      </a:r>
+                    </a:p>
+                  </a:txBody>
+                  <a:tcPr>
+                    <a:solidFill>
+                      <a:srgbClr val="003F87"/>
+                    </a:solidFill>
+                  </a:tcPr>
+                </a:tc>
+                <a:tc>
+                  <a:txBody>
+                    <a:bodyPr/>
+                    <a:lstStyle/>
+                    <a:p>
+                      <a:pPr>
+                        <a:defRPr sz="1500" b="1">
+                          <a:solidFill>
+                            <a:srgbClr val="FFFFFF"/>
+                          </a:solidFill>
+                          <a:latin typeface="Calibri"/>
+                        </a:defRPr>
+                      </a:pPr>
+                      <a:r>
+                        <a:t>Error energy [%]</a:t>
                       </a:r>
                     </a:p>
                   </a:txBody>
@@ -14685,6 +14710,27 @@
                         </a:defRPr>
                       </a:pPr>
                       <a:r>
+                        <a:t>29.5%</a:t>
+                      </a:r>
+                    </a:p>
+                  </a:txBody>
+                  <a:tcPr>
+                    <a:solidFill>
+                      <a:srgbClr val="FFFFFF"/>
+                    </a:solidFill>
+                  </a:tcPr>
+                </a:tc>
+                <a:tc>
+                  <a:txBody>
+                    <a:bodyPr/>
+                    <a:lstStyle/>
+                    <a:p>
+                      <a:pPr>
+                        <a:defRPr sz="1500">
+                          <a:latin typeface="Calibri"/>
+                        </a:defRPr>
+                      </a:pPr>
+                      <a:r>
                         <a:t>0</a:t>
                       </a:r>
                     </a:p>
@@ -14750,6 +14796,27 @@
                         </a:defRPr>
                       </a:pPr>
                       <a:r>
+                        <a:t>7.9%</a:t>
+                      </a:r>
+                    </a:p>
+                  </a:txBody>
+                  <a:tcPr>
+                    <a:solidFill>
+                      <a:srgbClr val="EEF4FB"/>
+                    </a:solidFill>
+                  </a:tcPr>
+                </a:tc>
+                <a:tc>
+                  <a:txBody>
+                    <a:bodyPr/>
+                    <a:lstStyle/>
+                    <a:p>
+                      <a:pPr>
+                        <a:defRPr sz="1500">
+                          <a:latin typeface="Calibri"/>
+                        </a:defRPr>
+                      </a:pPr>
+                      <a:r>
                         <a:t>0</a:t>
                       </a:r>
                     </a:p>
@@ -16309,7 +16376,7 @@
         </p:nvGraphicFramePr>
         <p:xfrm>
           <a:off x="7573975" y="1188720"/>
-          <a:ext cx="3931920" cy="1810512"/>
+          <a:ext cx="4114800" cy="1810512"/>
         </p:xfrm>
         <a:graphic>
           <a:graphicData uri="http://schemas.openxmlformats.org/drawingml/2006/table">
@@ -16318,9 +16385,10 @@
                 <a:tableStyleId>{5C22544A-7EE6-4342-B048-85BDC9FD1C3A}</a:tableStyleId>
               </a:tblPr>
               <a:tblGrid>
-                <a:gridCol w="1828800"/>
-                <a:gridCol w="1005840"/>
-                <a:gridCol w="1097280"/>
+                <a:gridCol w="1417320"/>
+                <a:gridCol w="777240"/>
+                <a:gridCol w="960120"/>
+                <a:gridCol w="960120"/>
               </a:tblGrid>
               <a:tr h="301752">
                 <a:tc>
@@ -16395,6 +16463,30 @@
                     </a:solidFill>
                   </a:tcPr>
                 </a:tc>
+                <a:tc>
+                  <a:txBody>
+                    <a:bodyPr/>
+                    <a:lstStyle/>
+                    <a:p>
+                      <a:pPr>
+                        <a:defRPr sz="1500" b="1">
+                          <a:solidFill>
+                            <a:srgbClr val="FFFFFF"/>
+                          </a:solidFill>
+                          <a:latin typeface="Calibri"/>
+                        </a:defRPr>
+                      </a:pPr>
+                      <a:r>
+                        <a:t>Error [%]</a:t>
+                      </a:r>
+                    </a:p>
+                  </a:txBody>
+                  <a:tcPr>
+                    <a:solidFill>
+                      <a:srgbClr val="003F87"/>
+                    </a:solidFill>
+                  </a:tcPr>
+                </a:tc>
               </a:tr>
               <a:tr h="301752">
                 <a:tc>
@@ -16451,6 +16543,27 @@
                       </a:pPr>
                       <a:r>
                         <a:t>−5.3 dB</a:t>
+                      </a:r>
+                    </a:p>
+                  </a:txBody>
+                  <a:tcPr>
+                    <a:solidFill>
+                      <a:srgbClr val="FFFFFF"/>
+                    </a:solidFill>
+                  </a:tcPr>
+                </a:tc>
+                <a:tc>
+                  <a:txBody>
+                    <a:bodyPr/>
+                    <a:lstStyle/>
+                    <a:p>
+                      <a:pPr>
+                        <a:defRPr sz="1500">
+                          <a:latin typeface="Calibri"/>
+                        </a:defRPr>
+                      </a:pPr>
+                      <a:r>
+                        <a:t>29.5%</a:t>
                       </a:r>
                     </a:p>
                   </a:txBody>
@@ -16525,6 +16638,27 @@
                     </a:solidFill>
                   </a:tcPr>
                 </a:tc>
+                <a:tc>
+                  <a:txBody>
+                    <a:bodyPr/>
+                    <a:lstStyle/>
+                    <a:p>
+                      <a:pPr>
+                        <a:defRPr sz="1500">
+                          <a:latin typeface="Calibri"/>
+                        </a:defRPr>
+                      </a:pPr>
+                      <a:r>
+                        <a:t>7.9%</a:t>
+                      </a:r>
+                    </a:p>
+                  </a:txBody>
+                  <a:tcPr>
+                    <a:solidFill>
+                      <a:srgbClr val="EEF4FB"/>
+                    </a:solidFill>
+                  </a:tcPr>
+                </a:tc>
               </a:tr>
               <a:tr h="301752">
                 <a:tc>
@@ -16581,6 +16715,27 @@
                       </a:pPr>
                       <a:r>
                         <a:t>−20.3 dB</a:t>
+                      </a:r>
+                    </a:p>
+                  </a:txBody>
+                  <a:tcPr>
+                    <a:solidFill>
+                      <a:srgbClr val="FFFFFF"/>
+                    </a:solidFill>
+                  </a:tcPr>
+                </a:tc>
+                <a:tc>
+                  <a:txBody>
+                    <a:bodyPr/>
+                    <a:lstStyle/>
+                    <a:p>
+                      <a:pPr>
+                        <a:defRPr sz="1500">
+                          <a:latin typeface="Calibri"/>
+                        </a:defRPr>
+                      </a:pPr>
+                      <a:r>
+                        <a:t>0.93%</a:t>
                       </a:r>
                     </a:p>
                   </a:txBody>
@@ -16655,6 +16810,27 @@
                     </a:solidFill>
                   </a:tcPr>
                 </a:tc>
+                <a:tc>
+                  <a:txBody>
+                    <a:bodyPr/>
+                    <a:lstStyle/>
+                    <a:p>
+                      <a:pPr>
+                        <a:defRPr sz="1500">
+                          <a:latin typeface="Calibri"/>
+                        </a:defRPr>
+                      </a:pPr>
+                      <a:r>
+                        <a:t>0.10%</a:t>
+                      </a:r>
+                    </a:p>
+                  </a:txBody>
+                  <a:tcPr>
+                    <a:solidFill>
+                      <a:srgbClr val="EEF4FB"/>
+                    </a:solidFill>
+                  </a:tcPr>
+                </a:tc>
               </a:tr>
               <a:tr h="301752">
                 <a:tc>
@@ -16720,6 +16896,30 @@
                       </a:pPr>
                       <a:r>
                         <a:t>−61.4 dB</a:t>
+                      </a:r>
+                    </a:p>
+                  </a:txBody>
+                  <a:tcPr>
+                    <a:solidFill>
+                      <a:srgbClr val="D4EDFF"/>
+                    </a:solidFill>
+                  </a:tcPr>
+                </a:tc>
+                <a:tc>
+                  <a:txBody>
+                    <a:bodyPr/>
+                    <a:lstStyle/>
+                    <a:p>
+                      <a:pPr>
+                        <a:defRPr sz="1500" b="1">
+                          <a:solidFill>
+                            <a:srgbClr val="003F87"/>
+                          </a:solidFill>
+                          <a:latin typeface="Calibri"/>
+                        </a:defRPr>
+                      </a:pPr>
+                      <a:r>
+                        <a:t>0.00007%</a:t>
                       </a:r>
                     </a:p>
                   </a:txBody>

</xml_diff>

<commit_message>
Define BPTT acronym at the bottom of slide 5
Co-Authored-By: Claude Fable 5 <noreply@anthropic.com>
</commit_message>
<xml_diff>
--- a/submission/MBDL_Seminar_Presentation.pptx
+++ b/submission/MBDL_Seminar_Presentation.pptx
@@ -15917,6 +15917,41 @@
           </a:p>
         </p:txBody>
       </p:sp>
+      <p:sp>
+        <p:nvSpPr>
+          <p:cNvPr id="25" name="TextBox 24"/>
+          <p:cNvSpPr txBox="1"/>
+          <p:nvPr/>
+        </p:nvSpPr>
+        <p:spPr>
+          <a:xfrm>
+            <a:off x="502920" y="5943600"/>
+            <a:ext cx="11185855" cy="274320"/>
+          </a:xfrm>
+          <a:prstGeom prst="rect">
+            <a:avLst/>
+          </a:prstGeom>
+          <a:noFill/>
+        </p:spPr>
+        <p:txBody>
+          <a:bodyPr wrap="square">
+            <a:spAutoFit/>
+          </a:bodyPr>
+          <a:lstStyle/>
+          <a:p>
+            <a:pPr algn="l"/>
+            <a:r>
+              <a:rPr sz="1200" b="0" i="1">
+                <a:solidFill>
+                  <a:srgbClr val="4A5568"/>
+                </a:solidFill>
+                <a:latin typeface="Calibri"/>
+              </a:rPr>
+              <a:t>BPTT = Backpropagation Through Time — end-to-end backpropagation through all K unrolled layers, as when training a recurrent network</a:t>
+            </a:r>
+          </a:p>
+        </p:txBody>
+      </p:sp>
     </p:spTree>
   </p:cSld>
   <p:clrMapOvr>

</xml_diff>

<commit_message>
Convert all equations to native PPTX text and note synthetic data on slide 6
- every formula (slides 3-7, 9) is now real editable text with true
  sub/superscript runs instead of rendered PNG images
- slide 6: sizes rebalanced, synthetic-data caption under the results
  table (m=250, n=500, s=50, noiseless, K=16)

Co-Authored-By: Claude Fable 5 <noreply@anthropic.com>
</commit_message>
<xml_diff>
--- a/submission/MBDL_Seminar_Presentation.pptx
+++ b/submission/MBDL_Seminar_Presentation.pptx
@@ -13786,30 +13786,94 @@
           </a:p>
         </p:txBody>
       </p:sp>
-      <p:pic>
-        <p:nvPicPr>
-          <p:cNvPr id="11" name="Picture 10" descr="image.png"/>
-          <p:cNvPicPr>
-            <a:picLocks noChangeAspect="1"/>
-          </p:cNvPicPr>
-          <p:nvPr/>
-        </p:nvPicPr>
-        <p:blipFill>
-          <a:blip r:embed="rId2"/>
-          <a:stretch>
-            <a:fillRect/>
-          </a:stretch>
-        </p:blipFill>
-        <p:spPr>
-          <a:xfrm>
-            <a:off x="685800" y="4389120"/>
-            <a:ext cx="4389120" cy="574054"/>
-          </a:xfrm>
-          <a:prstGeom prst="rect">
-            <a:avLst/>
-          </a:prstGeom>
-        </p:spPr>
-      </p:pic>
+      <p:sp>
+        <p:nvSpPr>
+          <p:cNvPr id="11" name="TextBox 10"/>
+          <p:cNvSpPr txBox="1"/>
+          <p:nvPr/>
+        </p:nvSpPr>
+        <p:spPr>
+          <a:xfrm>
+            <a:off x="685800" y="4434840"/>
+            <a:ext cx="5486400" cy="411480"/>
+          </a:xfrm>
+          <a:prstGeom prst="rect">
+            <a:avLst/>
+          </a:prstGeom>
+          <a:noFill/>
+        </p:spPr>
+        <p:txBody>
+          <a:bodyPr wrap="none">
+            <a:spAutoFit/>
+          </a:bodyPr>
+          <a:lstStyle/>
+          <a:p>
+            <a:r>
+              <a:rPr sz="2000" i="1">
+                <a:solidFill>
+                  <a:srgbClr val="1A1A2E"/>
+                </a:solidFill>
+                <a:latin typeface="Cambria"/>
+              </a:rPr>
+              <a:t>x̂  =  arg min</a:t>
+            </a:r>
+            <a:r>
+              <a:rPr sz="1400" i="1" baseline="-25000">
+                <a:solidFill>
+                  <a:srgbClr val="1A1A2E"/>
+                </a:solidFill>
+                <a:latin typeface="Cambria"/>
+              </a:rPr>
+              <a:t>x</a:t>
+            </a:r>
+            <a:r>
+              <a:rPr sz="2000" i="1">
+                <a:solidFill>
+                  <a:srgbClr val="1A1A2E"/>
+                </a:solidFill>
+                <a:latin typeface="Cambria"/>
+              </a:rPr>
+              <a:t>  ½ ‖ b − A x ‖</a:t>
+            </a:r>
+            <a:r>
+              <a:rPr sz="1400" i="1" baseline="-25000">
+                <a:solidFill>
+                  <a:srgbClr val="1A1A2E"/>
+                </a:solidFill>
+                <a:latin typeface="Cambria"/>
+              </a:rPr>
+              <a:t>2</a:t>
+            </a:r>
+            <a:r>
+              <a:rPr sz="1400" i="1" baseline="30000">
+                <a:solidFill>
+                  <a:srgbClr val="1A1A2E"/>
+                </a:solidFill>
+                <a:latin typeface="Cambria"/>
+              </a:rPr>
+              <a:t>2</a:t>
+            </a:r>
+            <a:r>
+              <a:rPr sz="2000" i="1">
+                <a:solidFill>
+                  <a:srgbClr val="1A1A2E"/>
+                </a:solidFill>
+                <a:latin typeface="Cambria"/>
+              </a:rPr>
+              <a:t>  +  λ ‖ x ‖</a:t>
+            </a:r>
+            <a:r>
+              <a:rPr sz="1400" i="1" baseline="-25000">
+                <a:solidFill>
+                  <a:srgbClr val="1A1A2E"/>
+                </a:solidFill>
+                <a:latin typeface="Cambria"/>
+              </a:rPr>
+              <a:t>1</a:t>
+            </a:r>
+          </a:p>
+        </p:txBody>
+      </p:sp>
       <p:sp>
         <p:nvSpPr>
           <p:cNvPr id="12" name="TextBox 11"/>
@@ -13923,30 +13987,58 @@
           </a:p>
         </p:txBody>
       </p:sp>
-      <p:pic>
-        <p:nvPicPr>
-          <p:cNvPr id="15" name="Picture 14" descr="image.png"/>
-          <p:cNvPicPr>
-            <a:picLocks noChangeAspect="1"/>
-          </p:cNvPicPr>
-          <p:nvPr/>
-        </p:nvPicPr>
-        <p:blipFill>
-          <a:blip r:embed="rId3"/>
-          <a:stretch>
-            <a:fillRect/>
-          </a:stretch>
-        </p:blipFill>
-        <p:spPr>
-          <a:xfrm>
-            <a:off x="7132320" y="1783080"/>
-            <a:ext cx="2743200" cy="683741"/>
-          </a:xfrm>
-          <a:prstGeom prst="rect">
-            <a:avLst/>
-          </a:prstGeom>
-        </p:spPr>
-      </p:pic>
+      <p:sp>
+        <p:nvSpPr>
+          <p:cNvPr id="15" name="TextBox 14"/>
+          <p:cNvSpPr txBox="1"/>
+          <p:nvPr/>
+        </p:nvSpPr>
+        <p:spPr>
+          <a:xfrm>
+            <a:off x="7132320" y="1801368"/>
+            <a:ext cx="3657600" cy="411480"/>
+          </a:xfrm>
+          <a:prstGeom prst="rect">
+            <a:avLst/>
+          </a:prstGeom>
+          <a:noFill/>
+        </p:spPr>
+        <p:txBody>
+          <a:bodyPr wrap="none">
+            <a:spAutoFit/>
+          </a:bodyPr>
+          <a:lstStyle/>
+          <a:p>
+            <a:r>
+              <a:rPr sz="2400" i="1">
+                <a:solidFill>
+                  <a:srgbClr val="FFFFFF"/>
+                </a:solidFill>
+                <a:latin typeface="Cambria"/>
+              </a:rPr>
+              <a:t>b  =  A x</a:t>
+            </a:r>
+            <a:r>
+              <a:rPr sz="1700" i="1" baseline="30000">
+                <a:solidFill>
+                  <a:srgbClr val="FFFFFF"/>
+                </a:solidFill>
+                <a:latin typeface="Cambria"/>
+              </a:rPr>
+              <a:t>*</a:t>
+            </a:r>
+            <a:r>
+              <a:rPr sz="2400" i="1">
+                <a:solidFill>
+                  <a:srgbClr val="FFFFFF"/>
+                </a:solidFill>
+                <a:latin typeface="Cambria"/>
+              </a:rPr>
+              <a:t>  +  ε</a:t>
+            </a:r>
+          </a:p>
+        </p:txBody>
+      </p:sp>
       <p:sp>
         <p:nvSpPr>
           <p:cNvPr id="16" name="TextBox 15"/>
@@ -14451,30 +14543,157 @@
           </a:p>
         </p:txBody>
       </p:sp>
-      <p:pic>
-        <p:nvPicPr>
-          <p:cNvPr id="8" name="Picture 7" descr="image.png"/>
-          <p:cNvPicPr>
-            <a:picLocks noChangeAspect="1"/>
-          </p:cNvPicPr>
-          <p:nvPr/>
-        </p:nvPicPr>
-        <p:blipFill>
-          <a:blip r:embed="rId2"/>
-          <a:stretch>
-            <a:fillRect/>
-          </a:stretch>
-        </p:blipFill>
-        <p:spPr>
-          <a:xfrm>
-            <a:off x="822960" y="1554480"/>
-            <a:ext cx="9601200" cy="813509"/>
-          </a:xfrm>
-          <a:prstGeom prst="rect">
-            <a:avLst/>
-          </a:prstGeom>
-        </p:spPr>
-      </p:pic>
+      <p:sp>
+        <p:nvSpPr>
+          <p:cNvPr id="8" name="TextBox 7"/>
+          <p:cNvSpPr txBox="1"/>
+          <p:nvPr/>
+        </p:nvSpPr>
+        <p:spPr>
+          <a:xfrm>
+            <a:off x="822960" y="1572768"/>
+            <a:ext cx="10515600" cy="411480"/>
+          </a:xfrm>
+          <a:prstGeom prst="rect">
+            <a:avLst/>
+          </a:prstGeom>
+          <a:noFill/>
+        </p:spPr>
+        <p:txBody>
+          <a:bodyPr wrap="none">
+            <a:spAutoFit/>
+          </a:bodyPr>
+          <a:lstStyle/>
+          <a:p>
+            <a:r>
+              <a:rPr sz="2000" i="1">
+                <a:solidFill>
+                  <a:srgbClr val="1A1A2E"/>
+                </a:solidFill>
+                <a:latin typeface="Cambria"/>
+              </a:rPr>
+              <a:t>x</a:t>
+            </a:r>
+            <a:r>
+              <a:rPr sz="1400" i="1" baseline="30000">
+                <a:solidFill>
+                  <a:srgbClr val="1A1A2E"/>
+                </a:solidFill>
+                <a:latin typeface="Cambria"/>
+              </a:rPr>
+              <a:t>(k+1)</a:t>
+            </a:r>
+            <a:r>
+              <a:rPr sz="2000" i="1">
+                <a:solidFill>
+                  <a:srgbClr val="1A1A2E"/>
+                </a:solidFill>
+                <a:latin typeface="Cambria"/>
+              </a:rPr>
+              <a:t> = S</a:t>
+            </a:r>
+            <a:r>
+              <a:rPr sz="1400" i="1" baseline="-25000">
+                <a:solidFill>
+                  <a:srgbClr val="1A1A2E"/>
+                </a:solidFill>
+                <a:latin typeface="Cambria"/>
+              </a:rPr>
+              <a:t>θ</a:t>
+            </a:r>
+            <a:r>
+              <a:rPr sz="2000" i="1">
+                <a:solidFill>
+                  <a:srgbClr val="1A1A2E"/>
+                </a:solidFill>
+                <a:latin typeface="Cambria"/>
+              </a:rPr>
+              <a:t>( x</a:t>
+            </a:r>
+            <a:r>
+              <a:rPr sz="1400" i="1" baseline="30000">
+                <a:solidFill>
+                  <a:srgbClr val="1A1A2E"/>
+                </a:solidFill>
+                <a:latin typeface="Cambria"/>
+              </a:rPr>
+              <a:t>(k)</a:t>
+            </a:r>
+            <a:r>
+              <a:rPr sz="2000" i="1">
+                <a:solidFill>
+                  <a:srgbClr val="1A1A2E"/>
+                </a:solidFill>
+                <a:latin typeface="Cambria"/>
+              </a:rPr>
+              <a:t> + (1/L) A</a:t>
+            </a:r>
+            <a:r>
+              <a:rPr sz="1400" i="1" baseline="30000">
+                <a:solidFill>
+                  <a:srgbClr val="1A1A2E"/>
+                </a:solidFill>
+                <a:latin typeface="Cambria"/>
+              </a:rPr>
+              <a:t>T</a:t>
+            </a:r>
+            <a:r>
+              <a:rPr sz="2000" i="1">
+                <a:solidFill>
+                  <a:srgbClr val="1A1A2E"/>
+                </a:solidFill>
+                <a:latin typeface="Cambria"/>
+              </a:rPr>
+              <a:t>( b − A x</a:t>
+            </a:r>
+            <a:r>
+              <a:rPr sz="1400" i="1" baseline="30000">
+                <a:solidFill>
+                  <a:srgbClr val="1A1A2E"/>
+                </a:solidFill>
+                <a:latin typeface="Cambria"/>
+              </a:rPr>
+              <a:t>(k)</a:t>
+            </a:r>
+            <a:r>
+              <a:rPr sz="2000" i="1">
+                <a:solidFill>
+                  <a:srgbClr val="1A1A2E"/>
+                </a:solidFill>
+                <a:latin typeface="Cambria"/>
+              </a:rPr>
+              <a:t> ) ) ,      L = ‖A‖</a:t>
+            </a:r>
+            <a:r>
+              <a:rPr sz="1400" i="1" baseline="-25000">
+                <a:solidFill>
+                  <a:srgbClr val="1A1A2E"/>
+                </a:solidFill>
+                <a:latin typeface="Cambria"/>
+              </a:rPr>
+              <a:t>2</a:t>
+            </a:r>
+            <a:r>
+              <a:rPr sz="1400" i="1" baseline="30000">
+                <a:solidFill>
+                  <a:srgbClr val="1A1A2E"/>
+                </a:solidFill>
+                <a:latin typeface="Cambria"/>
+              </a:rPr>
+              <a:t>2</a:t>
+            </a:r>
+            <a:r>
+              <a:rPr sz="2000" i="1">
+                <a:solidFill>
+                  <a:srgbClr val="1A1A2E"/>
+                </a:solidFill>
+                <a:latin typeface="Cambria"/>
+              </a:rPr>
+              <a:t> ,      θ = λ / L</a:t>
+            </a:r>
+          </a:p>
+        </p:txBody>
+      </p:sp>
       <p:sp>
         <p:nvSpPr>
           <p:cNvPr id="9" name="TextBox 8"/>
@@ -14510,30 +14729,238 @@
           </a:p>
         </p:txBody>
       </p:sp>
-      <p:pic>
-        <p:nvPicPr>
-          <p:cNvPr id="10" name="Picture 9" descr="image.png"/>
-          <p:cNvPicPr>
-            <a:picLocks noChangeAspect="1"/>
-          </p:cNvPicPr>
-          <p:nvPr/>
-        </p:nvPicPr>
-        <p:blipFill>
-          <a:blip r:embed="rId3"/>
-          <a:stretch>
-            <a:fillRect/>
-          </a:stretch>
-        </p:blipFill>
-        <p:spPr>
-          <a:xfrm>
-            <a:off x="822960" y="2697480"/>
-            <a:ext cx="10058400" cy="743121"/>
-          </a:xfrm>
-          <a:prstGeom prst="rect">
-            <a:avLst/>
-          </a:prstGeom>
-        </p:spPr>
-      </p:pic>
+      <p:sp>
+        <p:nvSpPr>
+          <p:cNvPr id="10" name="TextBox 9"/>
+          <p:cNvSpPr txBox="1"/>
+          <p:nvPr/>
+        </p:nvSpPr>
+        <p:spPr>
+          <a:xfrm>
+            <a:off x="822960" y="2715768"/>
+            <a:ext cx="10972800" cy="411480"/>
+          </a:xfrm>
+          <a:prstGeom prst="rect">
+            <a:avLst/>
+          </a:prstGeom>
+          <a:noFill/>
+        </p:spPr>
+        <p:txBody>
+          <a:bodyPr wrap="none">
+            <a:spAutoFit/>
+          </a:bodyPr>
+          <a:lstStyle/>
+          <a:p>
+            <a:r>
+              <a:rPr sz="2000" i="1">
+                <a:solidFill>
+                  <a:srgbClr val="1A1A2E"/>
+                </a:solidFill>
+                <a:latin typeface="Cambria"/>
+              </a:rPr>
+              <a:t>y</a:t>
+            </a:r>
+            <a:r>
+              <a:rPr sz="1400" i="1" baseline="30000">
+                <a:solidFill>
+                  <a:srgbClr val="1A1A2E"/>
+                </a:solidFill>
+                <a:latin typeface="Cambria"/>
+              </a:rPr>
+              <a:t>(k)</a:t>
+            </a:r>
+            <a:r>
+              <a:rPr sz="2000" i="1">
+                <a:solidFill>
+                  <a:srgbClr val="1A1A2E"/>
+                </a:solidFill>
+                <a:latin typeface="Cambria"/>
+              </a:rPr>
+              <a:t> = x</a:t>
+            </a:r>
+            <a:r>
+              <a:rPr sz="1400" i="1" baseline="30000">
+                <a:solidFill>
+                  <a:srgbClr val="1A1A2E"/>
+                </a:solidFill>
+                <a:latin typeface="Cambria"/>
+              </a:rPr>
+              <a:t>(k)</a:t>
+            </a:r>
+            <a:r>
+              <a:rPr sz="2000" i="1">
+                <a:solidFill>
+                  <a:srgbClr val="1A1A2E"/>
+                </a:solidFill>
+                <a:latin typeface="Cambria"/>
+              </a:rPr>
+              <a:t> + (( t</a:t>
+            </a:r>
+            <a:r>
+              <a:rPr sz="1400" i="1" baseline="-25000">
+                <a:solidFill>
+                  <a:srgbClr val="1A1A2E"/>
+                </a:solidFill>
+                <a:latin typeface="Cambria"/>
+              </a:rPr>
+              <a:t>k</a:t>
+            </a:r>
+            <a:r>
+              <a:rPr sz="2000" i="1">
+                <a:solidFill>
+                  <a:srgbClr val="1A1A2E"/>
+                </a:solidFill>
+                <a:latin typeface="Cambria"/>
+              </a:rPr>
+              <a:t> − 1 ) / t</a:t>
+            </a:r>
+            <a:r>
+              <a:rPr sz="1400" i="1" baseline="-25000">
+                <a:solidFill>
+                  <a:srgbClr val="1A1A2E"/>
+                </a:solidFill>
+                <a:latin typeface="Cambria"/>
+              </a:rPr>
+              <a:t>k+1</a:t>
+            </a:r>
+            <a:r>
+              <a:rPr sz="2000" i="1">
+                <a:solidFill>
+                  <a:srgbClr val="1A1A2E"/>
+                </a:solidFill>
+                <a:latin typeface="Cambria"/>
+              </a:rPr>
+              <a:t> ) ( x</a:t>
+            </a:r>
+            <a:r>
+              <a:rPr sz="1400" i="1" baseline="30000">
+                <a:solidFill>
+                  <a:srgbClr val="1A1A2E"/>
+                </a:solidFill>
+                <a:latin typeface="Cambria"/>
+              </a:rPr>
+              <a:t>(k)</a:t>
+            </a:r>
+            <a:r>
+              <a:rPr sz="2000" i="1">
+                <a:solidFill>
+                  <a:srgbClr val="1A1A2E"/>
+                </a:solidFill>
+                <a:latin typeface="Cambria"/>
+              </a:rPr>
+              <a:t> − x</a:t>
+            </a:r>
+            <a:r>
+              <a:rPr sz="1400" i="1" baseline="30000">
+                <a:solidFill>
+                  <a:srgbClr val="1A1A2E"/>
+                </a:solidFill>
+                <a:latin typeface="Cambria"/>
+              </a:rPr>
+              <a:t>(k−1)</a:t>
+            </a:r>
+            <a:r>
+              <a:rPr sz="2000" i="1">
+                <a:solidFill>
+                  <a:srgbClr val="1A1A2E"/>
+                </a:solidFill>
+                <a:latin typeface="Cambria"/>
+              </a:rPr>
+              <a:t> ) ,      x</a:t>
+            </a:r>
+            <a:r>
+              <a:rPr sz="1400" i="1" baseline="30000">
+                <a:solidFill>
+                  <a:srgbClr val="1A1A2E"/>
+                </a:solidFill>
+                <a:latin typeface="Cambria"/>
+              </a:rPr>
+              <a:t>(k+1)</a:t>
+            </a:r>
+            <a:r>
+              <a:rPr sz="2000" i="1">
+                <a:solidFill>
+                  <a:srgbClr val="1A1A2E"/>
+                </a:solidFill>
+                <a:latin typeface="Cambria"/>
+              </a:rPr>
+              <a:t> = S</a:t>
+            </a:r>
+            <a:r>
+              <a:rPr sz="1400" i="1" baseline="-25000">
+                <a:solidFill>
+                  <a:srgbClr val="1A1A2E"/>
+                </a:solidFill>
+                <a:latin typeface="Cambria"/>
+              </a:rPr>
+              <a:t>θ</a:t>
+            </a:r>
+            <a:r>
+              <a:rPr sz="2000" i="1">
+                <a:solidFill>
+                  <a:srgbClr val="1A1A2E"/>
+                </a:solidFill>
+                <a:latin typeface="Cambria"/>
+              </a:rPr>
+              <a:t>( y</a:t>
+            </a:r>
+            <a:r>
+              <a:rPr sz="1400" i="1" baseline="30000">
+                <a:solidFill>
+                  <a:srgbClr val="1A1A2E"/>
+                </a:solidFill>
+                <a:latin typeface="Cambria"/>
+              </a:rPr>
+              <a:t>(k)</a:t>
+            </a:r>
+            <a:r>
+              <a:rPr sz="2000" i="1">
+                <a:solidFill>
+                  <a:srgbClr val="1A1A2E"/>
+                </a:solidFill>
+                <a:latin typeface="Cambria"/>
+              </a:rPr>
+              <a:t> + (1/L) A</a:t>
+            </a:r>
+            <a:r>
+              <a:rPr sz="1400" i="1" baseline="30000">
+                <a:solidFill>
+                  <a:srgbClr val="1A1A2E"/>
+                </a:solidFill>
+                <a:latin typeface="Cambria"/>
+              </a:rPr>
+              <a:t>T</a:t>
+            </a:r>
+            <a:r>
+              <a:rPr sz="2000" i="1">
+                <a:solidFill>
+                  <a:srgbClr val="1A1A2E"/>
+                </a:solidFill>
+                <a:latin typeface="Cambria"/>
+              </a:rPr>
+              <a:t>( b − A y</a:t>
+            </a:r>
+            <a:r>
+              <a:rPr sz="1400" i="1" baseline="30000">
+                <a:solidFill>
+                  <a:srgbClr val="1A1A2E"/>
+                </a:solidFill>
+                <a:latin typeface="Cambria"/>
+              </a:rPr>
+              <a:t>(k)</a:t>
+            </a:r>
+            <a:r>
+              <a:rPr sz="2000" i="1">
+                <a:solidFill>
+                  <a:srgbClr val="1A1A2E"/>
+                </a:solidFill>
+                <a:latin typeface="Cambria"/>
+              </a:rPr>
+              <a:t> ) )</a:t>
+            </a:r>
+          </a:p>
+        </p:txBody>
+      </p:sp>
       <p:graphicFrame>
         <p:nvGraphicFramePr>
           <p:cNvPr id="11" name="Table 10"/>
@@ -15375,54 +15802,200 @@
           </a:p>
         </p:txBody>
       </p:sp>
-      <p:pic>
-        <p:nvPicPr>
-          <p:cNvPr id="10" name="Picture 9" descr="image.png"/>
-          <p:cNvPicPr>
-            <a:picLocks noChangeAspect="1"/>
-          </p:cNvPicPr>
-          <p:nvPr/>
-        </p:nvPicPr>
-        <p:blipFill>
-          <a:blip r:embed="rId2"/>
-          <a:stretch>
-            <a:fillRect/>
-          </a:stretch>
-        </p:blipFill>
-        <p:spPr>
-          <a:xfrm>
-            <a:off x="640080" y="2286000"/>
-            <a:ext cx="5120640" cy="871598"/>
-          </a:xfrm>
-          <a:prstGeom prst="rect">
-            <a:avLst/>
-          </a:prstGeom>
-        </p:spPr>
-      </p:pic>
-      <p:pic>
-        <p:nvPicPr>
-          <p:cNvPr id="11" name="Picture 10" descr="image.png"/>
-          <p:cNvPicPr>
-            <a:picLocks noChangeAspect="1"/>
-          </p:cNvPicPr>
-          <p:nvPr/>
-        </p:nvPicPr>
-        <p:blipFill>
-          <a:blip r:embed="rId3"/>
-          <a:stretch>
-            <a:fillRect/>
-          </a:stretch>
-        </p:blipFill>
-        <p:spPr>
-          <a:xfrm>
-            <a:off x="640080" y="2926080"/>
-            <a:ext cx="3657600" cy="856034"/>
-          </a:xfrm>
-          <a:prstGeom prst="rect">
-            <a:avLst/>
-          </a:prstGeom>
-        </p:spPr>
-      </p:pic>
+      <p:sp>
+        <p:nvSpPr>
+          <p:cNvPr id="10" name="TextBox 9"/>
+          <p:cNvSpPr txBox="1"/>
+          <p:nvPr/>
+        </p:nvSpPr>
+        <p:spPr>
+          <a:xfrm>
+            <a:off x="731520" y="2331720"/>
+            <a:ext cx="5120640" cy="411480"/>
+          </a:xfrm>
+          <a:prstGeom prst="rect">
+            <a:avLst/>
+          </a:prstGeom>
+          <a:noFill/>
+        </p:spPr>
+        <p:txBody>
+          <a:bodyPr wrap="none">
+            <a:spAutoFit/>
+          </a:bodyPr>
+          <a:lstStyle/>
+          <a:p>
+            <a:r>
+              <a:rPr sz="1900" i="1">
+                <a:solidFill>
+                  <a:srgbClr val="1A1A2E"/>
+                </a:solidFill>
+                <a:latin typeface="Cambria"/>
+              </a:rPr>
+              <a:t>z</a:t>
+            </a:r>
+            <a:r>
+              <a:rPr sz="1300" i="1" baseline="30000">
+                <a:solidFill>
+                  <a:srgbClr val="1A1A2E"/>
+                </a:solidFill>
+                <a:latin typeface="Cambria"/>
+              </a:rPr>
+              <a:t>(k)</a:t>
+            </a:r>
+            <a:r>
+              <a:rPr sz="1900" i="1">
+                <a:solidFill>
+                  <a:srgbClr val="1A1A2E"/>
+                </a:solidFill>
+                <a:latin typeface="Cambria"/>
+              </a:rPr>
+              <a:t> = x</a:t>
+            </a:r>
+            <a:r>
+              <a:rPr sz="1300" i="1" baseline="30000">
+                <a:solidFill>
+                  <a:srgbClr val="1A1A2E"/>
+                </a:solidFill>
+                <a:latin typeface="Cambria"/>
+              </a:rPr>
+              <a:t>(k)</a:t>
+            </a:r>
+            <a:r>
+              <a:rPr sz="1900" i="1">
+                <a:solidFill>
+                  <a:srgbClr val="1A1A2E"/>
+                </a:solidFill>
+                <a:latin typeface="Cambria"/>
+              </a:rPr>
+              <a:t> + (1/L) A</a:t>
+            </a:r>
+            <a:r>
+              <a:rPr sz="1300" i="1" baseline="30000">
+                <a:solidFill>
+                  <a:srgbClr val="1A1A2E"/>
+                </a:solidFill>
+                <a:latin typeface="Cambria"/>
+              </a:rPr>
+              <a:t>T</a:t>
+            </a:r>
+            <a:r>
+              <a:rPr sz="1900" i="1">
+                <a:solidFill>
+                  <a:srgbClr val="1A1A2E"/>
+                </a:solidFill>
+                <a:latin typeface="Cambria"/>
+              </a:rPr>
+              <a:t>( b − A x</a:t>
+            </a:r>
+            <a:r>
+              <a:rPr sz="1300" i="1" baseline="30000">
+                <a:solidFill>
+                  <a:srgbClr val="1A1A2E"/>
+                </a:solidFill>
+                <a:latin typeface="Cambria"/>
+              </a:rPr>
+              <a:t>(k)</a:t>
+            </a:r>
+            <a:r>
+              <a:rPr sz="1900" i="1">
+                <a:solidFill>
+                  <a:srgbClr val="1A1A2E"/>
+                </a:solidFill>
+                <a:latin typeface="Cambria"/>
+              </a:rPr>
+              <a:t> )</a:t>
+            </a:r>
+          </a:p>
+        </p:txBody>
+      </p:sp>
+      <p:sp>
+        <p:nvSpPr>
+          <p:cNvPr id="11" name="TextBox 10"/>
+          <p:cNvSpPr txBox="1"/>
+          <p:nvPr/>
+        </p:nvSpPr>
+        <p:spPr>
+          <a:xfrm>
+            <a:off x="731520" y="2971800"/>
+            <a:ext cx="3657600" cy="411480"/>
+          </a:xfrm>
+          <a:prstGeom prst="rect">
+            <a:avLst/>
+          </a:prstGeom>
+          <a:noFill/>
+        </p:spPr>
+        <p:txBody>
+          <a:bodyPr wrap="none">
+            <a:spAutoFit/>
+          </a:bodyPr>
+          <a:lstStyle/>
+          <a:p>
+            <a:r>
+              <a:rPr sz="1900" i="1">
+                <a:solidFill>
+                  <a:srgbClr val="1A1A2E"/>
+                </a:solidFill>
+                <a:latin typeface="Cambria"/>
+              </a:rPr>
+              <a:t>x</a:t>
+            </a:r>
+            <a:r>
+              <a:rPr sz="1300" i="1" baseline="30000">
+                <a:solidFill>
+                  <a:srgbClr val="1A1A2E"/>
+                </a:solidFill>
+                <a:latin typeface="Cambria"/>
+              </a:rPr>
+              <a:t>(k+1)</a:t>
+            </a:r>
+            <a:r>
+              <a:rPr sz="1900" i="1">
+                <a:solidFill>
+                  <a:srgbClr val="1A1A2E"/>
+                </a:solidFill>
+                <a:latin typeface="Cambria"/>
+              </a:rPr>
+              <a:t> = S</a:t>
+            </a:r>
+            <a:r>
+              <a:rPr sz="1300" i="1" baseline="-25000">
+                <a:solidFill>
+                  <a:srgbClr val="1A1A2E"/>
+                </a:solidFill>
+                <a:latin typeface="Cambria"/>
+              </a:rPr>
+              <a:t>θ</a:t>
+            </a:r>
+            <a:r>
+              <a:rPr sz="1900" i="1">
+                <a:solidFill>
+                  <a:srgbClr val="1A1A2E"/>
+                </a:solidFill>
+                <a:latin typeface="Cambria"/>
+              </a:rPr>
+              <a:t>( z</a:t>
+            </a:r>
+            <a:r>
+              <a:rPr sz="1300" i="1" baseline="30000">
+                <a:solidFill>
+                  <a:srgbClr val="1A1A2E"/>
+                </a:solidFill>
+                <a:latin typeface="Cambria"/>
+              </a:rPr>
+              <a:t>(k)</a:t>
+            </a:r>
+            <a:r>
+              <a:rPr sz="1900" i="1">
+                <a:solidFill>
+                  <a:srgbClr val="1A1A2E"/>
+                </a:solidFill>
+                <a:latin typeface="Cambria"/>
+              </a:rPr>
+              <a:t> )</a:t>
+            </a:r>
+          </a:p>
+        </p:txBody>
+      </p:sp>
       <p:sp>
         <p:nvSpPr>
           <p:cNvPr id="12" name="TextBox 11"/>
@@ -15616,54 +16189,218 @@
           </a:p>
         </p:txBody>
       </p:sp>
-      <p:pic>
-        <p:nvPicPr>
-          <p:cNvPr id="17" name="Picture 16" descr="image.png"/>
-          <p:cNvPicPr>
-            <a:picLocks noChangeAspect="1"/>
-          </p:cNvPicPr>
-          <p:nvPr/>
-        </p:nvPicPr>
-        <p:blipFill>
-          <a:blip r:embed="rId4"/>
-          <a:stretch>
-            <a:fillRect/>
-          </a:stretch>
-        </p:blipFill>
-        <p:spPr>
-          <a:xfrm>
-            <a:off x="6347307" y="2286000"/>
-            <a:ext cx="4572000" cy="926897"/>
-          </a:xfrm>
-          <a:prstGeom prst="rect">
-            <a:avLst/>
-          </a:prstGeom>
-        </p:spPr>
-      </p:pic>
-      <p:pic>
-        <p:nvPicPr>
-          <p:cNvPr id="18" name="Picture 17" descr="image.png"/>
-          <p:cNvPicPr>
-            <a:picLocks noChangeAspect="1"/>
-          </p:cNvPicPr>
-          <p:nvPr/>
-        </p:nvPicPr>
-        <p:blipFill>
-          <a:blip r:embed="rId5"/>
-          <a:stretch>
-            <a:fillRect/>
-          </a:stretch>
-        </p:blipFill>
-        <p:spPr>
-          <a:xfrm>
-            <a:off x="6347307" y="2926080"/>
-            <a:ext cx="3657600" cy="879540"/>
-          </a:xfrm>
-          <a:prstGeom prst="rect">
-            <a:avLst/>
-          </a:prstGeom>
-        </p:spPr>
-      </p:pic>
+      <p:sp>
+        <p:nvSpPr>
+          <p:cNvPr id="17" name="TextBox 16"/>
+          <p:cNvSpPr txBox="1"/>
+          <p:nvPr/>
+        </p:nvSpPr>
+        <p:spPr>
+          <a:xfrm>
+            <a:off x="6438747" y="2331720"/>
+            <a:ext cx="4572000" cy="411480"/>
+          </a:xfrm>
+          <a:prstGeom prst="rect">
+            <a:avLst/>
+          </a:prstGeom>
+          <a:noFill/>
+        </p:spPr>
+        <p:txBody>
+          <a:bodyPr wrap="none">
+            <a:spAutoFit/>
+          </a:bodyPr>
+          <a:lstStyle/>
+          <a:p>
+            <a:r>
+              <a:rPr sz="1900" i="1">
+                <a:solidFill>
+                  <a:srgbClr val="1A1A2E"/>
+                </a:solidFill>
+                <a:latin typeface="Cambria"/>
+              </a:rPr>
+              <a:t>z</a:t>
+            </a:r>
+            <a:r>
+              <a:rPr sz="1300" i="1" baseline="30000">
+                <a:solidFill>
+                  <a:srgbClr val="1A1A2E"/>
+                </a:solidFill>
+                <a:latin typeface="Cambria"/>
+              </a:rPr>
+              <a:t>(k)</a:t>
+            </a:r>
+            <a:r>
+              <a:rPr sz="1900" i="1">
+                <a:solidFill>
+                  <a:srgbClr val="1A1A2E"/>
+                </a:solidFill>
+                <a:latin typeface="Cambria"/>
+              </a:rPr>
+              <a:t> = W</a:t>
+            </a:r>
+            <a:r>
+              <a:rPr sz="1300" i="1" baseline="-25000">
+                <a:solidFill>
+                  <a:srgbClr val="1A1A2E"/>
+                </a:solidFill>
+                <a:latin typeface="Cambria"/>
+              </a:rPr>
+              <a:t>x</a:t>
+            </a:r>
+            <a:r>
+              <a:rPr sz="1300" i="1" baseline="30000">
+                <a:solidFill>
+                  <a:srgbClr val="1A1A2E"/>
+                </a:solidFill>
+                <a:latin typeface="Cambria"/>
+              </a:rPr>
+              <a:t>(k)</a:t>
+            </a:r>
+            <a:r>
+              <a:rPr sz="1900" i="1">
+                <a:solidFill>
+                  <a:srgbClr val="1A1A2E"/>
+                </a:solidFill>
+                <a:latin typeface="Cambria"/>
+              </a:rPr>
+              <a:t> x</a:t>
+            </a:r>
+            <a:r>
+              <a:rPr sz="1300" i="1" baseline="30000">
+                <a:solidFill>
+                  <a:srgbClr val="1A1A2E"/>
+                </a:solidFill>
+                <a:latin typeface="Cambria"/>
+              </a:rPr>
+              <a:t>(k)</a:t>
+            </a:r>
+            <a:r>
+              <a:rPr sz="1900" i="1">
+                <a:solidFill>
+                  <a:srgbClr val="1A1A2E"/>
+                </a:solidFill>
+                <a:latin typeface="Cambria"/>
+              </a:rPr>
+              <a:t> + W</a:t>
+            </a:r>
+            <a:r>
+              <a:rPr sz="1300" i="1" baseline="-25000">
+                <a:solidFill>
+                  <a:srgbClr val="1A1A2E"/>
+                </a:solidFill>
+                <a:latin typeface="Cambria"/>
+              </a:rPr>
+              <a:t>y</a:t>
+            </a:r>
+            <a:r>
+              <a:rPr sz="1300" i="1" baseline="30000">
+                <a:solidFill>
+                  <a:srgbClr val="1A1A2E"/>
+                </a:solidFill>
+                <a:latin typeface="Cambria"/>
+              </a:rPr>
+              <a:t>(k)</a:t>
+            </a:r>
+            <a:r>
+              <a:rPr sz="1900" i="1">
+                <a:solidFill>
+                  <a:srgbClr val="1A1A2E"/>
+                </a:solidFill>
+                <a:latin typeface="Cambria"/>
+              </a:rPr>
+              <a:t> b</a:t>
+            </a:r>
+          </a:p>
+        </p:txBody>
+      </p:sp>
+      <p:sp>
+        <p:nvSpPr>
+          <p:cNvPr id="18" name="TextBox 17"/>
+          <p:cNvSpPr txBox="1"/>
+          <p:nvPr/>
+        </p:nvSpPr>
+        <p:spPr>
+          <a:xfrm>
+            <a:off x="6438747" y="2971800"/>
+            <a:ext cx="3657600" cy="411480"/>
+          </a:xfrm>
+          <a:prstGeom prst="rect">
+            <a:avLst/>
+          </a:prstGeom>
+          <a:noFill/>
+        </p:spPr>
+        <p:txBody>
+          <a:bodyPr wrap="none">
+            <a:spAutoFit/>
+          </a:bodyPr>
+          <a:lstStyle/>
+          <a:p>
+            <a:r>
+              <a:rPr sz="1900" i="1">
+                <a:solidFill>
+                  <a:srgbClr val="1A1A2E"/>
+                </a:solidFill>
+                <a:latin typeface="Cambria"/>
+              </a:rPr>
+              <a:t>x</a:t>
+            </a:r>
+            <a:r>
+              <a:rPr sz="1300" i="1" baseline="30000">
+                <a:solidFill>
+                  <a:srgbClr val="1A1A2E"/>
+                </a:solidFill>
+                <a:latin typeface="Cambria"/>
+              </a:rPr>
+              <a:t>(k+1)</a:t>
+            </a:r>
+            <a:r>
+              <a:rPr sz="1900" i="1">
+                <a:solidFill>
+                  <a:srgbClr val="1A1A2E"/>
+                </a:solidFill>
+                <a:latin typeface="Cambria"/>
+              </a:rPr>
+              <a:t> = S</a:t>
+            </a:r>
+            <a:r>
+              <a:rPr sz="1300" i="1" baseline="-25000">
+                <a:solidFill>
+                  <a:srgbClr val="1A1A2E"/>
+                </a:solidFill>
+                <a:latin typeface="Cambria"/>
+              </a:rPr>
+              <a:t>θₖ</a:t>
+            </a:r>
+            <a:r>
+              <a:rPr sz="1900" i="1">
+                <a:solidFill>
+                  <a:srgbClr val="1A1A2E"/>
+                </a:solidFill>
+                <a:latin typeface="Cambria"/>
+              </a:rPr>
+              <a:t>( z</a:t>
+            </a:r>
+            <a:r>
+              <a:rPr sz="1300" i="1" baseline="30000">
+                <a:solidFill>
+                  <a:srgbClr val="1A1A2E"/>
+                </a:solidFill>
+                <a:latin typeface="Cambria"/>
+              </a:rPr>
+              <a:t>(k)</a:t>
+            </a:r>
+            <a:r>
+              <a:rPr sz="1900" i="1">
+                <a:solidFill>
+                  <a:srgbClr val="1A1A2E"/>
+                </a:solidFill>
+                <a:latin typeface="Cambria"/>
+              </a:rPr>
+              <a:t> )</a:t>
+            </a:r>
+          </a:p>
+        </p:txBody>
+      </p:sp>
       <p:sp>
         <p:nvSpPr>
           <p:cNvPr id="19" name="TextBox 18"/>
@@ -16211,30 +16948,148 @@
           </a:p>
         </p:txBody>
       </p:sp>
-      <p:pic>
-        <p:nvPicPr>
-          <p:cNvPr id="8" name="Picture 7" descr="image.png"/>
-          <p:cNvPicPr>
-            <a:picLocks noChangeAspect="1"/>
-          </p:cNvPicPr>
-          <p:nvPr/>
-        </p:nvPicPr>
-        <p:blipFill>
-          <a:blip r:embed="rId2"/>
-          <a:stretch>
-            <a:fillRect/>
-          </a:stretch>
-        </p:blipFill>
-        <p:spPr>
-          <a:xfrm>
-            <a:off x="502920" y="1554480"/>
-            <a:ext cx="6400800" cy="991836"/>
-          </a:xfrm>
-          <a:prstGeom prst="rect">
-            <a:avLst/>
-          </a:prstGeom>
-        </p:spPr>
-      </p:pic>
+      <p:sp>
+        <p:nvSpPr>
+          <p:cNvPr id="8" name="TextBox 7"/>
+          <p:cNvSpPr txBox="1"/>
+          <p:nvPr/>
+        </p:nvSpPr>
+        <p:spPr>
+          <a:xfrm>
+            <a:off x="731520" y="1572768"/>
+            <a:ext cx="6400800" cy="411480"/>
+          </a:xfrm>
+          <a:prstGeom prst="rect">
+            <a:avLst/>
+          </a:prstGeom>
+          <a:noFill/>
+        </p:spPr>
+        <p:txBody>
+          <a:bodyPr wrap="none">
+            <a:spAutoFit/>
+          </a:bodyPr>
+          <a:lstStyle/>
+          <a:p>
+            <a:r>
+              <a:rPr sz="2000" i="1">
+                <a:solidFill>
+                  <a:srgbClr val="1A1A2E"/>
+                </a:solidFill>
+                <a:latin typeface="Cambria"/>
+              </a:rPr>
+              <a:t>x</a:t>
+            </a:r>
+            <a:r>
+              <a:rPr sz="1400" i="1" baseline="30000">
+                <a:solidFill>
+                  <a:srgbClr val="1A1A2E"/>
+                </a:solidFill>
+                <a:latin typeface="Cambria"/>
+              </a:rPr>
+              <a:t>(k+1)</a:t>
+            </a:r>
+            <a:r>
+              <a:rPr sz="2000" i="1">
+                <a:solidFill>
+                  <a:srgbClr val="1A1A2E"/>
+                </a:solidFill>
+                <a:latin typeface="Cambria"/>
+              </a:rPr>
+              <a:t> = S</a:t>
+            </a:r>
+            <a:r>
+              <a:rPr sz="1400" i="1" baseline="-25000">
+                <a:solidFill>
+                  <a:srgbClr val="1A1A2E"/>
+                </a:solidFill>
+                <a:latin typeface="Cambria"/>
+              </a:rPr>
+              <a:t>θₖ</a:t>
+            </a:r>
+            <a:r>
+              <a:rPr sz="2000" i="1">
+                <a:solidFill>
+                  <a:srgbClr val="1A1A2E"/>
+                </a:solidFill>
+                <a:latin typeface="Cambria"/>
+              </a:rPr>
+              <a:t>( W</a:t>
+            </a:r>
+            <a:r>
+              <a:rPr sz="1400" i="1" baseline="-25000">
+                <a:solidFill>
+                  <a:srgbClr val="1A1A2E"/>
+                </a:solidFill>
+                <a:latin typeface="Cambria"/>
+              </a:rPr>
+              <a:t>x</a:t>
+            </a:r>
+            <a:r>
+              <a:rPr sz="1400" i="1" baseline="30000">
+                <a:solidFill>
+                  <a:srgbClr val="1A1A2E"/>
+                </a:solidFill>
+                <a:latin typeface="Cambria"/>
+              </a:rPr>
+              <a:t>(k)</a:t>
+            </a:r>
+            <a:r>
+              <a:rPr sz="2000" i="1">
+                <a:solidFill>
+                  <a:srgbClr val="1A1A2E"/>
+                </a:solidFill>
+                <a:latin typeface="Cambria"/>
+              </a:rPr>
+              <a:t> x</a:t>
+            </a:r>
+            <a:r>
+              <a:rPr sz="1400" i="1" baseline="30000">
+                <a:solidFill>
+                  <a:srgbClr val="1A1A2E"/>
+                </a:solidFill>
+                <a:latin typeface="Cambria"/>
+              </a:rPr>
+              <a:t>(k)</a:t>
+            </a:r>
+            <a:r>
+              <a:rPr sz="2000" i="1">
+                <a:solidFill>
+                  <a:srgbClr val="1A1A2E"/>
+                </a:solidFill>
+                <a:latin typeface="Cambria"/>
+              </a:rPr>
+              <a:t> + W</a:t>
+            </a:r>
+            <a:r>
+              <a:rPr sz="1400" i="1" baseline="-25000">
+                <a:solidFill>
+                  <a:srgbClr val="1A1A2E"/>
+                </a:solidFill>
+                <a:latin typeface="Cambria"/>
+              </a:rPr>
+              <a:t>y</a:t>
+            </a:r>
+            <a:r>
+              <a:rPr sz="1400" i="1" baseline="30000">
+                <a:solidFill>
+                  <a:srgbClr val="1A1A2E"/>
+                </a:solidFill>
+                <a:latin typeface="Cambria"/>
+              </a:rPr>
+              <a:t>(k)</a:t>
+            </a:r>
+            <a:r>
+              <a:rPr sz="2000" i="1">
+                <a:solidFill>
+                  <a:srgbClr val="1A1A2E"/>
+                </a:solidFill>
+                <a:latin typeface="Cambria"/>
+              </a:rPr>
+              <a:t> b )</a:t>
+            </a:r>
+          </a:p>
+        </p:txBody>
+      </p:sp>
       <p:sp>
         <p:nvSpPr>
           <p:cNvPr id="9" name="TextBox 8"/>
@@ -16270,54 +17125,236 @@
           </a:p>
         </p:txBody>
       </p:sp>
-      <p:pic>
-        <p:nvPicPr>
-          <p:cNvPr id="10" name="Picture 9" descr="image.png"/>
-          <p:cNvPicPr>
-            <a:picLocks noChangeAspect="1"/>
-          </p:cNvPicPr>
-          <p:nvPr/>
-        </p:nvPicPr>
-        <p:blipFill>
-          <a:blip r:embed="rId3"/>
-          <a:stretch>
-            <a:fillRect/>
-          </a:stretch>
-        </p:blipFill>
-        <p:spPr>
-          <a:xfrm>
-            <a:off x="502920" y="2697480"/>
-            <a:ext cx="5029200" cy="680139"/>
-          </a:xfrm>
-          <a:prstGeom prst="rect">
-            <a:avLst/>
-          </a:prstGeom>
-        </p:spPr>
-      </p:pic>
-      <p:pic>
-        <p:nvPicPr>
-          <p:cNvPr id="11" name="Picture 10" descr="image.png"/>
-          <p:cNvPicPr>
-            <a:picLocks noChangeAspect="1"/>
-          </p:cNvPicPr>
-          <p:nvPr/>
-        </p:nvPicPr>
-        <p:blipFill>
-          <a:blip r:embed="rId4"/>
-          <a:stretch>
-            <a:fillRect/>
-          </a:stretch>
-        </p:blipFill>
-        <p:spPr>
-          <a:xfrm>
-            <a:off x="502920" y="3108960"/>
-            <a:ext cx="6858000" cy="846399"/>
-          </a:xfrm>
-          <a:prstGeom prst="rect">
-            <a:avLst/>
-          </a:prstGeom>
-        </p:spPr>
-      </p:pic>
+      <p:sp>
+        <p:nvSpPr>
+          <p:cNvPr id="10" name="TextBox 9"/>
+          <p:cNvSpPr txBox="1"/>
+          <p:nvPr/>
+        </p:nvSpPr>
+        <p:spPr>
+          <a:xfrm>
+            <a:off x="731520" y="2715768"/>
+            <a:ext cx="5943600" cy="411480"/>
+          </a:xfrm>
+          <a:prstGeom prst="rect">
+            <a:avLst/>
+          </a:prstGeom>
+          <a:noFill/>
+        </p:spPr>
+        <p:txBody>
+          <a:bodyPr wrap="none">
+            <a:spAutoFit/>
+          </a:bodyPr>
+          <a:lstStyle/>
+          <a:p>
+            <a:r>
+              <a:rPr sz="1800" i="1">
+                <a:solidFill>
+                  <a:srgbClr val="1A1A2E"/>
+                </a:solidFill>
+                <a:latin typeface="Cambria"/>
+              </a:rPr>
+              <a:t>W</a:t>
+            </a:r>
+            <a:r>
+              <a:rPr sz="1200" i="1" baseline="30000">
+                <a:solidFill>
+                  <a:srgbClr val="1A1A2E"/>
+                </a:solidFill>
+                <a:latin typeface="Cambria"/>
+              </a:rPr>
+              <a:t>*</a:t>
+            </a:r>
+            <a:r>
+              <a:rPr sz="1800" i="1">
+                <a:solidFill>
+                  <a:srgbClr val="1A1A2E"/>
+                </a:solidFill>
+                <a:latin typeface="Cambria"/>
+              </a:rPr>
+              <a:t> = ( A A</a:t>
+            </a:r>
+            <a:r>
+              <a:rPr sz="1200" i="1" baseline="30000">
+                <a:solidFill>
+                  <a:srgbClr val="1A1A2E"/>
+                </a:solidFill>
+                <a:latin typeface="Cambria"/>
+              </a:rPr>
+              <a:t>T</a:t>
+            </a:r>
+            <a:r>
+              <a:rPr sz="1800" i="1">
+                <a:solidFill>
+                  <a:srgbClr val="1A1A2E"/>
+                </a:solidFill>
+                <a:latin typeface="Cambria"/>
+              </a:rPr>
+              <a:t> )</a:t>
+            </a:r>
+            <a:r>
+              <a:rPr sz="1200" i="1" baseline="30000">
+                <a:solidFill>
+                  <a:srgbClr val="1A1A2E"/>
+                </a:solidFill>
+                <a:latin typeface="Cambria"/>
+              </a:rPr>
+              <a:t>−1</a:t>
+            </a:r>
+            <a:r>
+              <a:rPr sz="1800" i="1">
+                <a:solidFill>
+                  <a:srgbClr val="1A1A2E"/>
+                </a:solidFill>
+                <a:latin typeface="Cambria"/>
+              </a:rPr>
+              <a:t> A      (column-normalized)</a:t>
+            </a:r>
+          </a:p>
+        </p:txBody>
+      </p:sp>
+      <p:sp>
+        <p:nvSpPr>
+          <p:cNvPr id="11" name="TextBox 10"/>
+          <p:cNvSpPr txBox="1"/>
+          <p:nvPr/>
+        </p:nvSpPr>
+        <p:spPr>
+          <a:xfrm>
+            <a:off x="731520" y="3145536"/>
+            <a:ext cx="6858000" cy="411480"/>
+          </a:xfrm>
+          <a:prstGeom prst="rect">
+            <a:avLst/>
+          </a:prstGeom>
+          <a:noFill/>
+        </p:spPr>
+        <p:txBody>
+          <a:bodyPr wrap="none">
+            <a:spAutoFit/>
+          </a:bodyPr>
+          <a:lstStyle/>
+          <a:p>
+            <a:r>
+              <a:rPr sz="1800" i="1">
+                <a:solidFill>
+                  <a:srgbClr val="1A1A2E"/>
+                </a:solidFill>
+                <a:latin typeface="Cambria"/>
+              </a:rPr>
+              <a:t>x</a:t>
+            </a:r>
+            <a:r>
+              <a:rPr sz="1200" i="1" baseline="30000">
+                <a:solidFill>
+                  <a:srgbClr val="1A1A2E"/>
+                </a:solidFill>
+                <a:latin typeface="Cambria"/>
+              </a:rPr>
+              <a:t>(k+1)</a:t>
+            </a:r>
+            <a:r>
+              <a:rPr sz="1800" i="1">
+                <a:solidFill>
+                  <a:srgbClr val="1A1A2E"/>
+                </a:solidFill>
+                <a:latin typeface="Cambria"/>
+              </a:rPr>
+              <a:t> = S</a:t>
+            </a:r>
+            <a:r>
+              <a:rPr sz="1200" i="1" baseline="-25000">
+                <a:solidFill>
+                  <a:srgbClr val="1A1A2E"/>
+                </a:solidFill>
+                <a:latin typeface="Cambria"/>
+              </a:rPr>
+              <a:t>θₖ</a:t>
+            </a:r>
+            <a:r>
+              <a:rPr sz="1800" i="1">
+                <a:solidFill>
+                  <a:srgbClr val="1A1A2E"/>
+                </a:solidFill>
+                <a:latin typeface="Cambria"/>
+              </a:rPr>
+              <a:t>( x</a:t>
+            </a:r>
+            <a:r>
+              <a:rPr sz="1200" i="1" baseline="30000">
+                <a:solidFill>
+                  <a:srgbClr val="1A1A2E"/>
+                </a:solidFill>
+                <a:latin typeface="Cambria"/>
+              </a:rPr>
+              <a:t>(k)</a:t>
+            </a:r>
+            <a:r>
+              <a:rPr sz="1800" i="1">
+                <a:solidFill>
+                  <a:srgbClr val="1A1A2E"/>
+                </a:solidFill>
+                <a:latin typeface="Cambria"/>
+              </a:rPr>
+              <a:t> + γ</a:t>
+            </a:r>
+            <a:r>
+              <a:rPr sz="1200" i="1" baseline="-25000">
+                <a:solidFill>
+                  <a:srgbClr val="1A1A2E"/>
+                </a:solidFill>
+                <a:latin typeface="Cambria"/>
+              </a:rPr>
+              <a:t>k</a:t>
+            </a:r>
+            <a:r>
+              <a:rPr sz="1800" i="1">
+                <a:solidFill>
+                  <a:srgbClr val="1A1A2E"/>
+                </a:solidFill>
+                <a:latin typeface="Cambria"/>
+              </a:rPr>
+              <a:t> W</a:t>
+            </a:r>
+            <a:r>
+              <a:rPr sz="1200" i="1" baseline="30000">
+                <a:solidFill>
+                  <a:srgbClr val="1A1A2E"/>
+                </a:solidFill>
+                <a:latin typeface="Cambria"/>
+              </a:rPr>
+              <a:t>*T</a:t>
+            </a:r>
+            <a:r>
+              <a:rPr sz="1800" i="1">
+                <a:solidFill>
+                  <a:srgbClr val="1A1A2E"/>
+                </a:solidFill>
+                <a:latin typeface="Cambria"/>
+              </a:rPr>
+              <a:t>( b − A x</a:t>
+            </a:r>
+            <a:r>
+              <a:rPr sz="1200" i="1" baseline="30000">
+                <a:solidFill>
+                  <a:srgbClr val="1A1A2E"/>
+                </a:solidFill>
+                <a:latin typeface="Cambria"/>
+              </a:rPr>
+              <a:t>(k)</a:t>
+            </a:r>
+            <a:r>
+              <a:rPr sz="1800" i="1">
+                <a:solidFill>
+                  <a:srgbClr val="1A1A2E"/>
+                </a:solidFill>
+                <a:latin typeface="Cambria"/>
+              </a:rPr>
+              <a:t> ) )</a:t>
+            </a:r>
+          </a:p>
+        </p:txBody>
+      </p:sp>
       <p:sp>
         <p:nvSpPr>
           <p:cNvPr id="12" name="TextBox 11"/>
@@ -16353,54 +17390,353 @@
           </a:p>
         </p:txBody>
       </p:sp>
-      <p:pic>
-        <p:nvPicPr>
-          <p:cNvPr id="13" name="Picture 12" descr="image.png"/>
-          <p:cNvPicPr>
-            <a:picLocks noChangeAspect="1"/>
-          </p:cNvPicPr>
-          <p:nvPr/>
-        </p:nvPicPr>
-        <p:blipFill>
-          <a:blip r:embed="rId5"/>
-          <a:stretch>
-            <a:fillRect/>
-          </a:stretch>
-        </p:blipFill>
-        <p:spPr>
-          <a:xfrm>
-            <a:off x="502920" y="4206240"/>
-            <a:ext cx="6400800" cy="622050"/>
-          </a:xfrm>
-          <a:prstGeom prst="rect">
-            <a:avLst/>
-          </a:prstGeom>
-        </p:spPr>
-      </p:pic>
-      <p:pic>
-        <p:nvPicPr>
-          <p:cNvPr id="14" name="Picture 13" descr="image.png"/>
-          <p:cNvPicPr>
-            <a:picLocks noChangeAspect="1"/>
-          </p:cNvPicPr>
-          <p:nvPr/>
-        </p:nvPicPr>
-        <p:blipFill>
-          <a:blip r:embed="rId6"/>
-          <a:stretch>
-            <a:fillRect/>
-          </a:stretch>
-        </p:blipFill>
-        <p:spPr>
-          <a:xfrm>
-            <a:off x="502920" y="4663440"/>
-            <a:ext cx="5029200" cy="1221190"/>
-          </a:xfrm>
-          <a:prstGeom prst="rect">
-            <a:avLst/>
-          </a:prstGeom>
-        </p:spPr>
-      </p:pic>
+      <p:sp>
+        <p:nvSpPr>
+          <p:cNvPr id="13" name="TextBox 12"/>
+          <p:cNvSpPr txBox="1"/>
+          <p:nvPr/>
+        </p:nvSpPr>
+        <p:spPr>
+          <a:xfrm>
+            <a:off x="731520" y="4407408"/>
+            <a:ext cx="6583680" cy="411480"/>
+          </a:xfrm>
+          <a:prstGeom prst="rect">
+            <a:avLst/>
+          </a:prstGeom>
+          <a:noFill/>
+        </p:spPr>
+        <p:txBody>
+          <a:bodyPr wrap="none">
+            <a:spAutoFit/>
+          </a:bodyPr>
+          <a:lstStyle/>
+          <a:p>
+            <a:r>
+              <a:rPr sz="1600" i="1">
+                <a:solidFill>
+                  <a:srgbClr val="1A1A2E"/>
+                </a:solidFill>
+                <a:latin typeface="Cambria"/>
+              </a:rPr>
+              <a:t>θ</a:t>
+            </a:r>
+            <a:r>
+              <a:rPr sz="1100" i="1" baseline="30000">
+                <a:solidFill>
+                  <a:srgbClr val="1A1A2E"/>
+                </a:solidFill>
+                <a:latin typeface="Cambria"/>
+              </a:rPr>
+              <a:t>(k)</a:t>
+            </a:r>
+            <a:r>
+              <a:rPr sz="1600" i="1">
+                <a:solidFill>
+                  <a:srgbClr val="1A1A2E"/>
+                </a:solidFill>
+                <a:latin typeface="Cambria"/>
+              </a:rPr>
+              <a:t> = c</a:t>
+            </a:r>
+            <a:r>
+              <a:rPr sz="1100" i="1" baseline="-25000">
+                <a:solidFill>
+                  <a:srgbClr val="1A1A2E"/>
+                </a:solidFill>
+                <a:latin typeface="Cambria"/>
+              </a:rPr>
+              <a:t>1</a:t>
+            </a:r>
+            <a:r>
+              <a:rPr sz="1600" i="1">
+                <a:solidFill>
+                  <a:srgbClr val="1A1A2E"/>
+                </a:solidFill>
+                <a:latin typeface="Cambria"/>
+              </a:rPr>
+              <a:t> μ ‖ A</a:t>
+            </a:r>
+            <a:r>
+              <a:rPr sz="1100" i="1" baseline="30000">
+                <a:solidFill>
+                  <a:srgbClr val="1A1A2E"/>
+                </a:solidFill>
+                <a:latin typeface="Cambria"/>
+              </a:rPr>
+              <a:t>+</a:t>
+            </a:r>
+            <a:r>
+              <a:rPr sz="1600" i="1">
+                <a:solidFill>
+                  <a:srgbClr val="1A1A2E"/>
+                </a:solidFill>
+                <a:latin typeface="Cambria"/>
+              </a:rPr>
+              <a:t>( A x</a:t>
+            </a:r>
+            <a:r>
+              <a:rPr sz="1100" i="1" baseline="30000">
+                <a:solidFill>
+                  <a:srgbClr val="1A1A2E"/>
+                </a:solidFill>
+                <a:latin typeface="Cambria"/>
+              </a:rPr>
+              <a:t>(k)</a:t>
+            </a:r>
+            <a:r>
+              <a:rPr sz="1600" i="1">
+                <a:solidFill>
+                  <a:srgbClr val="1A1A2E"/>
+                </a:solidFill>
+                <a:latin typeface="Cambria"/>
+              </a:rPr>
+              <a:t> − b ) ‖</a:t>
+            </a:r>
+            <a:r>
+              <a:rPr sz="1100" i="1" baseline="-25000">
+                <a:solidFill>
+                  <a:srgbClr val="1A1A2E"/>
+                </a:solidFill>
+                <a:latin typeface="Cambria"/>
+              </a:rPr>
+              <a:t>1</a:t>
+            </a:r>
+            <a:r>
+              <a:rPr sz="1600" i="1">
+                <a:solidFill>
+                  <a:srgbClr val="1A1A2E"/>
+                </a:solidFill>
+                <a:latin typeface="Cambria"/>
+              </a:rPr>
+              <a:t> ,     β</a:t>
+            </a:r>
+            <a:r>
+              <a:rPr sz="1100" i="1" baseline="30000">
+                <a:solidFill>
+                  <a:srgbClr val="1A1A2E"/>
+                </a:solidFill>
+                <a:latin typeface="Cambria"/>
+              </a:rPr>
+              <a:t>(k)</a:t>
+            </a:r>
+            <a:r>
+              <a:rPr sz="1600" i="1">
+                <a:solidFill>
+                  <a:srgbClr val="1A1A2E"/>
+                </a:solidFill>
+                <a:latin typeface="Cambria"/>
+              </a:rPr>
+              <a:t> = c</a:t>
+            </a:r>
+            <a:r>
+              <a:rPr sz="1100" i="1" baseline="-25000">
+                <a:solidFill>
+                  <a:srgbClr val="1A1A2E"/>
+                </a:solidFill>
+                <a:latin typeface="Cambria"/>
+              </a:rPr>
+              <a:t>2</a:t>
+            </a:r>
+            <a:r>
+              <a:rPr sz="1600" i="1">
+                <a:solidFill>
+                  <a:srgbClr val="1A1A2E"/>
+                </a:solidFill>
+                <a:latin typeface="Cambria"/>
+              </a:rPr>
+              <a:t> μ ‖ x</a:t>
+            </a:r>
+            <a:r>
+              <a:rPr sz="1100" i="1" baseline="30000">
+                <a:solidFill>
+                  <a:srgbClr val="1A1A2E"/>
+                </a:solidFill>
+                <a:latin typeface="Cambria"/>
+              </a:rPr>
+              <a:t>(k)</a:t>
+            </a:r>
+            <a:r>
+              <a:rPr sz="1600" i="1">
+                <a:solidFill>
+                  <a:srgbClr val="1A1A2E"/>
+                </a:solidFill>
+                <a:latin typeface="Cambria"/>
+              </a:rPr>
+              <a:t> ‖</a:t>
+            </a:r>
+            <a:r>
+              <a:rPr sz="1100" i="1" baseline="-25000">
+                <a:solidFill>
+                  <a:srgbClr val="1A1A2E"/>
+                </a:solidFill>
+                <a:latin typeface="Cambria"/>
+              </a:rPr>
+              <a:t>0</a:t>
+            </a:r>
+          </a:p>
+        </p:txBody>
+      </p:sp>
+      <p:sp>
+        <p:nvSpPr>
+          <p:cNvPr id="14" name="TextBox 13"/>
+          <p:cNvSpPr txBox="1"/>
+          <p:nvPr/>
+        </p:nvSpPr>
+        <p:spPr>
+          <a:xfrm>
+            <a:off x="731520" y="4864608"/>
+            <a:ext cx="6583680" cy="411480"/>
+          </a:xfrm>
+          <a:prstGeom prst="rect">
+            <a:avLst/>
+          </a:prstGeom>
+          <a:noFill/>
+        </p:spPr>
+        <p:txBody>
+          <a:bodyPr wrap="none">
+            <a:spAutoFit/>
+          </a:bodyPr>
+          <a:lstStyle/>
+          <a:p>
+            <a:r>
+              <a:rPr sz="1600" i="1">
+                <a:solidFill>
+                  <a:srgbClr val="1A1A2E"/>
+                </a:solidFill>
+                <a:latin typeface="Cambria"/>
+              </a:rPr>
+              <a:t>p</a:t>
+            </a:r>
+            <a:r>
+              <a:rPr sz="1100" i="1" baseline="30000">
+                <a:solidFill>
+                  <a:srgbClr val="1A1A2E"/>
+                </a:solidFill>
+                <a:latin typeface="Cambria"/>
+              </a:rPr>
+              <a:t>(k)</a:t>
+            </a:r>
+            <a:r>
+              <a:rPr sz="1600" i="1">
+                <a:solidFill>
+                  <a:srgbClr val="1A1A2E"/>
+                </a:solidFill>
+                <a:latin typeface="Cambria"/>
+              </a:rPr>
+              <a:t> = c</a:t>
+            </a:r>
+            <a:r>
+              <a:rPr sz="1100" i="1" baseline="-25000">
+                <a:solidFill>
+                  <a:srgbClr val="1A1A2E"/>
+                </a:solidFill>
+                <a:latin typeface="Cambria"/>
+              </a:rPr>
+              <a:t>3</a:t>
+            </a:r>
+            <a:r>
+              <a:rPr sz="1600" i="1">
+                <a:solidFill>
+                  <a:srgbClr val="1A1A2E"/>
+                </a:solidFill>
+                <a:latin typeface="Cambria"/>
+              </a:rPr>
+              <a:t> log (  ‖ A</a:t>
+            </a:r>
+            <a:r>
+              <a:rPr sz="1100" i="1" baseline="30000">
+                <a:solidFill>
+                  <a:srgbClr val="1A1A2E"/>
+                </a:solidFill>
+                <a:latin typeface="Cambria"/>
+              </a:rPr>
+              <a:t>+</a:t>
+            </a:r>
+            <a:r>
+              <a:rPr sz="1600" i="1">
+                <a:solidFill>
+                  <a:srgbClr val="1A1A2E"/>
+                </a:solidFill>
+                <a:latin typeface="Cambria"/>
+              </a:rPr>
+              <a:t> b ‖</a:t>
+            </a:r>
+            <a:r>
+              <a:rPr sz="1100" i="1" baseline="-25000">
+                <a:solidFill>
+                  <a:srgbClr val="1A1A2E"/>
+                </a:solidFill>
+                <a:latin typeface="Cambria"/>
+              </a:rPr>
+              <a:t>1</a:t>
+            </a:r>
+            <a:r>
+              <a:rPr sz="1600" i="1">
+                <a:solidFill>
+                  <a:srgbClr val="1A1A2E"/>
+                </a:solidFill>
+                <a:latin typeface="Cambria"/>
+              </a:rPr>
+              <a:t>  /  ‖ A</a:t>
+            </a:r>
+            <a:r>
+              <a:rPr sz="1100" i="1" baseline="30000">
+                <a:solidFill>
+                  <a:srgbClr val="1A1A2E"/>
+                </a:solidFill>
+                <a:latin typeface="Cambria"/>
+              </a:rPr>
+              <a:t>+</a:t>
+            </a:r>
+            <a:r>
+              <a:rPr sz="1600" i="1">
+                <a:solidFill>
+                  <a:srgbClr val="1A1A2E"/>
+                </a:solidFill>
+                <a:latin typeface="Cambria"/>
+              </a:rPr>
+              <a:t>( A x</a:t>
+            </a:r>
+            <a:r>
+              <a:rPr sz="1100" i="1" baseline="30000">
+                <a:solidFill>
+                  <a:srgbClr val="1A1A2E"/>
+                </a:solidFill>
+                <a:latin typeface="Cambria"/>
+              </a:rPr>
+              <a:t>(k)</a:t>
+            </a:r>
+            <a:r>
+              <a:rPr sz="1600" i="1">
+                <a:solidFill>
+                  <a:srgbClr val="1A1A2E"/>
+                </a:solidFill>
+                <a:latin typeface="Cambria"/>
+              </a:rPr>
+              <a:t> − b ) ‖</a:t>
+            </a:r>
+            <a:r>
+              <a:rPr sz="1100" i="1" baseline="-25000">
+                <a:solidFill>
+                  <a:srgbClr val="1A1A2E"/>
+                </a:solidFill>
+                <a:latin typeface="Cambria"/>
+              </a:rPr>
+              <a:t>1</a:t>
+            </a:r>
+            <a:r>
+              <a:rPr sz="1600" i="1">
+                <a:solidFill>
+                  <a:srgbClr val="1A1A2E"/>
+                </a:solidFill>
+                <a:latin typeface="Cambria"/>
+              </a:rPr>
+              <a:t>  )</a:t>
+            </a:r>
+          </a:p>
+        </p:txBody>
+      </p:sp>
       <p:graphicFrame>
         <p:nvGraphicFramePr>
           <p:cNvPr id="15" name="Table 14"/>
@@ -16971,7 +18307,42 @@
       </p:graphicFrame>
       <p:sp>
         <p:nvSpPr>
-          <p:cNvPr id="16" name="Rectangle 15"/>
+          <p:cNvPr id="16" name="TextBox 15"/>
+          <p:cNvSpPr txBox="1"/>
+          <p:nvPr/>
+        </p:nvSpPr>
+        <p:spPr>
+          <a:xfrm>
+            <a:off x="7573975" y="3127248"/>
+            <a:ext cx="4114800" cy="502920"/>
+          </a:xfrm>
+          <a:prstGeom prst="rect">
+            <a:avLst/>
+          </a:prstGeom>
+          <a:noFill/>
+        </p:spPr>
+        <p:txBody>
+          <a:bodyPr wrap="square">
+            <a:spAutoFit/>
+          </a:bodyPr>
+          <a:lstStyle/>
+          <a:p>
+            <a:pPr algn="l"/>
+            <a:r>
+              <a:rPr sz="1200" b="0" i="1">
+                <a:solidFill>
+                  <a:srgbClr val="4A5568"/>
+                </a:solidFill>
+                <a:latin typeface="Calibri"/>
+              </a:rPr>
+              <a:t>NMSE on synthetic sparse recovery (m=250, n=500, s=50, noiseless, K=16 layers)</a:t>
+            </a:r>
+          </a:p>
+        </p:txBody>
+      </p:sp>
+      <p:sp>
+        <p:nvSpPr>
+          <p:cNvPr id="17" name="Rectangle 16"/>
           <p:cNvSpPr/>
           <p:nvPr/>
         </p:nvSpPr>
@@ -17014,7 +18385,7 @@
       </p:sp>
       <p:sp>
         <p:nvSpPr>
-          <p:cNvPr id="17" name="TextBox 16"/>
+          <p:cNvPr id="18" name="TextBox 17"/>
           <p:cNvSpPr txBox="1"/>
           <p:nvPr/>
         </p:nvSpPr>
@@ -17351,30 +18722,148 @@
           </a:p>
         </p:txBody>
       </p:sp>
-      <p:pic>
-        <p:nvPicPr>
-          <p:cNvPr id="9" name="Picture 8" descr="image.png"/>
-          <p:cNvPicPr>
-            <a:picLocks noChangeAspect="1"/>
-          </p:cNvPicPr>
-          <p:nvPr/>
-        </p:nvPicPr>
-        <p:blipFill>
-          <a:blip r:embed="rId2"/>
-          <a:stretch>
-            <a:fillRect/>
-          </a:stretch>
-        </p:blipFill>
-        <p:spPr>
-          <a:xfrm>
-            <a:off x="1371600" y="2011680"/>
-            <a:ext cx="8229600" cy="928468"/>
-          </a:xfrm>
-          <a:prstGeom prst="rect">
-            <a:avLst/>
-          </a:prstGeom>
-        </p:spPr>
-      </p:pic>
+      <p:sp>
+        <p:nvSpPr>
+          <p:cNvPr id="9" name="TextBox 8"/>
+          <p:cNvSpPr txBox="1"/>
+          <p:nvPr/>
+        </p:nvSpPr>
+        <p:spPr>
+          <a:xfrm>
+            <a:off x="3291840" y="2084831"/>
+            <a:ext cx="8229600" cy="411480"/>
+          </a:xfrm>
+          <a:prstGeom prst="rect">
+            <a:avLst/>
+          </a:prstGeom>
+          <a:noFill/>
+        </p:spPr>
+        <p:txBody>
+          <a:bodyPr wrap="none">
+            <a:spAutoFit/>
+          </a:bodyPr>
+          <a:lstStyle/>
+          <a:p>
+            <a:r>
+              <a:rPr sz="2200" i="1">
+                <a:solidFill>
+                  <a:srgbClr val="1A1A2E"/>
+                </a:solidFill>
+                <a:latin typeface="Cambria"/>
+              </a:rPr>
+              <a:t>x</a:t>
+            </a:r>
+            <a:r>
+              <a:rPr sz="1500" i="1" baseline="30000">
+                <a:solidFill>
+                  <a:srgbClr val="1A1A2E"/>
+                </a:solidFill>
+                <a:latin typeface="Cambria"/>
+              </a:rPr>
+              <a:t>(k+1)</a:t>
+            </a:r>
+            <a:r>
+              <a:rPr sz="2200" i="1">
+                <a:solidFill>
+                  <a:srgbClr val="1A1A2E"/>
+                </a:solidFill>
+                <a:latin typeface="Cambria"/>
+              </a:rPr>
+              <a:t> = S</a:t>
+            </a:r>
+            <a:r>
+              <a:rPr sz="1500" i="1" baseline="-25000">
+                <a:solidFill>
+                  <a:srgbClr val="1A1A2E"/>
+                </a:solidFill>
+                <a:latin typeface="Cambria"/>
+              </a:rPr>
+              <a:t>θₖ</a:t>
+            </a:r>
+            <a:r>
+              <a:rPr sz="2200" i="1">
+                <a:solidFill>
+                  <a:srgbClr val="1A1A2E"/>
+                </a:solidFill>
+                <a:latin typeface="Cambria"/>
+              </a:rPr>
+              <a:t>( x</a:t>
+            </a:r>
+            <a:r>
+              <a:rPr sz="1500" i="1" baseline="30000">
+                <a:solidFill>
+                  <a:srgbClr val="1A1A2E"/>
+                </a:solidFill>
+                <a:latin typeface="Cambria"/>
+              </a:rPr>
+              <a:t>(k)</a:t>
+            </a:r>
+            <a:r>
+              <a:rPr sz="2200" i="1">
+                <a:solidFill>
+                  <a:srgbClr val="1A1A2E"/>
+                </a:solidFill>
+                <a:latin typeface="Cambria"/>
+              </a:rPr>
+              <a:t> + γ</a:t>
+            </a:r>
+            <a:r>
+              <a:rPr sz="1500" i="1" baseline="-25000">
+                <a:solidFill>
+                  <a:srgbClr val="1A1A2E"/>
+                </a:solidFill>
+                <a:latin typeface="Cambria"/>
+              </a:rPr>
+              <a:t>k</a:t>
+            </a:r>
+            <a:r>
+              <a:rPr sz="2200" i="1">
+                <a:solidFill>
+                  <a:srgbClr val="1A1A2E"/>
+                </a:solidFill>
+                <a:latin typeface="Cambria"/>
+              </a:rPr>
+              <a:t> A</a:t>
+            </a:r>
+            <a:r>
+              <a:rPr sz="1500" i="1" baseline="30000">
+                <a:solidFill>
+                  <a:srgbClr val="1A1A2E"/>
+                </a:solidFill>
+                <a:latin typeface="Cambria"/>
+              </a:rPr>
+              <a:t>T</a:t>
+            </a:r>
+            <a:r>
+              <a:rPr sz="2200" i="1">
+                <a:solidFill>
+                  <a:srgbClr val="1A1A2E"/>
+                </a:solidFill>
+                <a:latin typeface="Cambria"/>
+              </a:rPr>
+              <a:t>( b − A x</a:t>
+            </a:r>
+            <a:r>
+              <a:rPr sz="1500" i="1" baseline="30000">
+                <a:solidFill>
+                  <a:srgbClr val="1A1A2E"/>
+                </a:solidFill>
+                <a:latin typeface="Cambria"/>
+              </a:rPr>
+              <a:t>(k)</a:t>
+            </a:r>
+            <a:r>
+              <a:rPr sz="2200" i="1">
+                <a:solidFill>
+                  <a:srgbClr val="1A1A2E"/>
+                </a:solidFill>
+                <a:latin typeface="Cambria"/>
+              </a:rPr>
+              <a:t> ) )</a:t>
+            </a:r>
+          </a:p>
+        </p:txBody>
+      </p:sp>
       <p:sp>
         <p:nvSpPr>
           <p:cNvPr id="10" name="TextBox 9"/>
@@ -19551,30 +21040,85 @@
           </a:p>
         </p:txBody>
       </p:sp>
-      <p:pic>
-        <p:nvPicPr>
-          <p:cNvPr id="10" name="Picture 9" descr="image.png"/>
-          <p:cNvPicPr>
-            <a:picLocks noChangeAspect="1"/>
-          </p:cNvPicPr>
-          <p:nvPr/>
-        </p:nvPicPr>
-        <p:blipFill>
-          <a:blip r:embed="rId2"/>
-          <a:stretch>
-            <a:fillRect/>
-          </a:stretch>
-        </p:blipFill>
-        <p:spPr>
-          <a:xfrm>
-            <a:off x="594360" y="2103120"/>
-            <a:ext cx="2834640" cy="733790"/>
-          </a:xfrm>
-          <a:prstGeom prst="rect">
-            <a:avLst/>
-          </a:prstGeom>
-        </p:spPr>
-      </p:pic>
+      <p:sp>
+        <p:nvSpPr>
+          <p:cNvPr id="10" name="TextBox 9"/>
+          <p:cNvSpPr txBox="1"/>
+          <p:nvPr/>
+        </p:nvSpPr>
+        <p:spPr>
+          <a:xfrm>
+            <a:off x="685800" y="2240280"/>
+            <a:ext cx="3286658" cy="411480"/>
+          </a:xfrm>
+          <a:prstGeom prst="rect">
+            <a:avLst/>
+          </a:prstGeom>
+          <a:noFill/>
+        </p:spPr>
+        <p:txBody>
+          <a:bodyPr wrap="none">
+            <a:spAutoFit/>
+          </a:bodyPr>
+          <a:lstStyle/>
+          <a:p>
+            <a:r>
+              <a:rPr sz="1500" i="1">
+                <a:solidFill>
+                  <a:srgbClr val="1A1A2E"/>
+                </a:solidFill>
+                <a:latin typeface="Cambria"/>
+              </a:rPr>
+              <a:t>L = ‖ x</a:t>
+            </a:r>
+            <a:r>
+              <a:rPr sz="1000" i="1" baseline="30000">
+                <a:solidFill>
+                  <a:srgbClr val="1A1A2E"/>
+                </a:solidFill>
+                <a:latin typeface="Cambria"/>
+              </a:rPr>
+              <a:t>(K)</a:t>
+            </a:r>
+            <a:r>
+              <a:rPr sz="1500" i="1">
+                <a:solidFill>
+                  <a:srgbClr val="1A1A2E"/>
+                </a:solidFill>
+                <a:latin typeface="Cambria"/>
+              </a:rPr>
+              <a:t> − x</a:t>
+            </a:r>
+            <a:r>
+              <a:rPr sz="1000" i="1" baseline="30000">
+                <a:solidFill>
+                  <a:srgbClr val="1A1A2E"/>
+                </a:solidFill>
+                <a:latin typeface="Cambria"/>
+              </a:rPr>
+              <a:t>*</a:t>
+            </a:r>
+            <a:r>
+              <a:rPr sz="1500" i="1">
+                <a:solidFill>
+                  <a:srgbClr val="1A1A2E"/>
+                </a:solidFill>
+                <a:latin typeface="Cambria"/>
+              </a:rPr>
+              <a:t> ‖</a:t>
+            </a:r>
+            <a:r>
+              <a:rPr sz="1000" i="1" baseline="30000">
+                <a:solidFill>
+                  <a:srgbClr val="1A1A2E"/>
+                </a:solidFill>
+                <a:latin typeface="Cambria"/>
+              </a:rPr>
+              <a:t>2</a:t>
+            </a:r>
+          </a:p>
+        </p:txBody>
+      </p:sp>
       <p:sp>
         <p:nvSpPr>
           <p:cNvPr id="11" name="TextBox 10"/>
@@ -19691,30 +21235,175 @@
           </a:p>
         </p:txBody>
       </p:sp>
-      <p:pic>
-        <p:nvPicPr>
-          <p:cNvPr id="14" name="Picture 13" descr="image.png"/>
-          <p:cNvPicPr>
-            <a:picLocks noChangeAspect="1"/>
-          </p:cNvPicPr>
-          <p:nvPr/>
-        </p:nvPicPr>
-        <p:blipFill>
-          <a:blip r:embed="rId3"/>
-          <a:stretch>
-            <a:fillRect/>
-          </a:stretch>
-        </p:blipFill>
-        <p:spPr>
-          <a:xfrm>
-            <a:off x="4315358" y="2103120"/>
-            <a:ext cx="3469538" cy="582099"/>
-          </a:xfrm>
-          <a:prstGeom prst="rect">
-            <a:avLst/>
-          </a:prstGeom>
-        </p:spPr>
-      </p:pic>
+      <p:sp>
+        <p:nvSpPr>
+          <p:cNvPr id="14" name="TextBox 13"/>
+          <p:cNvSpPr txBox="1"/>
+          <p:nvPr/>
+        </p:nvSpPr>
+        <p:spPr>
+          <a:xfrm>
+            <a:off x="4406798" y="2240280"/>
+            <a:ext cx="3286658" cy="411480"/>
+          </a:xfrm>
+          <a:prstGeom prst="rect">
+            <a:avLst/>
+          </a:prstGeom>
+          <a:noFill/>
+        </p:spPr>
+        <p:txBody>
+          <a:bodyPr wrap="none">
+            <a:spAutoFit/>
+          </a:bodyPr>
+          <a:lstStyle/>
+          <a:p>
+            <a:r>
+              <a:rPr sz="1500" i="1">
+                <a:solidFill>
+                  <a:srgbClr val="1A1A2E"/>
+                </a:solidFill>
+                <a:latin typeface="Cambria"/>
+              </a:rPr>
+              <a:t>L = ‖x</a:t>
+            </a:r>
+            <a:r>
+              <a:rPr sz="1000" i="1" baseline="30000">
+                <a:solidFill>
+                  <a:srgbClr val="1A1A2E"/>
+                </a:solidFill>
+                <a:latin typeface="Cambria"/>
+              </a:rPr>
+              <a:t>(K)</a:t>
+            </a:r>
+            <a:r>
+              <a:rPr sz="1500" i="1">
+                <a:solidFill>
+                  <a:srgbClr val="1A1A2E"/>
+                </a:solidFill>
+                <a:latin typeface="Cambria"/>
+              </a:rPr>
+              <a:t>−x</a:t>
+            </a:r>
+            <a:r>
+              <a:rPr sz="1000" i="1" baseline="30000">
+                <a:solidFill>
+                  <a:srgbClr val="1A1A2E"/>
+                </a:solidFill>
+                <a:latin typeface="Cambria"/>
+              </a:rPr>
+              <a:t>*</a:t>
+            </a:r>
+            <a:r>
+              <a:rPr sz="1500" i="1">
+                <a:solidFill>
+                  <a:srgbClr val="1A1A2E"/>
+                </a:solidFill>
+                <a:latin typeface="Cambria"/>
+              </a:rPr>
+              <a:t>‖</a:t>
+            </a:r>
+            <a:r>
+              <a:rPr sz="1000" i="1" baseline="30000">
+                <a:solidFill>
+                  <a:srgbClr val="1A1A2E"/>
+                </a:solidFill>
+                <a:latin typeface="Cambria"/>
+              </a:rPr>
+              <a:t>2</a:t>
+            </a:r>
+            <a:r>
+              <a:rPr sz="1500" i="1">
+                <a:solidFill>
+                  <a:srgbClr val="1A1A2E"/>
+                </a:solidFill>
+                <a:latin typeface="Cambria"/>
+              </a:rPr>
+              <a:t> + λ Σ</a:t>
+            </a:r>
+            <a:r>
+              <a:rPr sz="1000" i="1" baseline="-25000">
+                <a:solidFill>
+                  <a:srgbClr val="1A1A2E"/>
+                </a:solidFill>
+                <a:latin typeface="Cambria"/>
+              </a:rPr>
+              <a:t>k</a:t>
+            </a:r>
+            <a:r>
+              <a:rPr sz="1500" i="1">
+                <a:solidFill>
+                  <a:srgbClr val="1A1A2E"/>
+                </a:solidFill>
+                <a:latin typeface="Cambria"/>
+              </a:rPr>
+              <a:t> w</a:t>
+            </a:r>
+            <a:r>
+              <a:rPr sz="1000" i="1" baseline="-25000">
+                <a:solidFill>
+                  <a:srgbClr val="1A1A2E"/>
+                </a:solidFill>
+                <a:latin typeface="Cambria"/>
+              </a:rPr>
+              <a:t>k</a:t>
+            </a:r>
+            <a:r>
+              <a:rPr sz="1500" i="1">
+                <a:solidFill>
+                  <a:srgbClr val="1A1A2E"/>
+                </a:solidFill>
+                <a:latin typeface="Cambria"/>
+              </a:rPr>
+              <a:t> ‖x</a:t>
+            </a:r>
+            <a:r>
+              <a:rPr sz="1000" i="1" baseline="30000">
+                <a:solidFill>
+                  <a:srgbClr val="1A1A2E"/>
+                </a:solidFill>
+                <a:latin typeface="Cambria"/>
+              </a:rPr>
+              <a:t>(k)</a:t>
+            </a:r>
+            <a:r>
+              <a:rPr sz="1500" i="1">
+                <a:solidFill>
+                  <a:srgbClr val="1A1A2E"/>
+                </a:solidFill>
+                <a:latin typeface="Cambria"/>
+              </a:rPr>
+              <a:t>−x</a:t>
+            </a:r>
+            <a:r>
+              <a:rPr sz="1000" i="1" baseline="30000">
+                <a:solidFill>
+                  <a:srgbClr val="1A1A2E"/>
+                </a:solidFill>
+                <a:latin typeface="Cambria"/>
+              </a:rPr>
+              <a:t>*</a:t>
+            </a:r>
+            <a:r>
+              <a:rPr sz="1500" i="1">
+                <a:solidFill>
+                  <a:srgbClr val="1A1A2E"/>
+                </a:solidFill>
+                <a:latin typeface="Cambria"/>
+              </a:rPr>
+              <a:t>‖</a:t>
+            </a:r>
+            <a:r>
+              <a:rPr sz="1000" i="1" baseline="30000">
+                <a:solidFill>
+                  <a:srgbClr val="1A1A2E"/>
+                </a:solidFill>
+                <a:latin typeface="Cambria"/>
+              </a:rPr>
+              <a:t>2</a:t>
+            </a:r>
+          </a:p>
+        </p:txBody>
+      </p:sp>
       <p:sp>
         <p:nvSpPr>
           <p:cNvPr id="15" name="TextBox 14"/>
@@ -19831,30 +21520,103 @@
           </a:p>
         </p:txBody>
       </p:sp>
-      <p:pic>
-        <p:nvPicPr>
-          <p:cNvPr id="18" name="Picture 17" descr="image.png"/>
-          <p:cNvPicPr>
-            <a:picLocks noChangeAspect="1"/>
-          </p:cNvPicPr>
-          <p:nvPr/>
-        </p:nvPicPr>
-        <p:blipFill>
-          <a:blip r:embed="rId4"/>
-          <a:stretch>
-            <a:fillRect/>
-          </a:stretch>
-        </p:blipFill>
-        <p:spPr>
-          <a:xfrm>
-            <a:off x="8036356" y="2103120"/>
-            <a:ext cx="2286000" cy="762000"/>
-          </a:xfrm>
-          <a:prstGeom prst="rect">
-            <a:avLst/>
-          </a:prstGeom>
-        </p:spPr>
-      </p:pic>
+      <p:sp>
+        <p:nvSpPr>
+          <p:cNvPr id="18" name="TextBox 17"/>
+          <p:cNvSpPr txBox="1"/>
+          <p:nvPr/>
+        </p:nvSpPr>
+        <p:spPr>
+          <a:xfrm>
+            <a:off x="8127796" y="2240280"/>
+            <a:ext cx="3286658" cy="411480"/>
+          </a:xfrm>
+          <a:prstGeom prst="rect">
+            <a:avLst/>
+          </a:prstGeom>
+          <a:noFill/>
+        </p:spPr>
+        <p:txBody>
+          <a:bodyPr wrap="none">
+            <a:spAutoFit/>
+          </a:bodyPr>
+          <a:lstStyle/>
+          <a:p>
+            <a:r>
+              <a:rPr sz="1500" i="1">
+                <a:solidFill>
+                  <a:srgbClr val="1A1A2E"/>
+                </a:solidFill>
+                <a:latin typeface="Cambria"/>
+              </a:rPr>
+              <a:t>min</a:t>
+            </a:r>
+            <a:r>
+              <a:rPr sz="1000" i="1" baseline="-25000">
+                <a:solidFill>
+                  <a:srgbClr val="1A1A2E"/>
+                </a:solidFill>
+                <a:latin typeface="Cambria"/>
+              </a:rPr>
+              <a:t>θₖ</a:t>
+            </a:r>
+            <a:r>
+              <a:rPr sz="1500" i="1">
+                <a:solidFill>
+                  <a:srgbClr val="1A1A2E"/>
+                </a:solidFill>
+                <a:latin typeface="Cambria"/>
+              </a:rPr>
+              <a:t> ‖ x</a:t>
+            </a:r>
+            <a:r>
+              <a:rPr sz="1000" i="1" baseline="30000">
+                <a:solidFill>
+                  <a:srgbClr val="1A1A2E"/>
+                </a:solidFill>
+                <a:latin typeface="Cambria"/>
+              </a:rPr>
+              <a:t>(k)</a:t>
+            </a:r>
+            <a:r>
+              <a:rPr sz="1500" i="1">
+                <a:solidFill>
+                  <a:srgbClr val="1A1A2E"/>
+                </a:solidFill>
+                <a:latin typeface="Cambria"/>
+              </a:rPr>
+              <a:t> − x</a:t>
+            </a:r>
+            <a:r>
+              <a:rPr sz="1000" i="1" baseline="30000">
+                <a:solidFill>
+                  <a:srgbClr val="1A1A2E"/>
+                </a:solidFill>
+                <a:latin typeface="Cambria"/>
+              </a:rPr>
+              <a:t>*</a:t>
+            </a:r>
+            <a:r>
+              <a:rPr sz="1500" i="1">
+                <a:solidFill>
+                  <a:srgbClr val="1A1A2E"/>
+                </a:solidFill>
+                <a:latin typeface="Cambria"/>
+              </a:rPr>
+              <a:t> ‖</a:t>
+            </a:r>
+            <a:r>
+              <a:rPr sz="1000" i="1" baseline="30000">
+                <a:solidFill>
+                  <a:srgbClr val="1A1A2E"/>
+                </a:solidFill>
+                <a:latin typeface="Cambria"/>
+              </a:rPr>
+              <a:t>2</a:t>
+            </a:r>
+          </a:p>
+        </p:txBody>
+      </p:sp>
       <p:sp>
         <p:nvSpPr>
           <p:cNvPr id="19" name="TextBox 18"/>

</xml_diff>

<commit_message>
Uniform 20pt centered equations across all slides
- all native-text equations share one size and are horizontally centered
  in their column/card
- slide 9 loss formulas enlarged (15->20pt); L2 display simplified to
  the weighted per-layer sum (full form remains in the report)

Co-Authored-By: Claude Fable 5 <noreply@anthropic.com>
</commit_message>
<xml_diff>
--- a/submission/MBDL_Seminar_Presentation.pptx
+++ b/submission/MBDL_Seminar_Presentation.pptx
@@ -13794,8 +13794,8 @@
         </p:nvSpPr>
         <p:spPr>
           <a:xfrm>
-            <a:off x="685800" y="4434840"/>
-            <a:ext cx="5486400" cy="411480"/>
+            <a:off x="502920" y="4434840"/>
+            <a:ext cx="5943600" cy="411480"/>
           </a:xfrm>
           <a:prstGeom prst="rect">
             <a:avLst/>
@@ -13808,6 +13808,7 @@
           </a:bodyPr>
           <a:lstStyle/>
           <a:p>
+            <a:pPr algn="ctr"/>
             <a:r>
               <a:rPr sz="2000" i="1">
                 <a:solidFill>
@@ -13995,8 +13996,8 @@
         </p:nvSpPr>
         <p:spPr>
           <a:xfrm>
-            <a:off x="7132320" y="1801368"/>
-            <a:ext cx="3657600" cy="411480"/>
+            <a:off x="6858000" y="1801368"/>
+            <a:ext cx="4663440" cy="411480"/>
           </a:xfrm>
           <a:prstGeom prst="rect">
             <a:avLst/>
@@ -14009,6 +14010,7 @@
           </a:bodyPr>
           <a:lstStyle/>
           <a:p>
+            <a:pPr algn="ctr"/>
             <a:r>
               <a:rPr sz="2400" i="1">
                 <a:solidFill>
@@ -14551,8 +14553,8 @@
         </p:nvSpPr>
         <p:spPr>
           <a:xfrm>
-            <a:off x="822960" y="1572768"/>
-            <a:ext cx="10515600" cy="411480"/>
+            <a:off x="502920" y="1572768"/>
+            <a:ext cx="11185855" cy="411480"/>
           </a:xfrm>
           <a:prstGeom prst="rect">
             <a:avLst/>
@@ -14565,6 +14567,7 @@
           </a:bodyPr>
           <a:lstStyle/>
           <a:p>
+            <a:pPr algn="ctr"/>
             <a:r>
               <a:rPr sz="2000" i="1">
                 <a:solidFill>
@@ -14737,8 +14740,8 @@
         </p:nvSpPr>
         <p:spPr>
           <a:xfrm>
-            <a:off x="822960" y="2715768"/>
-            <a:ext cx="10972800" cy="411480"/>
+            <a:off x="502920" y="2715768"/>
+            <a:ext cx="11185855" cy="411480"/>
           </a:xfrm>
           <a:prstGeom prst="rect">
             <a:avLst/>
@@ -14751,6 +14754,7 @@
           </a:bodyPr>
           <a:lstStyle/>
           <a:p>
+            <a:pPr algn="ctr"/>
             <a:r>
               <a:rPr sz="2000" i="1">
                 <a:solidFill>
@@ -15810,8 +15814,8 @@
         </p:nvSpPr>
         <p:spPr>
           <a:xfrm>
-            <a:off x="731520" y="2331720"/>
-            <a:ext cx="5120640" cy="411480"/>
+            <a:off x="502920" y="2331720"/>
+            <a:ext cx="5478627" cy="411480"/>
           </a:xfrm>
           <a:prstGeom prst="rect">
             <a:avLst/>
@@ -15824,8 +15828,9 @@
           </a:bodyPr>
           <a:lstStyle/>
           <a:p>
-            <a:r>
-              <a:rPr sz="1900" i="1">
+            <a:pPr algn="ctr"/>
+            <a:r>
+              <a:rPr sz="2000" i="1">
                 <a:solidFill>
                   <a:srgbClr val="1A1A2E"/>
                 </a:solidFill>
@@ -15834,7 +15839,7 @@
               <a:t>z</a:t>
             </a:r>
             <a:r>
-              <a:rPr sz="1300" i="1" baseline="30000">
+              <a:rPr sz="1400" i="1" baseline="30000">
                 <a:solidFill>
                   <a:srgbClr val="1A1A2E"/>
                 </a:solidFill>
@@ -15843,7 +15848,7 @@
               <a:t>(k)</a:t>
             </a:r>
             <a:r>
-              <a:rPr sz="1900" i="1">
+              <a:rPr sz="2000" i="1">
                 <a:solidFill>
                   <a:srgbClr val="1A1A2E"/>
                 </a:solidFill>
@@ -15852,7 +15857,7 @@
               <a:t> = x</a:t>
             </a:r>
             <a:r>
-              <a:rPr sz="1300" i="1" baseline="30000">
+              <a:rPr sz="1400" i="1" baseline="30000">
                 <a:solidFill>
                   <a:srgbClr val="1A1A2E"/>
                 </a:solidFill>
@@ -15861,7 +15866,7 @@
               <a:t>(k)</a:t>
             </a:r>
             <a:r>
-              <a:rPr sz="1900" i="1">
+              <a:rPr sz="2000" i="1">
                 <a:solidFill>
                   <a:srgbClr val="1A1A2E"/>
                 </a:solidFill>
@@ -15870,7 +15875,7 @@
               <a:t> + (1/L) A</a:t>
             </a:r>
             <a:r>
-              <a:rPr sz="1300" i="1" baseline="30000">
+              <a:rPr sz="1400" i="1" baseline="30000">
                 <a:solidFill>
                   <a:srgbClr val="1A1A2E"/>
                 </a:solidFill>
@@ -15879,7 +15884,7 @@
               <a:t>T</a:t>
             </a:r>
             <a:r>
-              <a:rPr sz="1900" i="1">
+              <a:rPr sz="2000" i="1">
                 <a:solidFill>
                   <a:srgbClr val="1A1A2E"/>
                 </a:solidFill>
@@ -15888,7 +15893,7 @@
               <a:t>( b − A x</a:t>
             </a:r>
             <a:r>
-              <a:rPr sz="1300" i="1" baseline="30000">
+              <a:rPr sz="1400" i="1" baseline="30000">
                 <a:solidFill>
                   <a:srgbClr val="1A1A2E"/>
                 </a:solidFill>
@@ -15897,7 +15902,7 @@
               <a:t>(k)</a:t>
             </a:r>
             <a:r>
-              <a:rPr sz="1900" i="1">
+              <a:rPr sz="2000" i="1">
                 <a:solidFill>
                   <a:srgbClr val="1A1A2E"/>
                 </a:solidFill>
@@ -15916,8 +15921,8 @@
         </p:nvSpPr>
         <p:spPr>
           <a:xfrm>
-            <a:off x="731520" y="2971800"/>
-            <a:ext cx="3657600" cy="411480"/>
+            <a:off x="502920" y="2971800"/>
+            <a:ext cx="5478627" cy="411480"/>
           </a:xfrm>
           <a:prstGeom prst="rect">
             <a:avLst/>
@@ -15930,8 +15935,9 @@
           </a:bodyPr>
           <a:lstStyle/>
           <a:p>
-            <a:r>
-              <a:rPr sz="1900" i="1">
+            <a:pPr algn="ctr"/>
+            <a:r>
+              <a:rPr sz="2000" i="1">
                 <a:solidFill>
                   <a:srgbClr val="1A1A2E"/>
                 </a:solidFill>
@@ -15940,7 +15946,7 @@
               <a:t>x</a:t>
             </a:r>
             <a:r>
-              <a:rPr sz="1300" i="1" baseline="30000">
+              <a:rPr sz="1400" i="1" baseline="30000">
                 <a:solidFill>
                   <a:srgbClr val="1A1A2E"/>
                 </a:solidFill>
@@ -15949,7 +15955,7 @@
               <a:t>(k+1)</a:t>
             </a:r>
             <a:r>
-              <a:rPr sz="1900" i="1">
+              <a:rPr sz="2000" i="1">
                 <a:solidFill>
                   <a:srgbClr val="1A1A2E"/>
                 </a:solidFill>
@@ -15958,7 +15964,7 @@
               <a:t> = S</a:t>
             </a:r>
             <a:r>
-              <a:rPr sz="1300" i="1" baseline="-25000">
+              <a:rPr sz="1400" i="1" baseline="-25000">
                 <a:solidFill>
                   <a:srgbClr val="1A1A2E"/>
                 </a:solidFill>
@@ -15967,7 +15973,7 @@
               <a:t>θ</a:t>
             </a:r>
             <a:r>
-              <a:rPr sz="1900" i="1">
+              <a:rPr sz="2000" i="1">
                 <a:solidFill>
                   <a:srgbClr val="1A1A2E"/>
                 </a:solidFill>
@@ -15976,7 +15982,7 @@
               <a:t>( z</a:t>
             </a:r>
             <a:r>
-              <a:rPr sz="1300" i="1" baseline="30000">
+              <a:rPr sz="1400" i="1" baseline="30000">
                 <a:solidFill>
                   <a:srgbClr val="1A1A2E"/>
                 </a:solidFill>
@@ -15985,7 +15991,7 @@
               <a:t>(k)</a:t>
             </a:r>
             <a:r>
-              <a:rPr sz="1900" i="1">
+              <a:rPr sz="2000" i="1">
                 <a:solidFill>
                   <a:srgbClr val="1A1A2E"/>
                 </a:solidFill>
@@ -16197,8 +16203,8 @@
         </p:nvSpPr>
         <p:spPr>
           <a:xfrm>
-            <a:off x="6438747" y="2331720"/>
-            <a:ext cx="4572000" cy="411480"/>
+            <a:off x="6210147" y="2331720"/>
+            <a:ext cx="5478627" cy="411480"/>
           </a:xfrm>
           <a:prstGeom prst="rect">
             <a:avLst/>
@@ -16211,8 +16217,9 @@
           </a:bodyPr>
           <a:lstStyle/>
           <a:p>
-            <a:r>
-              <a:rPr sz="1900" i="1">
+            <a:pPr algn="ctr"/>
+            <a:r>
+              <a:rPr sz="2000" i="1">
                 <a:solidFill>
                   <a:srgbClr val="1A1A2E"/>
                 </a:solidFill>
@@ -16221,7 +16228,7 @@
               <a:t>z</a:t>
             </a:r>
             <a:r>
-              <a:rPr sz="1300" i="1" baseline="30000">
+              <a:rPr sz="1400" i="1" baseline="30000">
                 <a:solidFill>
                   <a:srgbClr val="1A1A2E"/>
                 </a:solidFill>
@@ -16230,7 +16237,7 @@
               <a:t>(k)</a:t>
             </a:r>
             <a:r>
-              <a:rPr sz="1900" i="1">
+              <a:rPr sz="2000" i="1">
                 <a:solidFill>
                   <a:srgbClr val="1A1A2E"/>
                 </a:solidFill>
@@ -16239,7 +16246,7 @@
               <a:t> = W</a:t>
             </a:r>
             <a:r>
-              <a:rPr sz="1300" i="1" baseline="-25000">
+              <a:rPr sz="1400" i="1" baseline="-25000">
                 <a:solidFill>
                   <a:srgbClr val="1A1A2E"/>
                 </a:solidFill>
@@ -16248,7 +16255,7 @@
               <a:t>x</a:t>
             </a:r>
             <a:r>
-              <a:rPr sz="1300" i="1" baseline="30000">
+              <a:rPr sz="1400" i="1" baseline="30000">
                 <a:solidFill>
                   <a:srgbClr val="1A1A2E"/>
                 </a:solidFill>
@@ -16257,7 +16264,7 @@
               <a:t>(k)</a:t>
             </a:r>
             <a:r>
-              <a:rPr sz="1900" i="1">
+              <a:rPr sz="2000" i="1">
                 <a:solidFill>
                   <a:srgbClr val="1A1A2E"/>
                 </a:solidFill>
@@ -16266,7 +16273,7 @@
               <a:t> x</a:t>
             </a:r>
             <a:r>
-              <a:rPr sz="1300" i="1" baseline="30000">
+              <a:rPr sz="1400" i="1" baseline="30000">
                 <a:solidFill>
                   <a:srgbClr val="1A1A2E"/>
                 </a:solidFill>
@@ -16275,7 +16282,7 @@
               <a:t>(k)</a:t>
             </a:r>
             <a:r>
-              <a:rPr sz="1900" i="1">
+              <a:rPr sz="2000" i="1">
                 <a:solidFill>
                   <a:srgbClr val="1A1A2E"/>
                 </a:solidFill>
@@ -16284,7 +16291,7 @@
               <a:t> + W</a:t>
             </a:r>
             <a:r>
-              <a:rPr sz="1300" i="1" baseline="-25000">
+              <a:rPr sz="1400" i="1" baseline="-25000">
                 <a:solidFill>
                   <a:srgbClr val="1A1A2E"/>
                 </a:solidFill>
@@ -16293,7 +16300,7 @@
               <a:t>y</a:t>
             </a:r>
             <a:r>
-              <a:rPr sz="1300" i="1" baseline="30000">
+              <a:rPr sz="1400" i="1" baseline="30000">
                 <a:solidFill>
                   <a:srgbClr val="1A1A2E"/>
                 </a:solidFill>
@@ -16302,7 +16309,7 @@
               <a:t>(k)</a:t>
             </a:r>
             <a:r>
-              <a:rPr sz="1900" i="1">
+              <a:rPr sz="2000" i="1">
                 <a:solidFill>
                   <a:srgbClr val="1A1A2E"/>
                 </a:solidFill>
@@ -16321,8 +16328,8 @@
         </p:nvSpPr>
         <p:spPr>
           <a:xfrm>
-            <a:off x="6438747" y="2971800"/>
-            <a:ext cx="3657600" cy="411480"/>
+            <a:off x="6210147" y="2971800"/>
+            <a:ext cx="5478627" cy="411480"/>
           </a:xfrm>
           <a:prstGeom prst="rect">
             <a:avLst/>
@@ -16335,8 +16342,9 @@
           </a:bodyPr>
           <a:lstStyle/>
           <a:p>
-            <a:r>
-              <a:rPr sz="1900" i="1">
+            <a:pPr algn="ctr"/>
+            <a:r>
+              <a:rPr sz="2000" i="1">
                 <a:solidFill>
                   <a:srgbClr val="1A1A2E"/>
                 </a:solidFill>
@@ -16345,7 +16353,7 @@
               <a:t>x</a:t>
             </a:r>
             <a:r>
-              <a:rPr sz="1300" i="1" baseline="30000">
+              <a:rPr sz="1400" i="1" baseline="30000">
                 <a:solidFill>
                   <a:srgbClr val="1A1A2E"/>
                 </a:solidFill>
@@ -16354,7 +16362,7 @@
               <a:t>(k+1)</a:t>
             </a:r>
             <a:r>
-              <a:rPr sz="1900" i="1">
+              <a:rPr sz="2000" i="1">
                 <a:solidFill>
                   <a:srgbClr val="1A1A2E"/>
                 </a:solidFill>
@@ -16363,7 +16371,7 @@
               <a:t> = S</a:t>
             </a:r>
             <a:r>
-              <a:rPr sz="1300" i="1" baseline="-25000">
+              <a:rPr sz="1400" i="1" baseline="-25000">
                 <a:solidFill>
                   <a:srgbClr val="1A1A2E"/>
                 </a:solidFill>
@@ -16372,7 +16380,7 @@
               <a:t>θₖ</a:t>
             </a:r>
             <a:r>
-              <a:rPr sz="1900" i="1">
+              <a:rPr sz="2000" i="1">
                 <a:solidFill>
                   <a:srgbClr val="1A1A2E"/>
                 </a:solidFill>
@@ -16381,7 +16389,7 @@
               <a:t>( z</a:t>
             </a:r>
             <a:r>
-              <a:rPr sz="1300" i="1" baseline="30000">
+              <a:rPr sz="1400" i="1" baseline="30000">
                 <a:solidFill>
                   <a:srgbClr val="1A1A2E"/>
                 </a:solidFill>
@@ -16390,7 +16398,7 @@
               <a:t>(k)</a:t>
             </a:r>
             <a:r>
-              <a:rPr sz="1900" i="1">
+              <a:rPr sz="2000" i="1">
                 <a:solidFill>
                   <a:srgbClr val="1A1A2E"/>
                 </a:solidFill>
@@ -16956,8 +16964,8 @@
         </p:nvSpPr>
         <p:spPr>
           <a:xfrm>
-            <a:off x="731520" y="1572768"/>
-            <a:ext cx="6400800" cy="411480"/>
+            <a:off x="502920" y="1572768"/>
+            <a:ext cx="6705295" cy="411480"/>
           </a:xfrm>
           <a:prstGeom prst="rect">
             <a:avLst/>
@@ -16970,6 +16978,7 @@
           </a:bodyPr>
           <a:lstStyle/>
           <a:p>
+            <a:pPr algn="ctr"/>
             <a:r>
               <a:rPr sz="2000" i="1">
                 <a:solidFill>
@@ -17133,8 +17142,8 @@
         </p:nvSpPr>
         <p:spPr>
           <a:xfrm>
-            <a:off x="731520" y="2715768"/>
-            <a:ext cx="5943600" cy="411480"/>
+            <a:off x="502920" y="2715768"/>
+            <a:ext cx="6705295" cy="411480"/>
           </a:xfrm>
           <a:prstGeom prst="rect">
             <a:avLst/>
@@ -17147,8 +17156,9 @@
           </a:bodyPr>
           <a:lstStyle/>
           <a:p>
-            <a:r>
-              <a:rPr sz="1800" i="1">
+            <a:pPr algn="ctr"/>
+            <a:r>
+              <a:rPr sz="2000" i="1">
                 <a:solidFill>
                   <a:srgbClr val="1A1A2E"/>
                 </a:solidFill>
@@ -17157,7 +17167,7 @@
               <a:t>W</a:t>
             </a:r>
             <a:r>
-              <a:rPr sz="1200" i="1" baseline="30000">
+              <a:rPr sz="1400" i="1" baseline="30000">
                 <a:solidFill>
                   <a:srgbClr val="1A1A2E"/>
                 </a:solidFill>
@@ -17166,7 +17176,7 @@
               <a:t>*</a:t>
             </a:r>
             <a:r>
-              <a:rPr sz="1800" i="1">
+              <a:rPr sz="2000" i="1">
                 <a:solidFill>
                   <a:srgbClr val="1A1A2E"/>
                 </a:solidFill>
@@ -17175,7 +17185,7 @@
               <a:t> = ( A A</a:t>
             </a:r>
             <a:r>
-              <a:rPr sz="1200" i="1" baseline="30000">
+              <a:rPr sz="1400" i="1" baseline="30000">
                 <a:solidFill>
                   <a:srgbClr val="1A1A2E"/>
                 </a:solidFill>
@@ -17184,7 +17194,7 @@
               <a:t>T</a:t>
             </a:r>
             <a:r>
-              <a:rPr sz="1800" i="1">
+              <a:rPr sz="2000" i="1">
                 <a:solidFill>
                   <a:srgbClr val="1A1A2E"/>
                 </a:solidFill>
@@ -17193,7 +17203,7 @@
               <a:t> )</a:t>
             </a:r>
             <a:r>
-              <a:rPr sz="1200" i="1" baseline="30000">
+              <a:rPr sz="1400" i="1" baseline="30000">
                 <a:solidFill>
                   <a:srgbClr val="1A1A2E"/>
                 </a:solidFill>
@@ -17202,7 +17212,7 @@
               <a:t>−1</a:t>
             </a:r>
             <a:r>
-              <a:rPr sz="1800" i="1">
+              <a:rPr sz="2000" i="1">
                 <a:solidFill>
                   <a:srgbClr val="1A1A2E"/>
                 </a:solidFill>
@@ -17221,8 +17231,8 @@
         </p:nvSpPr>
         <p:spPr>
           <a:xfrm>
-            <a:off x="731520" y="3145536"/>
-            <a:ext cx="6858000" cy="411480"/>
+            <a:off x="502920" y="3145536"/>
+            <a:ext cx="6705295" cy="411480"/>
           </a:xfrm>
           <a:prstGeom prst="rect">
             <a:avLst/>
@@ -17235,8 +17245,9 @@
           </a:bodyPr>
           <a:lstStyle/>
           <a:p>
-            <a:r>
-              <a:rPr sz="1800" i="1">
+            <a:pPr algn="ctr"/>
+            <a:r>
+              <a:rPr sz="2000" i="1">
                 <a:solidFill>
                   <a:srgbClr val="1A1A2E"/>
                 </a:solidFill>
@@ -17245,7 +17256,7 @@
               <a:t>x</a:t>
             </a:r>
             <a:r>
-              <a:rPr sz="1200" i="1" baseline="30000">
+              <a:rPr sz="1400" i="1" baseline="30000">
                 <a:solidFill>
                   <a:srgbClr val="1A1A2E"/>
                 </a:solidFill>
@@ -17254,7 +17265,7 @@
               <a:t>(k+1)</a:t>
             </a:r>
             <a:r>
-              <a:rPr sz="1800" i="1">
+              <a:rPr sz="2000" i="1">
                 <a:solidFill>
                   <a:srgbClr val="1A1A2E"/>
                 </a:solidFill>
@@ -17263,7 +17274,7 @@
               <a:t> = S</a:t>
             </a:r>
             <a:r>
-              <a:rPr sz="1200" i="1" baseline="-25000">
+              <a:rPr sz="1400" i="1" baseline="-25000">
                 <a:solidFill>
                   <a:srgbClr val="1A1A2E"/>
                 </a:solidFill>
@@ -17272,7 +17283,7 @@
               <a:t>θₖ</a:t>
             </a:r>
             <a:r>
-              <a:rPr sz="1800" i="1">
+              <a:rPr sz="2000" i="1">
                 <a:solidFill>
                   <a:srgbClr val="1A1A2E"/>
                 </a:solidFill>
@@ -17281,7 +17292,7 @@
               <a:t>( x</a:t>
             </a:r>
             <a:r>
-              <a:rPr sz="1200" i="1" baseline="30000">
+              <a:rPr sz="1400" i="1" baseline="30000">
                 <a:solidFill>
                   <a:srgbClr val="1A1A2E"/>
                 </a:solidFill>
@@ -17290,7 +17301,7 @@
               <a:t>(k)</a:t>
             </a:r>
             <a:r>
-              <a:rPr sz="1800" i="1">
+              <a:rPr sz="2000" i="1">
                 <a:solidFill>
                   <a:srgbClr val="1A1A2E"/>
                 </a:solidFill>
@@ -17299,7 +17310,7 @@
               <a:t> + γ</a:t>
             </a:r>
             <a:r>
-              <a:rPr sz="1200" i="1" baseline="-25000">
+              <a:rPr sz="1400" i="1" baseline="-25000">
                 <a:solidFill>
                   <a:srgbClr val="1A1A2E"/>
                 </a:solidFill>
@@ -17308,7 +17319,7 @@
               <a:t>k</a:t>
             </a:r>
             <a:r>
-              <a:rPr sz="1800" i="1">
+              <a:rPr sz="2000" i="1">
                 <a:solidFill>
                   <a:srgbClr val="1A1A2E"/>
                 </a:solidFill>
@@ -17317,7 +17328,7 @@
               <a:t> W</a:t>
             </a:r>
             <a:r>
-              <a:rPr sz="1200" i="1" baseline="30000">
+              <a:rPr sz="1400" i="1" baseline="30000">
                 <a:solidFill>
                   <a:srgbClr val="1A1A2E"/>
                 </a:solidFill>
@@ -17326,7 +17337,7 @@
               <a:t>*T</a:t>
             </a:r>
             <a:r>
-              <a:rPr sz="1800" i="1">
+              <a:rPr sz="2000" i="1">
                 <a:solidFill>
                   <a:srgbClr val="1A1A2E"/>
                 </a:solidFill>
@@ -17335,7 +17346,7 @@
               <a:t>( b − A x</a:t>
             </a:r>
             <a:r>
-              <a:rPr sz="1200" i="1" baseline="30000">
+              <a:rPr sz="1400" i="1" baseline="30000">
                 <a:solidFill>
                   <a:srgbClr val="1A1A2E"/>
                 </a:solidFill>
@@ -17344,7 +17355,7 @@
               <a:t>(k)</a:t>
             </a:r>
             <a:r>
-              <a:rPr sz="1800" i="1">
+              <a:rPr sz="2000" i="1">
                 <a:solidFill>
                   <a:srgbClr val="1A1A2E"/>
                 </a:solidFill>
@@ -17398,8 +17409,8 @@
         </p:nvSpPr>
         <p:spPr>
           <a:xfrm>
-            <a:off x="731520" y="4407408"/>
-            <a:ext cx="6583680" cy="411480"/>
+            <a:off x="502920" y="4407408"/>
+            <a:ext cx="6705295" cy="411480"/>
           </a:xfrm>
           <a:prstGeom prst="rect">
             <a:avLst/>
@@ -17412,8 +17423,9 @@
           </a:bodyPr>
           <a:lstStyle/>
           <a:p>
-            <a:r>
-              <a:rPr sz="1600" i="1">
+            <a:pPr algn="ctr"/>
+            <a:r>
+              <a:rPr sz="2000" i="1">
                 <a:solidFill>
                   <a:srgbClr val="1A1A2E"/>
                 </a:solidFill>
@@ -17422,7 +17434,7 @@
               <a:t>θ</a:t>
             </a:r>
             <a:r>
-              <a:rPr sz="1100" i="1" baseline="30000">
+              <a:rPr sz="1400" i="1" baseline="30000">
                 <a:solidFill>
                   <a:srgbClr val="1A1A2E"/>
                 </a:solidFill>
@@ -17431,7 +17443,7 @@
               <a:t>(k)</a:t>
             </a:r>
             <a:r>
-              <a:rPr sz="1600" i="1">
+              <a:rPr sz="2000" i="1">
                 <a:solidFill>
                   <a:srgbClr val="1A1A2E"/>
                 </a:solidFill>
@@ -17440,7 +17452,7 @@
               <a:t> = c</a:t>
             </a:r>
             <a:r>
-              <a:rPr sz="1100" i="1" baseline="-25000">
+              <a:rPr sz="1400" i="1" baseline="-25000">
                 <a:solidFill>
                   <a:srgbClr val="1A1A2E"/>
                 </a:solidFill>
@@ -17449,7 +17461,7 @@
               <a:t>1</a:t>
             </a:r>
             <a:r>
-              <a:rPr sz="1600" i="1">
+              <a:rPr sz="2000" i="1">
                 <a:solidFill>
                   <a:srgbClr val="1A1A2E"/>
                 </a:solidFill>
@@ -17458,7 +17470,7 @@
               <a:t> μ ‖ A</a:t>
             </a:r>
             <a:r>
-              <a:rPr sz="1100" i="1" baseline="30000">
+              <a:rPr sz="1400" i="1" baseline="30000">
                 <a:solidFill>
                   <a:srgbClr val="1A1A2E"/>
                 </a:solidFill>
@@ -17467,7 +17479,7 @@
               <a:t>+</a:t>
             </a:r>
             <a:r>
-              <a:rPr sz="1600" i="1">
+              <a:rPr sz="2000" i="1">
                 <a:solidFill>
                   <a:srgbClr val="1A1A2E"/>
                 </a:solidFill>
@@ -17476,7 +17488,7 @@
               <a:t>( A x</a:t>
             </a:r>
             <a:r>
-              <a:rPr sz="1100" i="1" baseline="30000">
+              <a:rPr sz="1400" i="1" baseline="30000">
                 <a:solidFill>
                   <a:srgbClr val="1A1A2E"/>
                 </a:solidFill>
@@ -17485,7 +17497,7 @@
               <a:t>(k)</a:t>
             </a:r>
             <a:r>
-              <a:rPr sz="1600" i="1">
+              <a:rPr sz="2000" i="1">
                 <a:solidFill>
                   <a:srgbClr val="1A1A2E"/>
                 </a:solidFill>
@@ -17494,7 +17506,7 @@
               <a:t> − b ) ‖</a:t>
             </a:r>
             <a:r>
-              <a:rPr sz="1100" i="1" baseline="-25000">
+              <a:rPr sz="1400" i="1" baseline="-25000">
                 <a:solidFill>
                   <a:srgbClr val="1A1A2E"/>
                 </a:solidFill>
@@ -17503,7 +17515,7 @@
               <a:t>1</a:t>
             </a:r>
             <a:r>
-              <a:rPr sz="1600" i="1">
+              <a:rPr sz="2000" i="1">
                 <a:solidFill>
                   <a:srgbClr val="1A1A2E"/>
                 </a:solidFill>
@@ -17512,7 +17524,7 @@
               <a:t> ,     β</a:t>
             </a:r>
             <a:r>
-              <a:rPr sz="1100" i="1" baseline="30000">
+              <a:rPr sz="1400" i="1" baseline="30000">
                 <a:solidFill>
                   <a:srgbClr val="1A1A2E"/>
                 </a:solidFill>
@@ -17521,7 +17533,7 @@
               <a:t>(k)</a:t>
             </a:r>
             <a:r>
-              <a:rPr sz="1600" i="1">
+              <a:rPr sz="2000" i="1">
                 <a:solidFill>
                   <a:srgbClr val="1A1A2E"/>
                 </a:solidFill>
@@ -17530,7 +17542,7 @@
               <a:t> = c</a:t>
             </a:r>
             <a:r>
-              <a:rPr sz="1100" i="1" baseline="-25000">
+              <a:rPr sz="1400" i="1" baseline="-25000">
                 <a:solidFill>
                   <a:srgbClr val="1A1A2E"/>
                 </a:solidFill>
@@ -17539,7 +17551,7 @@
               <a:t>2</a:t>
             </a:r>
             <a:r>
-              <a:rPr sz="1600" i="1">
+              <a:rPr sz="2000" i="1">
                 <a:solidFill>
                   <a:srgbClr val="1A1A2E"/>
                 </a:solidFill>
@@ -17548,7 +17560,7 @@
               <a:t> μ ‖ x</a:t>
             </a:r>
             <a:r>
-              <a:rPr sz="1100" i="1" baseline="30000">
+              <a:rPr sz="1400" i="1" baseline="30000">
                 <a:solidFill>
                   <a:srgbClr val="1A1A2E"/>
                 </a:solidFill>
@@ -17557,7 +17569,7 @@
               <a:t>(k)</a:t>
             </a:r>
             <a:r>
-              <a:rPr sz="1600" i="1">
+              <a:rPr sz="2000" i="1">
                 <a:solidFill>
                   <a:srgbClr val="1A1A2E"/>
                 </a:solidFill>
@@ -17566,7 +17578,7 @@
               <a:t> ‖</a:t>
             </a:r>
             <a:r>
-              <a:rPr sz="1100" i="1" baseline="-25000">
+              <a:rPr sz="1400" i="1" baseline="-25000">
                 <a:solidFill>
                   <a:srgbClr val="1A1A2E"/>
                 </a:solidFill>
@@ -17585,8 +17597,8 @@
         </p:nvSpPr>
         <p:spPr>
           <a:xfrm>
-            <a:off x="731520" y="4864608"/>
-            <a:ext cx="6583680" cy="411480"/>
+            <a:off x="502920" y="4864608"/>
+            <a:ext cx="6705295" cy="411480"/>
           </a:xfrm>
           <a:prstGeom prst="rect">
             <a:avLst/>
@@ -17599,8 +17611,9 @@
           </a:bodyPr>
           <a:lstStyle/>
           <a:p>
-            <a:r>
-              <a:rPr sz="1600" i="1">
+            <a:pPr algn="ctr"/>
+            <a:r>
+              <a:rPr sz="2000" i="1">
                 <a:solidFill>
                   <a:srgbClr val="1A1A2E"/>
                 </a:solidFill>
@@ -17609,7 +17622,7 @@
               <a:t>p</a:t>
             </a:r>
             <a:r>
-              <a:rPr sz="1100" i="1" baseline="30000">
+              <a:rPr sz="1400" i="1" baseline="30000">
                 <a:solidFill>
                   <a:srgbClr val="1A1A2E"/>
                 </a:solidFill>
@@ -17618,7 +17631,7 @@
               <a:t>(k)</a:t>
             </a:r>
             <a:r>
-              <a:rPr sz="1600" i="1">
+              <a:rPr sz="2000" i="1">
                 <a:solidFill>
                   <a:srgbClr val="1A1A2E"/>
                 </a:solidFill>
@@ -17627,7 +17640,7 @@
               <a:t> = c</a:t>
             </a:r>
             <a:r>
-              <a:rPr sz="1100" i="1" baseline="-25000">
+              <a:rPr sz="1400" i="1" baseline="-25000">
                 <a:solidFill>
                   <a:srgbClr val="1A1A2E"/>
                 </a:solidFill>
@@ -17636,7 +17649,7 @@
               <a:t>3</a:t>
             </a:r>
             <a:r>
-              <a:rPr sz="1600" i="1">
+              <a:rPr sz="2000" i="1">
                 <a:solidFill>
                   <a:srgbClr val="1A1A2E"/>
                 </a:solidFill>
@@ -17645,7 +17658,7 @@
               <a:t> log (  ‖ A</a:t>
             </a:r>
             <a:r>
-              <a:rPr sz="1100" i="1" baseline="30000">
+              <a:rPr sz="1400" i="1" baseline="30000">
                 <a:solidFill>
                   <a:srgbClr val="1A1A2E"/>
                 </a:solidFill>
@@ -17654,7 +17667,7 @@
               <a:t>+</a:t>
             </a:r>
             <a:r>
-              <a:rPr sz="1600" i="1">
+              <a:rPr sz="2000" i="1">
                 <a:solidFill>
                   <a:srgbClr val="1A1A2E"/>
                 </a:solidFill>
@@ -17663,7 +17676,7 @@
               <a:t> b ‖</a:t>
             </a:r>
             <a:r>
-              <a:rPr sz="1100" i="1" baseline="-25000">
+              <a:rPr sz="1400" i="1" baseline="-25000">
                 <a:solidFill>
                   <a:srgbClr val="1A1A2E"/>
                 </a:solidFill>
@@ -17672,7 +17685,7 @@
               <a:t>1</a:t>
             </a:r>
             <a:r>
-              <a:rPr sz="1600" i="1">
+              <a:rPr sz="2000" i="1">
                 <a:solidFill>
                   <a:srgbClr val="1A1A2E"/>
                 </a:solidFill>
@@ -17681,7 +17694,7 @@
               <a:t>  /  ‖ A</a:t>
             </a:r>
             <a:r>
-              <a:rPr sz="1100" i="1" baseline="30000">
+              <a:rPr sz="1400" i="1" baseline="30000">
                 <a:solidFill>
                   <a:srgbClr val="1A1A2E"/>
                 </a:solidFill>
@@ -17690,7 +17703,7 @@
               <a:t>+</a:t>
             </a:r>
             <a:r>
-              <a:rPr sz="1600" i="1">
+              <a:rPr sz="2000" i="1">
                 <a:solidFill>
                   <a:srgbClr val="1A1A2E"/>
                 </a:solidFill>
@@ -17699,7 +17712,7 @@
               <a:t>( A x</a:t>
             </a:r>
             <a:r>
-              <a:rPr sz="1100" i="1" baseline="30000">
+              <a:rPr sz="1400" i="1" baseline="30000">
                 <a:solidFill>
                   <a:srgbClr val="1A1A2E"/>
                 </a:solidFill>
@@ -17708,7 +17721,7 @@
               <a:t>(k)</a:t>
             </a:r>
             <a:r>
-              <a:rPr sz="1600" i="1">
+              <a:rPr sz="2000" i="1">
                 <a:solidFill>
                   <a:srgbClr val="1A1A2E"/>
                 </a:solidFill>
@@ -17717,7 +17730,7 @@
               <a:t> − b ) ‖</a:t>
             </a:r>
             <a:r>
-              <a:rPr sz="1100" i="1" baseline="-25000">
+              <a:rPr sz="1400" i="1" baseline="-25000">
                 <a:solidFill>
                   <a:srgbClr val="1A1A2E"/>
                 </a:solidFill>
@@ -17726,7 +17739,7 @@
               <a:t>1</a:t>
             </a:r>
             <a:r>
-              <a:rPr sz="1600" i="1">
+              <a:rPr sz="2000" i="1">
                 <a:solidFill>
                   <a:srgbClr val="1A1A2E"/>
                 </a:solidFill>
@@ -18730,8 +18743,8 @@
         </p:nvSpPr>
         <p:spPr>
           <a:xfrm>
-            <a:off x="3291840" y="2084831"/>
-            <a:ext cx="8229600" cy="411480"/>
+            <a:off x="502920" y="2084831"/>
+            <a:ext cx="11185855" cy="411480"/>
           </a:xfrm>
           <a:prstGeom prst="rect">
             <a:avLst/>
@@ -18744,8 +18757,9 @@
           </a:bodyPr>
           <a:lstStyle/>
           <a:p>
-            <a:r>
-              <a:rPr sz="2200" i="1">
+            <a:pPr algn="ctr"/>
+            <a:r>
+              <a:rPr sz="2000" i="1">
                 <a:solidFill>
                   <a:srgbClr val="1A1A2E"/>
                 </a:solidFill>
@@ -18754,7 +18768,7 @@
               <a:t>x</a:t>
             </a:r>
             <a:r>
-              <a:rPr sz="1500" i="1" baseline="30000">
+              <a:rPr sz="1400" i="1" baseline="30000">
                 <a:solidFill>
                   <a:srgbClr val="1A1A2E"/>
                 </a:solidFill>
@@ -18763,7 +18777,7 @@
               <a:t>(k+1)</a:t>
             </a:r>
             <a:r>
-              <a:rPr sz="2200" i="1">
+              <a:rPr sz="2000" i="1">
                 <a:solidFill>
                   <a:srgbClr val="1A1A2E"/>
                 </a:solidFill>
@@ -18772,7 +18786,7 @@
               <a:t> = S</a:t>
             </a:r>
             <a:r>
-              <a:rPr sz="1500" i="1" baseline="-25000">
+              <a:rPr sz="1400" i="1" baseline="-25000">
                 <a:solidFill>
                   <a:srgbClr val="1A1A2E"/>
                 </a:solidFill>
@@ -18781,7 +18795,7 @@
               <a:t>θₖ</a:t>
             </a:r>
             <a:r>
-              <a:rPr sz="2200" i="1">
+              <a:rPr sz="2000" i="1">
                 <a:solidFill>
                   <a:srgbClr val="1A1A2E"/>
                 </a:solidFill>
@@ -18790,7 +18804,7 @@
               <a:t>( x</a:t>
             </a:r>
             <a:r>
-              <a:rPr sz="1500" i="1" baseline="30000">
+              <a:rPr sz="1400" i="1" baseline="30000">
                 <a:solidFill>
                   <a:srgbClr val="1A1A2E"/>
                 </a:solidFill>
@@ -18799,7 +18813,7 @@
               <a:t>(k)</a:t>
             </a:r>
             <a:r>
-              <a:rPr sz="2200" i="1">
+              <a:rPr sz="2000" i="1">
                 <a:solidFill>
                   <a:srgbClr val="1A1A2E"/>
                 </a:solidFill>
@@ -18808,7 +18822,7 @@
               <a:t> + γ</a:t>
             </a:r>
             <a:r>
-              <a:rPr sz="1500" i="1" baseline="-25000">
+              <a:rPr sz="1400" i="1" baseline="-25000">
                 <a:solidFill>
                   <a:srgbClr val="1A1A2E"/>
                 </a:solidFill>
@@ -18817,7 +18831,7 @@
               <a:t>k</a:t>
             </a:r>
             <a:r>
-              <a:rPr sz="2200" i="1">
+              <a:rPr sz="2000" i="1">
                 <a:solidFill>
                   <a:srgbClr val="1A1A2E"/>
                 </a:solidFill>
@@ -18826,7 +18840,7 @@
               <a:t> A</a:t>
             </a:r>
             <a:r>
-              <a:rPr sz="1500" i="1" baseline="30000">
+              <a:rPr sz="1400" i="1" baseline="30000">
                 <a:solidFill>
                   <a:srgbClr val="1A1A2E"/>
                 </a:solidFill>
@@ -18835,7 +18849,7 @@
               <a:t>T</a:t>
             </a:r>
             <a:r>
-              <a:rPr sz="2200" i="1">
+              <a:rPr sz="2000" i="1">
                 <a:solidFill>
                   <a:srgbClr val="1A1A2E"/>
                 </a:solidFill>
@@ -18844,7 +18858,7 @@
               <a:t>( b − A x</a:t>
             </a:r>
             <a:r>
-              <a:rPr sz="1500" i="1" baseline="30000">
+              <a:rPr sz="1400" i="1" baseline="30000">
                 <a:solidFill>
                   <a:srgbClr val="1A1A2E"/>
                 </a:solidFill>
@@ -18853,7 +18867,7 @@
               <a:t>(k)</a:t>
             </a:r>
             <a:r>
-              <a:rPr sz="2200" i="1">
+              <a:rPr sz="2000" i="1">
                 <a:solidFill>
                   <a:srgbClr val="1A1A2E"/>
                 </a:solidFill>
@@ -21048,8 +21062,8 @@
         </p:nvSpPr>
         <p:spPr>
           <a:xfrm>
-            <a:off x="685800" y="2240280"/>
-            <a:ext cx="3286658" cy="411480"/>
+            <a:off x="502920" y="2240280"/>
+            <a:ext cx="3652418" cy="411480"/>
           </a:xfrm>
           <a:prstGeom prst="rect">
             <a:avLst/>
@@ -21062,8 +21076,9 @@
           </a:bodyPr>
           <a:lstStyle/>
           <a:p>
-            <a:r>
-              <a:rPr sz="1500" i="1">
+            <a:pPr algn="ctr"/>
+            <a:r>
+              <a:rPr sz="2000" i="1">
                 <a:solidFill>
                   <a:srgbClr val="1A1A2E"/>
                 </a:solidFill>
@@ -21072,7 +21087,7 @@
               <a:t>L = ‖ x</a:t>
             </a:r>
             <a:r>
-              <a:rPr sz="1000" i="1" baseline="30000">
+              <a:rPr sz="1400" i="1" baseline="30000">
                 <a:solidFill>
                   <a:srgbClr val="1A1A2E"/>
                 </a:solidFill>
@@ -21081,7 +21096,7 @@
               <a:t>(K)</a:t>
             </a:r>
             <a:r>
-              <a:rPr sz="1500" i="1">
+              <a:rPr sz="2000" i="1">
                 <a:solidFill>
                   <a:srgbClr val="1A1A2E"/>
                 </a:solidFill>
@@ -21090,7 +21105,7 @@
               <a:t> − x</a:t>
             </a:r>
             <a:r>
-              <a:rPr sz="1000" i="1" baseline="30000">
+              <a:rPr sz="1400" i="1" baseline="30000">
                 <a:solidFill>
                   <a:srgbClr val="1A1A2E"/>
                 </a:solidFill>
@@ -21099,7 +21114,7 @@
               <a:t>*</a:t>
             </a:r>
             <a:r>
-              <a:rPr sz="1500" i="1">
+              <a:rPr sz="2000" i="1">
                 <a:solidFill>
                   <a:srgbClr val="1A1A2E"/>
                 </a:solidFill>
@@ -21108,7 +21123,7 @@
               <a:t> ‖</a:t>
             </a:r>
             <a:r>
-              <a:rPr sz="1000" i="1" baseline="30000">
+              <a:rPr sz="1400" i="1" baseline="30000">
                 <a:solidFill>
                   <a:srgbClr val="1A1A2E"/>
                 </a:solidFill>
@@ -21243,8 +21258,8 @@
         </p:nvSpPr>
         <p:spPr>
           <a:xfrm>
-            <a:off x="4406798" y="2240280"/>
-            <a:ext cx="3286658" cy="411480"/>
+            <a:off x="4223918" y="2240280"/>
+            <a:ext cx="3652418" cy="411480"/>
           </a:xfrm>
           <a:prstGeom prst="rect">
             <a:avLst/>
@@ -21257,143 +21272,90 @@
           </a:bodyPr>
           <a:lstStyle/>
           <a:p>
-            <a:r>
-              <a:rPr sz="1500" i="1">
+            <a:pPr algn="ctr"/>
+            <a:r>
+              <a:rPr sz="2000" i="1">
                 <a:solidFill>
                   <a:srgbClr val="1A1A2E"/>
                 </a:solidFill>
                 <a:latin typeface="Cambria"/>
               </a:rPr>
-              <a:t>L = ‖x</a:t>
-            </a:r>
-            <a:r>
-              <a:rPr sz="1000" i="1" baseline="30000">
+              <a:t>L = Σ</a:t>
+            </a:r>
+            <a:r>
+              <a:rPr sz="1400" i="1" baseline="-25000">
                 <a:solidFill>
                   <a:srgbClr val="1A1A2E"/>
                 </a:solidFill>
                 <a:latin typeface="Cambria"/>
               </a:rPr>
-              <a:t>(K)</a:t>
-            </a:r>
-            <a:r>
-              <a:rPr sz="1500" i="1">
+              <a:t>k</a:t>
+            </a:r>
+            <a:r>
+              <a:rPr sz="2000" i="1">
                 <a:solidFill>
                   <a:srgbClr val="1A1A2E"/>
                 </a:solidFill>
                 <a:latin typeface="Cambria"/>
               </a:rPr>
-              <a:t>−x</a:t>
-            </a:r>
-            <a:r>
-              <a:rPr sz="1000" i="1" baseline="30000">
+              <a:t> w</a:t>
+            </a:r>
+            <a:r>
+              <a:rPr sz="1400" i="1" baseline="-25000">
                 <a:solidFill>
                   <a:srgbClr val="1A1A2E"/>
                 </a:solidFill>
                 <a:latin typeface="Cambria"/>
               </a:rPr>
+              <a:t>k</a:t>
+            </a:r>
+            <a:r>
+              <a:rPr sz="2000" i="1">
+                <a:solidFill>
+                  <a:srgbClr val="1A1A2E"/>
+                </a:solidFill>
+                <a:latin typeface="Cambria"/>
+              </a:rPr>
+              <a:t> ‖ x</a:t>
+            </a:r>
+            <a:r>
+              <a:rPr sz="1400" i="1" baseline="30000">
+                <a:solidFill>
+                  <a:srgbClr val="1A1A2E"/>
+                </a:solidFill>
+                <a:latin typeface="Cambria"/>
+              </a:rPr>
+              <a:t>(k)</a:t>
+            </a:r>
+            <a:r>
+              <a:rPr sz="2000" i="1">
+                <a:solidFill>
+                  <a:srgbClr val="1A1A2E"/>
+                </a:solidFill>
+                <a:latin typeface="Cambria"/>
+              </a:rPr>
+              <a:t> − x</a:t>
+            </a:r>
+            <a:r>
+              <a:rPr sz="1400" i="1" baseline="30000">
+                <a:solidFill>
+                  <a:srgbClr val="1A1A2E"/>
+                </a:solidFill>
+                <a:latin typeface="Cambria"/>
+              </a:rPr>
               <a:t>*</a:t>
             </a:r>
             <a:r>
-              <a:rPr sz="1500" i="1">
+              <a:rPr sz="2000" i="1">
                 <a:solidFill>
                   <a:srgbClr val="1A1A2E"/>
                 </a:solidFill>
                 <a:latin typeface="Cambria"/>
               </a:rPr>
-              <a:t>‖</a:t>
-            </a:r>
-            <a:r>
-              <a:rPr sz="1000" i="1" baseline="30000">
-                <a:solidFill>
-                  <a:srgbClr val="1A1A2E"/>
-                </a:solidFill>
-                <a:latin typeface="Cambria"/>
-              </a:rPr>
-              <a:t>2</a:t>
-            </a:r>
-            <a:r>
-              <a:rPr sz="1500" i="1">
-                <a:solidFill>
-                  <a:srgbClr val="1A1A2E"/>
-                </a:solidFill>
-                <a:latin typeface="Cambria"/>
-              </a:rPr>
-              <a:t> + λ Σ</a:t>
-            </a:r>
-            <a:r>
-              <a:rPr sz="1000" i="1" baseline="-25000">
-                <a:solidFill>
-                  <a:srgbClr val="1A1A2E"/>
-                </a:solidFill>
-                <a:latin typeface="Cambria"/>
-              </a:rPr>
-              <a:t>k</a:t>
-            </a:r>
-            <a:r>
-              <a:rPr sz="1500" i="1">
-                <a:solidFill>
-                  <a:srgbClr val="1A1A2E"/>
-                </a:solidFill>
-                <a:latin typeface="Cambria"/>
-              </a:rPr>
-              <a:t> w</a:t>
-            </a:r>
-            <a:r>
-              <a:rPr sz="1000" i="1" baseline="-25000">
-                <a:solidFill>
-                  <a:srgbClr val="1A1A2E"/>
-                </a:solidFill>
-                <a:latin typeface="Cambria"/>
-              </a:rPr>
-              <a:t>k</a:t>
-            </a:r>
-            <a:r>
-              <a:rPr sz="1500" i="1">
-                <a:solidFill>
-                  <a:srgbClr val="1A1A2E"/>
-                </a:solidFill>
-                <a:latin typeface="Cambria"/>
-              </a:rPr>
-              <a:t> ‖x</a:t>
-            </a:r>
-            <a:r>
-              <a:rPr sz="1000" i="1" baseline="30000">
-                <a:solidFill>
-                  <a:srgbClr val="1A1A2E"/>
-                </a:solidFill>
-                <a:latin typeface="Cambria"/>
-              </a:rPr>
-              <a:t>(k)</a:t>
-            </a:r>
-            <a:r>
-              <a:rPr sz="1500" i="1">
-                <a:solidFill>
-                  <a:srgbClr val="1A1A2E"/>
-                </a:solidFill>
-                <a:latin typeface="Cambria"/>
-              </a:rPr>
-              <a:t>−x</a:t>
-            </a:r>
-            <a:r>
-              <a:rPr sz="1000" i="1" baseline="30000">
-                <a:solidFill>
-                  <a:srgbClr val="1A1A2E"/>
-                </a:solidFill>
-                <a:latin typeface="Cambria"/>
-              </a:rPr>
-              <a:t>*</a:t>
-            </a:r>
-            <a:r>
-              <a:rPr sz="1500" i="1">
-                <a:solidFill>
-                  <a:srgbClr val="1A1A2E"/>
-                </a:solidFill>
-                <a:latin typeface="Cambria"/>
-              </a:rPr>
-              <a:t>‖</a:t>
-            </a:r>
-            <a:r>
-              <a:rPr sz="1000" i="1" baseline="30000">
+              <a:t> ‖</a:t>
+            </a:r>
+            <a:r>
+              <a:rPr sz="1400" i="1" baseline="30000">
                 <a:solidFill>
                   <a:srgbClr val="1A1A2E"/>
                 </a:solidFill>
@@ -21528,8 +21490,8 @@
         </p:nvSpPr>
         <p:spPr>
           <a:xfrm>
-            <a:off x="8127796" y="2240280"/>
-            <a:ext cx="3286658" cy="411480"/>
+            <a:off x="7944916" y="2240280"/>
+            <a:ext cx="3652418" cy="411480"/>
           </a:xfrm>
           <a:prstGeom prst="rect">
             <a:avLst/>
@@ -21542,8 +21504,9 @@
           </a:bodyPr>
           <a:lstStyle/>
           <a:p>
-            <a:r>
-              <a:rPr sz="1500" i="1">
+            <a:pPr algn="ctr"/>
+            <a:r>
+              <a:rPr sz="2000" i="1">
                 <a:solidFill>
                   <a:srgbClr val="1A1A2E"/>
                 </a:solidFill>
@@ -21552,7 +21515,7 @@
               <a:t>min</a:t>
             </a:r>
             <a:r>
-              <a:rPr sz="1000" i="1" baseline="-25000">
+              <a:rPr sz="1400" i="1" baseline="-25000">
                 <a:solidFill>
                   <a:srgbClr val="1A1A2E"/>
                 </a:solidFill>
@@ -21561,7 +21524,7 @@
               <a:t>θₖ</a:t>
             </a:r>
             <a:r>
-              <a:rPr sz="1500" i="1">
+              <a:rPr sz="2000" i="1">
                 <a:solidFill>
                   <a:srgbClr val="1A1A2E"/>
                 </a:solidFill>
@@ -21570,7 +21533,7 @@
               <a:t> ‖ x</a:t>
             </a:r>
             <a:r>
-              <a:rPr sz="1000" i="1" baseline="30000">
+              <a:rPr sz="1400" i="1" baseline="30000">
                 <a:solidFill>
                   <a:srgbClr val="1A1A2E"/>
                 </a:solidFill>
@@ -21579,7 +21542,7 @@
               <a:t>(k)</a:t>
             </a:r>
             <a:r>
-              <a:rPr sz="1500" i="1">
+              <a:rPr sz="2000" i="1">
                 <a:solidFill>
                   <a:srgbClr val="1A1A2E"/>
                 </a:solidFill>
@@ -21588,7 +21551,7 @@
               <a:t> − x</a:t>
             </a:r>
             <a:r>
-              <a:rPr sz="1000" i="1" baseline="30000">
+              <a:rPr sz="1400" i="1" baseline="30000">
                 <a:solidFill>
                   <a:srgbClr val="1A1A2E"/>
                 </a:solidFill>
@@ -21597,7 +21560,7 @@
               <a:t>*</a:t>
             </a:r>
             <a:r>
-              <a:rPr sz="1500" i="1">
+              <a:rPr sz="2000" i="1">
                 <a:solidFill>
                   <a:srgbClr val="1A1A2E"/>
                 </a:solidFill>
@@ -21606,7 +21569,7 @@
               <a:t> ‖</a:t>
             </a:r>
             <a:r>
-              <a:rPr sz="1000" i="1" baseline="30000">
+              <a:rPr sz="1400" i="1" baseline="30000">
                 <a:solidFill>
                   <a:srgbClr val="1A1A2E"/>
                 </a:solidFill>

</xml_diff>

<commit_message>
Align slide 10 table with its curves; add L1/L2/L3 plot to slide 9
- slide 9 now shows the training-methods NMSE curve (L1/L2/L3, same
  architecture) next to a results table and a compact weight-tying card
- slide 10 table lists exactly the seven models plotted in its figure,
  each family at its best variant, with a note pointing back to slide 9
- narration (PPTX notes + speaker script) updated to match

Co-Authored-By: Claude Fable 5 <noreply@anthropic.com>
</commit_message>
<xml_diff>
--- a/submission/MBDL_Seminar_Presentation.pptx
+++ b/submission/MBDL_Seminar_Presentation.pptx
@@ -587,7 +587,7 @@
           <a:lstStyle/>
           <a:p>
             <a:r>
-              <a:t>Here is the full picture on the synthetic problem: NMSE as a function of depth. The training method matters — L2 is the best, and L3 gets stuck around layer eight, because later layers have no incentive to improve on what earlier layers already solved. But the big hierarchy remains: ALISTA beats every LISTA variant with 32 parameters, and HyperLISTA beats everyone with three. When the model assumptions hold, structure beats capacity.</a:t>
+              <a:t>Here is the full picture on the synthetic problem: NMSE as a function of depth, with each family shown at its best — for LISTA that is the L2 variant from the previous slide. The hierarchy is clear: our scalar models match or beat full LISTA, ALISTA beats every LISTA variant with 32 parameters, and HyperLISTA beats everyone with three. When the model assumptions hold, structure beats capacity.</a:t>
             </a:r>
           </a:p>
         </p:txBody>
@@ -1567,7 +1567,7 @@
           <a:lstStyle/>
           <a:p>
             <a:r>
-              <a:t>Following the training strategies discussed in class, we compared them on the exact same architecture. L1 is standard end-to-end training, with a loss on the final layer only. L2 is deep supervision: a weighted loss on every intermediate layer. L3 is greedy layer-wise training, where each layer is trained while the previous ones are frozen. We also tested weight tying — the same layer repeated K times, like a recurrent network. The interesting finding: tied LISTA, with sixteen times fewer parameters, comes very close to the untied version. Weight tying acts as a built-in regularizer.</a:t>
+              <a:t>Following the training strategies discussed in class, we compared them on the exact same architecture. L1 is standard end-to-end training, with a loss on the final layer only. L2 is deep supervision: a weighted loss on every intermediate layer. L3 is greedy layer-wise training, where each layer is trained while the previous ones are frozen. We also tested weight tying — the same layer repeated K times, like a recurrent network. The curve at the bottom shows all three on the exact same architecture: deep supervision improves every layer and finishes best at minus 21.9 dB; end-to-end L1 improves mostly in the final layers; and greedy L3 flattens around layer eight at minus 16.6, because later layers have no incentive to improve on what earlier layers already solved. And note tied LISTA: with sixteen times fewer parameters it comes very close to the untied version — weight tying acts as a built-in regularizer.</a:t>
             </a:r>
           </a:p>
         </p:txBody>
@@ -5175,7 +5175,7 @@
         </p:nvGraphicFramePr>
         <p:xfrm>
           <a:off x="7269480" y="1097280"/>
-          <a:ext cx="4297680" cy="2715768"/>
+          <a:ext cx="4572000" cy="2414016"/>
         </p:xfrm>
         <a:graphic>
           <a:graphicData uri="http://schemas.openxmlformats.org/drawingml/2006/table">
@@ -5184,8 +5184,8 @@
                 <a:tableStyleId>{5C22544A-7EE6-4342-B048-85BDC9FD1C3A}</a:tableStyleId>
               </a:tblPr>
               <a:tblGrid>
-                <a:gridCol w="2103120"/>
-                <a:gridCol w="1280160"/>
+                <a:gridCol w="2468880"/>
+                <a:gridCol w="1188720"/>
                 <a:gridCol w="914400"/>
               </a:tblGrid>
               <a:tr h="301752">
@@ -5404,7 +5404,7 @@
                         </a:defRPr>
                       </a:pPr>
                       <a:r>
-                        <a:t>LISTA-L1</a:t>
+                        <a:t>StepISTA (ours)</a:t>
                       </a:r>
                     </a:p>
                   </a:txBody>
@@ -5425,7 +5425,137 @@
                         </a:defRPr>
                       </a:pPr>
                       <a:r>
-                        <a:t>−20.3 dB</a:t>
+                        <a:t>−20.0 dB</a:t>
+                      </a:r>
+                    </a:p>
+                  </a:txBody>
+                  <a:tcPr>
+                    <a:solidFill>
+                      <a:srgbClr val="FFFFFF"/>
+                    </a:solidFill>
+                  </a:tcPr>
+                </a:tc>
+                <a:tc>
+                  <a:txBody>
+                    <a:bodyPr/>
+                    <a:lstStyle/>
+                    <a:p>
+                      <a:pPr>
+                        <a:defRPr sz="1300">
+                          <a:latin typeface="Calibri"/>
+                        </a:defRPr>
+                      </a:pPr>
+                      <a:r>
+                        <a:t>16</a:t>
+                      </a:r>
+                    </a:p>
+                  </a:txBody>
+                  <a:tcPr>
+                    <a:solidFill>
+                      <a:srgbClr val="FFFFFF"/>
+                    </a:solidFill>
+                  </a:tcPr>
+                </a:tc>
+              </a:tr>
+              <a:tr h="301752">
+                <a:tc>
+                  <a:txBody>
+                    <a:bodyPr/>
+                    <a:lstStyle/>
+                    <a:p>
+                      <a:pPr>
+                        <a:defRPr sz="1300">
+                          <a:latin typeface="Calibri"/>
+                        </a:defRPr>
+                      </a:pPr>
+                      <a:r>
+                        <a:t>StepThresholdISTA (ours)</a:t>
+                      </a:r>
+                    </a:p>
+                  </a:txBody>
+                  <a:tcPr>
+                    <a:solidFill>
+                      <a:srgbClr val="EEF4FB"/>
+                    </a:solidFill>
+                  </a:tcPr>
+                </a:tc>
+                <a:tc>
+                  <a:txBody>
+                    <a:bodyPr/>
+                    <a:lstStyle/>
+                    <a:p>
+                      <a:pPr>
+                        <a:defRPr sz="1300">
+                          <a:latin typeface="Calibri"/>
+                        </a:defRPr>
+                      </a:pPr>
+                      <a:r>
+                        <a:t>−23.6 dB</a:t>
+                      </a:r>
+                    </a:p>
+                  </a:txBody>
+                  <a:tcPr>
+                    <a:solidFill>
+                      <a:srgbClr val="EEF4FB"/>
+                    </a:solidFill>
+                  </a:tcPr>
+                </a:tc>
+                <a:tc>
+                  <a:txBody>
+                    <a:bodyPr/>
+                    <a:lstStyle/>
+                    <a:p>
+                      <a:pPr>
+                        <a:defRPr sz="1300">
+                          <a:latin typeface="Calibri"/>
+                        </a:defRPr>
+                      </a:pPr>
+                      <a:r>
+                        <a:t>32</a:t>
+                      </a:r>
+                    </a:p>
+                  </a:txBody>
+                  <a:tcPr>
+                    <a:solidFill>
+                      <a:srgbClr val="EEF4FB"/>
+                    </a:solidFill>
+                  </a:tcPr>
+                </a:tc>
+              </a:tr>
+              <a:tr h="301752">
+                <a:tc>
+                  <a:txBody>
+                    <a:bodyPr/>
+                    <a:lstStyle/>
+                    <a:p>
+                      <a:pPr>
+                        <a:defRPr sz="1300">
+                          <a:latin typeface="Calibri"/>
+                        </a:defRPr>
+                      </a:pPr>
+                      <a:r>
+                        <a:t>LISTA-L2  (best LISTA)</a:t>
+                      </a:r>
+                    </a:p>
+                  </a:txBody>
+                  <a:tcPr>
+                    <a:solidFill>
+                      <a:srgbClr val="FFFFFF"/>
+                    </a:solidFill>
+                  </a:tcPr>
+                </a:tc>
+                <a:tc>
+                  <a:txBody>
+                    <a:bodyPr/>
+                    <a:lstStyle/>
+                    <a:p>
+                      <a:pPr>
+                        <a:defRPr sz="1300">
+                          <a:latin typeface="Calibri"/>
+                        </a:defRPr>
+                      </a:pPr>
+                      <a:r>
+                        <a:t>−21.9 dB</a:t>
                       </a:r>
                     </a:p>
                   </a:txBody>
@@ -5453,201 +5583,6 @@
                   <a:tcPr>
                     <a:solidFill>
                       <a:srgbClr val="FFFFFF"/>
-                    </a:solidFill>
-                  </a:tcPr>
-                </a:tc>
-              </a:tr>
-              <a:tr h="301752">
-                <a:tc>
-                  <a:txBody>
-                    <a:bodyPr/>
-                    <a:lstStyle/>
-                    <a:p>
-                      <a:pPr>
-                        <a:defRPr sz="1300">
-                          <a:latin typeface="Calibri"/>
-                        </a:defRPr>
-                      </a:pPr>
-                      <a:r>
-                        <a:t>LISTA-L2</a:t>
-                      </a:r>
-                    </a:p>
-                  </a:txBody>
-                  <a:tcPr>
-                    <a:solidFill>
-                      <a:srgbClr val="EEF4FB"/>
-                    </a:solidFill>
-                  </a:tcPr>
-                </a:tc>
-                <a:tc>
-                  <a:txBody>
-                    <a:bodyPr/>
-                    <a:lstStyle/>
-                    <a:p>
-                      <a:pPr>
-                        <a:defRPr sz="1300">
-                          <a:latin typeface="Calibri"/>
-                        </a:defRPr>
-                      </a:pPr>
-                      <a:r>
-                        <a:t>−21.9 dB</a:t>
-                      </a:r>
-                    </a:p>
-                  </a:txBody>
-                  <a:tcPr>
-                    <a:solidFill>
-                      <a:srgbClr val="EEF4FB"/>
-                    </a:solidFill>
-                  </a:tcPr>
-                </a:tc>
-                <a:tc>
-                  <a:txBody>
-                    <a:bodyPr/>
-                    <a:lstStyle/>
-                    <a:p>
-                      <a:pPr>
-                        <a:defRPr sz="1300">
-                          <a:latin typeface="Calibri"/>
-                        </a:defRPr>
-                      </a:pPr>
-                      <a:r>
-                        <a:t>6 M</a:t>
-                      </a:r>
-                    </a:p>
-                  </a:txBody>
-                  <a:tcPr>
-                    <a:solidFill>
-                      <a:srgbClr val="EEF4FB"/>
-                    </a:solidFill>
-                  </a:tcPr>
-                </a:tc>
-              </a:tr>
-              <a:tr h="301752">
-                <a:tc>
-                  <a:txBody>
-                    <a:bodyPr/>
-                    <a:lstStyle/>
-                    <a:p>
-                      <a:pPr>
-                        <a:defRPr sz="1300">
-                          <a:latin typeface="Calibri"/>
-                        </a:defRPr>
-                      </a:pPr>
-                      <a:r>
-                        <a:t>LISTA-L3</a:t>
-                      </a:r>
-                    </a:p>
-                  </a:txBody>
-                  <a:tcPr>
-                    <a:solidFill>
-                      <a:srgbClr val="FFFFFF"/>
-                    </a:solidFill>
-                  </a:tcPr>
-                </a:tc>
-                <a:tc>
-                  <a:txBody>
-                    <a:bodyPr/>
-                    <a:lstStyle/>
-                    <a:p>
-                      <a:pPr>
-                        <a:defRPr sz="1300">
-                          <a:latin typeface="Calibri"/>
-                        </a:defRPr>
-                      </a:pPr>
-                      <a:r>
-                        <a:t>−16.6 dB</a:t>
-                      </a:r>
-                    </a:p>
-                  </a:txBody>
-                  <a:tcPr>
-                    <a:solidFill>
-                      <a:srgbClr val="FFFFFF"/>
-                    </a:solidFill>
-                  </a:tcPr>
-                </a:tc>
-                <a:tc>
-                  <a:txBody>
-                    <a:bodyPr/>
-                    <a:lstStyle/>
-                    <a:p>
-                      <a:pPr>
-                        <a:defRPr sz="1300">
-                          <a:latin typeface="Calibri"/>
-                        </a:defRPr>
-                      </a:pPr>
-                      <a:r>
-                        <a:t>6 M</a:t>
-                      </a:r>
-                    </a:p>
-                  </a:txBody>
-                  <a:tcPr>
-                    <a:solidFill>
-                      <a:srgbClr val="FFFFFF"/>
-                    </a:solidFill>
-                  </a:tcPr>
-                </a:tc>
-              </a:tr>
-              <a:tr h="301752">
-                <a:tc>
-                  <a:txBody>
-                    <a:bodyPr/>
-                    <a:lstStyle/>
-                    <a:p>
-                      <a:pPr>
-                        <a:defRPr sz="1300">
-                          <a:latin typeface="Calibri"/>
-                        </a:defRPr>
-                      </a:pPr>
-                      <a:r>
-                        <a:t>LISTA-Tied-L1</a:t>
-                      </a:r>
-                    </a:p>
-                  </a:txBody>
-                  <a:tcPr>
-                    <a:solidFill>
-                      <a:srgbClr val="EEF4FB"/>
-                    </a:solidFill>
-                  </a:tcPr>
-                </a:tc>
-                <a:tc>
-                  <a:txBody>
-                    <a:bodyPr/>
-                    <a:lstStyle/>
-                    <a:p>
-                      <a:pPr>
-                        <a:defRPr sz="1300">
-                          <a:latin typeface="Calibri"/>
-                        </a:defRPr>
-                      </a:pPr>
-                      <a:r>
-                        <a:t>−19.1 dB</a:t>
-                      </a:r>
-                    </a:p>
-                  </a:txBody>
-                  <a:tcPr>
-                    <a:solidFill>
-                      <a:srgbClr val="EEF4FB"/>
-                    </a:solidFill>
-                  </a:tcPr>
-                </a:tc>
-                <a:tc>
-                  <a:txBody>
-                    <a:bodyPr/>
-                    <a:lstStyle/>
-                    <a:p>
-                      <a:pPr>
-                        <a:defRPr sz="1300">
-                          <a:latin typeface="Calibri"/>
-                        </a:defRPr>
-                      </a:pPr>
-                      <a:r>
-                        <a:t>375 K</a:t>
-                      </a:r>
-                    </a:p>
-                  </a:txBody>
-                  <a:tcPr>
-                    <a:solidFill>
-                      <a:srgbClr val="EEF4FB"/>
                     </a:solidFill>
                   </a:tcPr>
                 </a:tc>
@@ -5803,8 +5738,8 @@
         </p:nvSpPr>
         <p:spPr>
           <a:xfrm>
-            <a:off x="7269480" y="4251960"/>
-            <a:ext cx="4572000" cy="1645920"/>
+            <a:off x="7269480" y="3931920"/>
+            <a:ext cx="4572000" cy="1737360"/>
           </a:xfrm>
           <a:prstGeom prst="rect">
             <a:avLst/>
@@ -5848,8 +5783,8 @@
         </p:nvSpPr>
         <p:spPr>
           <a:xfrm>
-            <a:off x="7269480" y="4251960"/>
-            <a:ext cx="50292" cy="1645920"/>
+            <a:off x="7269480" y="3931920"/>
+            <a:ext cx="50292" cy="1737360"/>
           </a:xfrm>
           <a:prstGeom prst="rect">
             <a:avLst/>
@@ -5891,8 +5826,8 @@
         </p:nvSpPr>
         <p:spPr>
           <a:xfrm>
-            <a:off x="7461504" y="4361688"/>
-            <a:ext cx="4242816" cy="1426464"/>
+            <a:off x="7461504" y="4041648"/>
+            <a:ext cx="4242816" cy="1517904"/>
           </a:xfrm>
           <a:prstGeom prst="rect">
             <a:avLst/>
@@ -5914,7 +5849,7 @@
               </a:defRPr>
             </a:pPr>
             <a:r>
-              <a:t>L3 plateau:  NMSE flattens ~layer 8.</a:t>
+              <a:t>Each family is shown with its best variant</a:t>
             </a:r>
           </a:p>
           <a:p>
@@ -5930,7 +5865,7 @@
               </a:defRPr>
             </a:pPr>
             <a:r>
-              <a:t>Greedy training gives no incentive to improve</a:t>
+              <a:t>(LISTA → L2; full L1/L2/L3 comparison on</a:t>
             </a:r>
           </a:p>
           <a:p>
@@ -5946,7 +5881,7 @@
               </a:defRPr>
             </a:pPr>
             <a:r>
-              <a:t>beyond what prior layers solved.</a:t>
+              <a:t>the previous slide).</a:t>
             </a:r>
           </a:p>
           <a:p>
@@ -5975,7 +5910,23 @@
               </a:defRPr>
             </a:pPr>
             <a:r>
-              <a:t>LISTA-Tied &gt; LISTA-Untied despite 16× fewer params.</a:t>
+              <a:t>ALISTA (32 params) beats every LISTA variant;</a:t>
+            </a:r>
+          </a:p>
+          <a:p>
+            <a:pPr>
+              <a:spcBef>
+                <a:spcPts val="200"/>
+              </a:spcBef>
+              <a:defRPr sz="1300">
+                <a:solidFill>
+                  <a:srgbClr val="1A1A2E"/>
+                </a:solidFill>
+                <a:latin typeface="Calibri"/>
+              </a:defRPr>
+            </a:pPr>
+            <a:r>
+              <a:t>HyperLISTA (3) beats everything.</a:t>
             </a:r>
           </a:p>
         </p:txBody>
@@ -21616,41 +21567,30 @@
           </a:p>
         </p:txBody>
       </p:sp>
-      <p:sp>
-        <p:nvSpPr>
-          <p:cNvPr id="20" name="TextBox 19"/>
-          <p:cNvSpPr txBox="1"/>
-          <p:nvPr/>
-        </p:nvSpPr>
-        <p:spPr>
-          <a:xfrm>
-            <a:off x="502920" y="3886200"/>
-            <a:ext cx="11185855" cy="320040"/>
-          </a:xfrm>
-          <a:prstGeom prst="rect">
-            <a:avLst/>
-          </a:prstGeom>
-          <a:noFill/>
-        </p:spPr>
-        <p:txBody>
-          <a:bodyPr wrap="square">
-            <a:spAutoFit/>
-          </a:bodyPr>
-          <a:lstStyle/>
-          <a:p>
-            <a:pPr algn="l"/>
-            <a:r>
-              <a:rPr sz="1700" b="1" i="0">
-                <a:solidFill>
-                  <a:srgbClr val="003F87"/>
-                </a:solidFill>
-                <a:latin typeface="Calibri"/>
-              </a:rPr>
-              <a:t>Tied vs. Untied weights:</a:t>
-            </a:r>
-          </a:p>
-        </p:txBody>
-      </p:sp>
+      <p:pic>
+        <p:nvPicPr>
+          <p:cNvPr id="20" name="Picture 19" descr="training_methods.png"/>
+          <p:cNvPicPr>
+            <a:picLocks noChangeAspect="1"/>
+          </p:cNvPicPr>
+          <p:nvPr/>
+        </p:nvPicPr>
+        <p:blipFill>
+          <a:blip r:embed="rId2"/>
+          <a:stretch>
+            <a:fillRect/>
+          </a:stretch>
+        </p:blipFill>
+        <p:spPr>
+          <a:xfrm>
+            <a:off x="502920" y="3840480"/>
+            <a:ext cx="4480560" cy="2800350"/>
+          </a:xfrm>
+          <a:prstGeom prst="rect">
+            <a:avLst/>
+          </a:prstGeom>
+        </p:spPr>
+      </p:pic>
       <p:graphicFrame>
         <p:nvGraphicFramePr>
           <p:cNvPr id="21" name="Table 20"/>
@@ -21660,8 +21600,8 @@
           <p:nvPr/>
         </p:nvGraphicFramePr>
         <p:xfrm>
-          <a:off x="502920" y="4251960"/>
-          <a:ext cx="7772400" cy="1508760"/>
+          <a:off x="5349240" y="4023360"/>
+          <a:ext cx="4114800" cy="1508760"/>
         </p:xfrm>
         <a:graphic>
           <a:graphicData uri="http://schemas.openxmlformats.org/drawingml/2006/table">
@@ -21670,9 +21610,9 @@
                 <a:tableStyleId>{5C22544A-7EE6-4342-B048-85BDC9FD1C3A}</a:tableStyleId>
               </a:tblPr>
               <a:tblGrid>
-                <a:gridCol w="1188720"/>
-                <a:gridCol w="3291840"/>
-                <a:gridCol w="3291840"/>
+                <a:gridCol w="1737360"/>
+                <a:gridCol w="1463040"/>
+                <a:gridCol w="914400"/>
               </a:tblGrid>
               <a:tr h="301752">
                 <a:tc>
@@ -21681,28 +21621,7 @@
                     <a:lstStyle/>
                     <a:p>
                       <a:pPr>
-                        <a:defRPr sz="1400" b="1">
-                          <a:solidFill>
-                            <a:srgbClr val="FFFFFF"/>
-                          </a:solidFill>
-                          <a:latin typeface="Calibri"/>
-                        </a:defRPr>
-                      </a:pPr>
-                    </a:p>
-                  </a:txBody>
-                  <a:tcPr>
-                    <a:solidFill>
-                      <a:srgbClr val="003F87"/>
-                    </a:solidFill>
-                  </a:tcPr>
-                </a:tc>
-                <a:tc>
-                  <a:txBody>
-                    <a:bodyPr/>
-                    <a:lstStyle/>
-                    <a:p>
-                      <a:pPr>
-                        <a:defRPr sz="1400" b="1">
+                        <a:defRPr sz="1300" b="1">
                           <a:solidFill>
                             <a:srgbClr val="FFFFFF"/>
                           </a:solidFill>
@@ -21710,7 +21629,7 @@
                         </a:defRPr>
                       </a:pPr>
                       <a:r>
-                        <a:t>Untied LISTA</a:t>
+                        <a:t>Training</a:t>
                       </a:r>
                     </a:p>
                   </a:txBody>
@@ -21726,7 +21645,7 @@
                     <a:lstStyle/>
                     <a:p>
                       <a:pPr>
-                        <a:defRPr sz="1400" b="1">
+                        <a:defRPr sz="1300" b="1">
                           <a:solidFill>
                             <a:srgbClr val="FFFFFF"/>
                           </a:solidFill>
@@ -21734,7 +21653,31 @@
                         </a:defRPr>
                       </a:pPr>
                       <a:r>
-                        <a:t>Tied LISTA</a:t>
+                        <a:t>NMSE @ K=16</a:t>
+                      </a:r>
+                    </a:p>
+                  </a:txBody>
+                  <a:tcPr>
+                    <a:solidFill>
+                      <a:srgbClr val="003F87"/>
+                    </a:solidFill>
+                  </a:tcPr>
+                </a:tc>
+                <a:tc>
+                  <a:txBody>
+                    <a:bodyPr/>
+                    <a:lstStyle/>
+                    <a:p>
+                      <a:pPr>
+                        <a:defRPr sz="1300" b="1">
+                          <a:solidFill>
+                            <a:srgbClr val="FFFFFF"/>
+                          </a:solidFill>
+                          <a:latin typeface="Calibri"/>
+                        </a:defRPr>
+                      </a:pPr>
+                      <a:r>
+                        <a:t>Params</a:t>
                       </a:r>
                     </a:p>
                   </a:txBody>
@@ -21752,12 +21695,12 @@
                     <a:lstStyle/>
                     <a:p>
                       <a:pPr>
-                        <a:defRPr sz="1400">
+                        <a:defRPr sz="1300">
                           <a:latin typeface="Calibri"/>
                         </a:defRPr>
                       </a:pPr>
                       <a:r>
-                        <a:t>Weights</a:t>
+                        <a:t>LISTA-L1</a:t>
                       </a:r>
                     </a:p>
                   </a:txBody>
@@ -21773,12 +21716,12 @@
                     <a:lstStyle/>
                     <a:p>
                       <a:pPr>
-                        <a:defRPr sz="1400">
+                        <a:defRPr sz="1300">
                           <a:latin typeface="Calibri"/>
                         </a:defRPr>
                       </a:pPr>
                       <a:r>
-                        <a:t>Independent per layer</a:t>
+                        <a:t>−20.3 dB</a:t>
                       </a:r>
                     </a:p>
                   </a:txBody>
@@ -21794,12 +21737,12 @@
                     <a:lstStyle/>
                     <a:p>
                       <a:pPr>
-                        <a:defRPr sz="1400">
+                        <a:defRPr sz="1300">
                           <a:latin typeface="Calibri"/>
                         </a:defRPr>
                       </a:pPr>
                       <a:r>
-                        <a:t>Single shared (Wx, Wy, θ)</a:t>
+                        <a:t>6 M</a:t>
                       </a:r>
                     </a:p>
                   </a:txBody>
@@ -21817,18 +21760,21 @@
                     <a:lstStyle/>
                     <a:p>
                       <a:pPr>
-                        <a:defRPr sz="1400">
+                        <a:defRPr sz="1300" b="1">
+                          <a:solidFill>
+                            <a:srgbClr val="003F87"/>
+                          </a:solidFill>
                           <a:latin typeface="Calibri"/>
                         </a:defRPr>
                       </a:pPr>
                       <a:r>
-                        <a:t>Params</a:t>
+                        <a:t>LISTA-L2</a:t>
                       </a:r>
                     </a:p>
                   </a:txBody>
                   <a:tcPr>
                     <a:solidFill>
-                      <a:srgbClr val="EEF4FB"/>
+                      <a:srgbClr val="D4EDFF"/>
                     </a:solidFill>
                   </a:tcPr>
                 </a:tc>
@@ -21838,18 +21784,21 @@
                     <a:lstStyle/>
                     <a:p>
                       <a:pPr>
-                        <a:defRPr sz="1400">
+                        <a:defRPr sz="1300" b="1">
+                          <a:solidFill>
+                            <a:srgbClr val="003F87"/>
+                          </a:solidFill>
                           <a:latin typeface="Calibri"/>
                         </a:defRPr>
                       </a:pPr>
                       <a:r>
-                        <a:t>~6 M</a:t>
+                        <a:t>−21.9 dB</a:t>
                       </a:r>
                     </a:p>
                   </a:txBody>
                   <a:tcPr>
                     <a:solidFill>
-                      <a:srgbClr val="EEF4FB"/>
+                      <a:srgbClr val="D4EDFF"/>
                     </a:solidFill>
                   </a:tcPr>
                 </a:tc>
@@ -21859,18 +21808,21 @@
                     <a:lstStyle/>
                     <a:p>
                       <a:pPr>
-                        <a:defRPr sz="1400">
+                        <a:defRPr sz="1300" b="1">
+                          <a:solidFill>
+                            <a:srgbClr val="003F87"/>
+                          </a:solidFill>
                           <a:latin typeface="Calibri"/>
                         </a:defRPr>
                       </a:pPr>
                       <a:r>
-                        <a:t>375 K</a:t>
+                        <a:t>6 M</a:t>
                       </a:r>
                     </a:p>
                   </a:txBody>
                   <a:tcPr>
                     <a:solidFill>
-                      <a:srgbClr val="EEF4FB"/>
+                      <a:srgbClr val="D4EDFF"/>
                     </a:solidFill>
                   </a:tcPr>
                 </a:tc>
@@ -21882,12 +21834,12 @@
                     <a:lstStyle/>
                     <a:p>
                       <a:pPr>
-                        <a:defRPr sz="1400">
+                        <a:defRPr sz="1300">
                           <a:latin typeface="Calibri"/>
                         </a:defRPr>
                       </a:pPr>
                       <a:r>
-                        <a:t>Style</a:t>
+                        <a:t>LISTA-L3</a:t>
                       </a:r>
                     </a:p>
                   </a:txBody>
@@ -21903,12 +21855,12 @@
                     <a:lstStyle/>
                     <a:p>
                       <a:pPr>
-                        <a:defRPr sz="1400">
+                        <a:defRPr sz="1300">
                           <a:latin typeface="Calibri"/>
                         </a:defRPr>
                       </a:pPr>
                       <a:r>
-                        <a:t>Fully flexible</a:t>
+                        <a:t>−16.6 dB</a:t>
                       </a:r>
                     </a:p>
                   </a:txBody>
@@ -21924,12 +21876,12 @@
                     <a:lstStyle/>
                     <a:p>
                       <a:pPr>
-                        <a:defRPr sz="1400">
+                        <a:defRPr sz="1300">
                           <a:latin typeface="Calibri"/>
                         </a:defRPr>
                       </a:pPr>
                       <a:r>
-                        <a:t>RNN-like</a:t>
+                        <a:t>6 M</a:t>
                       </a:r>
                     </a:p>
                   </a:txBody>
@@ -21947,12 +21899,12 @@
                     <a:lstStyle/>
                     <a:p>
                       <a:pPr>
-                        <a:defRPr sz="1400">
+                        <a:defRPr sz="1300">
                           <a:latin typeface="Calibri"/>
                         </a:defRPr>
                       </a:pPr>
                       <a:r>
-                        <a:t>Effect</a:t>
+                        <a:t>LISTA-Tied-L1</a:t>
                       </a:r>
                     </a:p>
                   </a:txBody>
@@ -21968,12 +21920,12 @@
                     <a:lstStyle/>
                     <a:p>
                       <a:pPr>
-                        <a:defRPr sz="1400">
+                        <a:defRPr sz="1300">
                           <a:latin typeface="Calibri"/>
                         </a:defRPr>
                       </a:pPr>
                       <a:r>
-                        <a:t>Hard to optimize</a:t>
+                        <a:t>−19.1 dB</a:t>
                       </a:r>
                     </a:p>
                   </a:txBody>
@@ -21989,12 +21941,12 @@
                     <a:lstStyle/>
                     <a:p>
                       <a:pPr>
-                        <a:defRPr sz="1400">
+                        <a:defRPr sz="1300">
                           <a:latin typeface="Calibri"/>
                         </a:defRPr>
                       </a:pPr>
                       <a:r>
-                        <a:t>Smoother loss landscape</a:t>
+                        <a:t>375 K</a:t>
                       </a:r>
                     </a:p>
                   </a:txBody>
@@ -22017,8 +21969,8 @@
         </p:nvSpPr>
         <p:spPr>
           <a:xfrm>
-            <a:off x="8595360" y="4251960"/>
-            <a:ext cx="3291840" cy="1600200"/>
+            <a:off x="9738360" y="4023360"/>
+            <a:ext cx="2194560" cy="1828800"/>
           </a:xfrm>
           <a:prstGeom prst="rect">
             <a:avLst/>
@@ -22062,8 +22014,8 @@
         </p:nvSpPr>
         <p:spPr>
           <a:xfrm>
-            <a:off x="8595360" y="4251960"/>
-            <a:ext cx="50292" cy="1600200"/>
+            <a:off x="9738360" y="4023360"/>
+            <a:ext cx="50292" cy="1828800"/>
           </a:xfrm>
           <a:prstGeom prst="rect">
             <a:avLst/>
@@ -22105,8 +22057,8 @@
         </p:nvSpPr>
         <p:spPr>
           <a:xfrm>
-            <a:off x="8787384" y="4361688"/>
-            <a:ext cx="2962656" cy="1380744"/>
+            <a:off x="9930384" y="4133088"/>
+            <a:ext cx="1865376" cy="1609344"/>
           </a:xfrm>
           <a:prstGeom prst="rect">
             <a:avLst/>
@@ -22128,7 +22080,7 @@
               </a:defRPr>
             </a:pPr>
             <a:r>
-              <a:t>Weight tying = implicit regularization.</a:t>
+              <a:t>Tied = one shared (Wx, Wy, θ), RNN-style.</a:t>
             </a:r>
           </a:p>
           <a:p>
@@ -22143,6 +22095,9 @@
                 <a:latin typeface="Calibri"/>
               </a:defRPr>
             </a:pPr>
+            <a:r>
+              <a:t>Implicit regularization: −19.1 dB</a:t>
+            </a:r>
           </a:p>
           <a:p>
             <a:pPr>
@@ -22157,23 +22112,7 @@
               </a:defRPr>
             </a:pPr>
             <a:r>
-              <a:t>LISTA-Tied-L1:  −19.1 dB @ 375 K</a:t>
-            </a:r>
-          </a:p>
-          <a:p>
-            <a:pPr>
-              <a:spcBef>
-                <a:spcPts val="200"/>
-              </a:spcBef>
-              <a:defRPr sz="1200">
-                <a:solidFill>
-                  <a:srgbClr val="1A1A2E"/>
-                </a:solidFill>
-                <a:latin typeface="Calibri"/>
-              </a:defRPr>
-            </a:pPr>
-            <a:r>
-              <a:t>LISTA-L1:  −20.3 dB @ 6 M</a:t>
+              <a:t>with 16× fewer parameters.</a:t>
             </a:r>
           </a:p>
         </p:txBody>

</xml_diff>

<commit_message>
Slide 11: highlight StepThresholdISTA and ALISTA, show LISTA-L2 in table
- regenerated design-space figure with the two models starred and the
  rest de-emphasized in gray
- table now lists LISTA-L2 (best variant, -21.9 dB) instead of L1;
  row highlights follow the starred models
- callout: StepThresholdISTA beats even the best LISTA (L2)

Co-Authored-By: Claude Fable 5 <noreply@anthropic.com>
</commit_message>
<xml_diff>
--- a/submission/MBDL_Seminar_Presentation.pptx
+++ b/submission/MBDL_Seminar_Presentation.pptx
@@ -657,7 +657,7 @@
           <a:lstStyle/>
           <a:p>
             <a:r>
-              <a:t>This map summarizes the synthetic part. The x-axis is the number of parameters on a logarithmic scale; the y-axis is the reconstruction error; the bottom-left corner is the ideal. Our StepThresholdISTA, with 32 scalars, sits in an excellent spot and beats LISTA with 187,000 times fewer parameters. HyperLISTA breaks the scale entirely. The message: in problems with known structure, choosing what to learn matters more than raw capacity.</a:t>
+              <a:t>This map summarizes the synthetic part. The x-axis is the number of parameters on a logarithmic scale; the y-axis is the reconstruction error; the bottom-left corner is the ideal. The two starred models are the interesting ones: our StepThresholdISTA, with 32 scalars, beats even the best LISTA variant with 187,000 times fewer parameters, and ALISTA reaches minus 30 dB with the same 32 parameters thanks to its analytic weight matrix. HyperLISTA breaks the scale entirely. The message: in problems with known structure, choosing what to learn matters more than raw capacity.</a:t>
             </a:r>
           </a:p>
         </p:txBody>
@@ -6157,7 +6157,7 @@
       </p:sp>
       <p:pic>
         <p:nvPicPr>
-          <p:cNvPr id="7" name="Picture 6" descr="param_tradeoff_full.png"/>
+          <p:cNvPr id="7" name="Picture 6" descr="param_tradeoff_highlight.png"/>
           <p:cNvPicPr>
             <a:picLocks noChangeAspect="1"/>
           </p:cNvPicPr>
@@ -6172,7 +6172,7 @@
         <p:spPr>
           <a:xfrm>
             <a:off x="320040" y="1097280"/>
-            <a:ext cx="6400800" cy="4267200"/>
+            <a:ext cx="6400800" cy="4042611"/>
           </a:xfrm>
           <a:prstGeom prst="rect">
             <a:avLst/>
@@ -6583,7 +6583,7 @@
                         </a:defRPr>
                       </a:pPr>
                       <a:r>
-                        <a:t>LISTA-L1</a:t>
+                        <a:t>LISTA-L2</a:t>
                       </a:r>
                     </a:p>
                   </a:txBody>
@@ -6625,7 +6625,7 @@
                         </a:defRPr>
                       </a:pPr>
                       <a:r>
-                        <a:t>−20.3 dB</a:t>
+                        <a:t>−21.9 dB</a:t>
                       </a:r>
                     </a:p>
                   </a:txBody>
@@ -6646,99 +6646,13 @@
                         </a:defRPr>
                       </a:pPr>
                       <a:r>
-                        <a:t>full matrices</a:t>
+                        <a:t>full matrices + L2</a:t>
                       </a:r>
                     </a:p>
                   </a:txBody>
                   <a:tcPr>
                     <a:solidFill>
                       <a:srgbClr val="EEF4FB"/>
-                    </a:solidFill>
-                  </a:tcPr>
-                </a:tc>
-              </a:tr>
-              <a:tr h="301752">
-                <a:tc>
-                  <a:txBody>
-                    <a:bodyPr/>
-                    <a:lstStyle/>
-                    <a:p>
-                      <a:pPr>
-                        <a:defRPr sz="1300">
-                          <a:latin typeface="Calibri"/>
-                        </a:defRPr>
-                      </a:pPr>
-                      <a:r>
-                        <a:t>ALISTA</a:t>
-                      </a:r>
-                    </a:p>
-                  </a:txBody>
-                  <a:tcPr>
-                    <a:solidFill>
-                      <a:srgbClr val="FFFFFF"/>
-                    </a:solidFill>
-                  </a:tcPr>
-                </a:tc>
-                <a:tc>
-                  <a:txBody>
-                    <a:bodyPr/>
-                    <a:lstStyle/>
-                    <a:p>
-                      <a:pPr>
-                        <a:defRPr sz="1300">
-                          <a:latin typeface="Calibri"/>
-                        </a:defRPr>
-                      </a:pPr>
-                      <a:r>
-                        <a:t>32</a:t>
-                      </a:r>
-                    </a:p>
-                  </a:txBody>
-                  <a:tcPr>
-                    <a:solidFill>
-                      <a:srgbClr val="FFFFFF"/>
-                    </a:solidFill>
-                  </a:tcPr>
-                </a:tc>
-                <a:tc>
-                  <a:txBody>
-                    <a:bodyPr/>
-                    <a:lstStyle/>
-                    <a:p>
-                      <a:pPr>
-                        <a:defRPr sz="1300">
-                          <a:latin typeface="Calibri"/>
-                        </a:defRPr>
-                      </a:pPr>
-                      <a:r>
-                        <a:t>−29.8 dB</a:t>
-                      </a:r>
-                    </a:p>
-                  </a:txBody>
-                  <a:tcPr>
-                    <a:solidFill>
-                      <a:srgbClr val="FFFFFF"/>
-                    </a:solidFill>
-                  </a:tcPr>
-                </a:tc>
-                <a:tc>
-                  <a:txBody>
-                    <a:bodyPr/>
-                    <a:lstStyle/>
-                    <a:p>
-                      <a:pPr>
-                        <a:defRPr sz="1300">
-                          <a:latin typeface="Calibri"/>
-                        </a:defRPr>
-                      </a:pPr>
-                      <a:r>
-                        <a:t>analytic W</a:t>
-                      </a:r>
-                    </a:p>
-                  </a:txBody>
-                  <a:tcPr>
-                    <a:solidFill>
-                      <a:srgbClr val="FFFFFF"/>
                     </a:solidFill>
                   </a:tcPr>
                 </a:tc>
@@ -6758,7 +6672,7 @@
                         </a:defRPr>
                       </a:pPr>
                       <a:r>
-                        <a:t>HyperLISTA</a:t>
+                        <a:t>ALISTA</a:t>
                       </a:r>
                     </a:p>
                   </a:txBody>
@@ -6782,7 +6696,7 @@
                         </a:defRPr>
                       </a:pPr>
                       <a:r>
-                        <a:t>3</a:t>
+                        <a:t>32</a:t>
                       </a:r>
                     </a:p>
                   </a:txBody>
@@ -6806,7 +6720,7 @@
                         </a:defRPr>
                       </a:pPr>
                       <a:r>
-                        <a:t>−61.4 dB</a:t>
+                        <a:t>−29.8 dB</a:t>
                       </a:r>
                     </a:p>
                   </a:txBody>
@@ -6830,7 +6744,7 @@
                         </a:defRPr>
                       </a:pPr>
                       <a:r>
-                        <a:t>adaptive residuals</a:t>
+                        <a:t>analytic W</a:t>
                       </a:r>
                     </a:p>
                   </a:txBody>
@@ -6841,6 +6755,92 @@
                   </a:tcPr>
                 </a:tc>
               </a:tr>
+              <a:tr h="301752">
+                <a:tc>
+                  <a:txBody>
+                    <a:bodyPr/>
+                    <a:lstStyle/>
+                    <a:p>
+                      <a:pPr>
+                        <a:defRPr sz="1300" b="1">
+                          <a:latin typeface="Calibri"/>
+                        </a:defRPr>
+                      </a:pPr>
+                      <a:r>
+                        <a:t>HyperLISTA</a:t>
+                      </a:r>
+                    </a:p>
+                  </a:txBody>
+                  <a:tcPr>
+                    <a:solidFill>
+                      <a:srgbClr val="E8F5FF"/>
+                    </a:solidFill>
+                  </a:tcPr>
+                </a:tc>
+                <a:tc>
+                  <a:txBody>
+                    <a:bodyPr/>
+                    <a:lstStyle/>
+                    <a:p>
+                      <a:pPr>
+                        <a:defRPr sz="1300" b="1">
+                          <a:latin typeface="Calibri"/>
+                        </a:defRPr>
+                      </a:pPr>
+                      <a:r>
+                        <a:t>3</a:t>
+                      </a:r>
+                    </a:p>
+                  </a:txBody>
+                  <a:tcPr>
+                    <a:solidFill>
+                      <a:srgbClr val="E8F5FF"/>
+                    </a:solidFill>
+                  </a:tcPr>
+                </a:tc>
+                <a:tc>
+                  <a:txBody>
+                    <a:bodyPr/>
+                    <a:lstStyle/>
+                    <a:p>
+                      <a:pPr>
+                        <a:defRPr sz="1300" b="1">
+                          <a:latin typeface="Calibri"/>
+                        </a:defRPr>
+                      </a:pPr>
+                      <a:r>
+                        <a:t>−61.4 dB</a:t>
+                      </a:r>
+                    </a:p>
+                  </a:txBody>
+                  <a:tcPr>
+                    <a:solidFill>
+                      <a:srgbClr val="E8F5FF"/>
+                    </a:solidFill>
+                  </a:tcPr>
+                </a:tc>
+                <a:tc>
+                  <a:txBody>
+                    <a:bodyPr/>
+                    <a:lstStyle/>
+                    <a:p>
+                      <a:pPr>
+                        <a:defRPr sz="1300" b="1">
+                          <a:latin typeface="Calibri"/>
+                        </a:defRPr>
+                      </a:pPr>
+                      <a:r>
+                        <a:t>adaptive residuals</a:t>
+                      </a:r>
+                    </a:p>
+                  </a:txBody>
+                  <a:tcPr>
+                    <a:solidFill>
+                      <a:srgbClr val="E8F5FF"/>
+                    </a:solidFill>
+                  </a:tcPr>
+                </a:tc>
+              </a:tr>
             </a:tbl>
           </a:graphicData>
         </a:graphic>
@@ -6928,7 +6928,7 @@
                 </a:solidFill>
                 <a:latin typeface="Calibri"/>
               </a:rPr>
-              <a:t>beats LISTA-L1  (6 million matrices).</a:t>
+              <a:t>beats even the best LISTA  (L2, 6 M params).</a:t>
             </a:r>
           </a:p>
           <a:p>

</xml_diff>

<commit_message>
Fix mislabeled stress-test grids: images were ratio 0.5, not 0.25
The reconstruction grids embedded from the old deck carried ratio-0.5
metrics (e.g. FashionMNIST LISTA-L2 SSIM 0.88) while being captioned
ratio 0.25. Replaced both grids with renders of the authoritative
notebook-04 ratio-0.25 figures (LISTA-L2 -13.7 dB / 22.3 / 0.82,
matching Table 2 and the SSIM heatmap). Affects slide 14 and report
Figure 5. Caught by Etay & Etai.

Co-Authored-By: Claude Fable 5 <noreply@anthropic.com>
</commit_message>
<xml_diff>
--- a/submission/MBDL_Seminar_Presentation.pptx
+++ b/submission/MBDL_Seminar_Presentation.pptx
@@ -9263,7 +9263,7 @@
         <p:spPr>
           <a:xfrm>
             <a:off x="777240" y="1097280"/>
-            <a:ext cx="4709160" cy="4287094"/>
+            <a:ext cx="4709160" cy="4286169"/>
           </a:xfrm>
           <a:prstGeom prst="rect">
             <a:avLst/>
@@ -9287,7 +9287,7 @@
         <p:spPr>
           <a:xfrm>
             <a:off x="6720840" y="1097280"/>
-            <a:ext cx="4709160" cy="4287094"/>
+            <a:ext cx="4709160" cy="4286169"/>
           </a:xfrm>
           <a:prstGeom prst="rect">
             <a:avLst/>

</xml_diff>

<commit_message>
Render all slide equations with real LaTeX
Equations are now compiled per-formula with pdflatex (standalone class)
and placed as transparent 600-dpi PNGs, centered and uniformly scaled
from the same 10pt base — proper fractions, script letters, and
correctly sized superscripts, identical in every viewer.

Co-Authored-By: Claude Fable 5 <noreply@anthropic.com>
</commit_message>
<xml_diff>
--- a/submission/MBDL_Seminar_Presentation.pptx
+++ b/submission/MBDL_Seminar_Presentation.pptx
@@ -13737,95 +13737,30 @@
           </a:p>
         </p:txBody>
       </p:sp>
-      <p:sp>
-        <p:nvSpPr>
-          <p:cNvPr id="11" name="TextBox 10"/>
-          <p:cNvSpPr txBox="1"/>
-          <p:nvPr/>
-        </p:nvSpPr>
-        <p:spPr>
-          <a:xfrm>
-            <a:off x="502920" y="4434840"/>
-            <a:ext cx="5943600" cy="411480"/>
-          </a:xfrm>
-          <a:prstGeom prst="rect">
-            <a:avLst/>
-          </a:prstGeom>
-          <a:noFill/>
-        </p:spPr>
-        <p:txBody>
-          <a:bodyPr wrap="none">
-            <a:spAutoFit/>
-          </a:bodyPr>
-          <a:lstStyle/>
-          <a:p>
-            <a:pPr algn="ctr"/>
-            <a:r>
-              <a:rPr sz="2000" i="1">
-                <a:solidFill>
-                  <a:srgbClr val="1A1A2E"/>
-                </a:solidFill>
-                <a:latin typeface="Cambria"/>
-              </a:rPr>
-              <a:t>x̂  =  arg min</a:t>
-            </a:r>
-            <a:r>
-              <a:rPr sz="1400" i="1" baseline="-25000">
-                <a:solidFill>
-                  <a:srgbClr val="1A1A2E"/>
-                </a:solidFill>
-                <a:latin typeface="Cambria"/>
-              </a:rPr>
-              <a:t>x</a:t>
-            </a:r>
-            <a:r>
-              <a:rPr sz="2000" i="1">
-                <a:solidFill>
-                  <a:srgbClr val="1A1A2E"/>
-                </a:solidFill>
-                <a:latin typeface="Cambria"/>
-              </a:rPr>
-              <a:t>  ½ ‖ b − A x ‖</a:t>
-            </a:r>
-            <a:r>
-              <a:rPr sz="1400" i="1" baseline="-25000">
-                <a:solidFill>
-                  <a:srgbClr val="1A1A2E"/>
-                </a:solidFill>
-                <a:latin typeface="Cambria"/>
-              </a:rPr>
-              <a:t>2</a:t>
-            </a:r>
-            <a:r>
-              <a:rPr sz="1400" i="1" baseline="30000">
-                <a:solidFill>
-                  <a:srgbClr val="1A1A2E"/>
-                </a:solidFill>
-                <a:latin typeface="Cambria"/>
-              </a:rPr>
-              <a:t>2</a:t>
-            </a:r>
-            <a:r>
-              <a:rPr sz="2000" i="1">
-                <a:solidFill>
-                  <a:srgbClr val="1A1A2E"/>
-                </a:solidFill>
-                <a:latin typeface="Cambria"/>
-              </a:rPr>
-              <a:t>  +  λ ‖ x ‖</a:t>
-            </a:r>
-            <a:r>
-              <a:rPr sz="1400" i="1" baseline="-25000">
-                <a:solidFill>
-                  <a:srgbClr val="1A1A2E"/>
-                </a:solidFill>
-                <a:latin typeface="Cambria"/>
-              </a:rPr>
-              <a:t>1</a:t>
-            </a:r>
-          </a:p>
-        </p:txBody>
-      </p:sp>
+      <p:pic>
+        <p:nvPicPr>
+          <p:cNvPr id="11" name="Picture 10" descr="75f649db7ea0e3ab.png"/>
+          <p:cNvPicPr>
+            <a:picLocks noChangeAspect="1"/>
+          </p:cNvPicPr>
+          <p:nvPr/>
+        </p:nvPicPr>
+        <p:blipFill>
+          <a:blip r:embed="rId2"/>
+          <a:stretch>
+            <a:fillRect/>
+          </a:stretch>
+        </p:blipFill>
+        <p:spPr>
+          <a:xfrm>
+            <a:off x="1388364" y="4389120"/>
+            <a:ext cx="4172712" cy="408432"/>
+          </a:xfrm>
+          <a:prstGeom prst="rect">
+            <a:avLst/>
+          </a:prstGeom>
+        </p:spPr>
+      </p:pic>
       <p:sp>
         <p:nvSpPr>
           <p:cNvPr id="12" name="TextBox 11"/>
@@ -13939,59 +13874,30 @@
           </a:p>
         </p:txBody>
       </p:sp>
-      <p:sp>
-        <p:nvSpPr>
-          <p:cNvPr id="15" name="TextBox 14"/>
-          <p:cNvSpPr txBox="1"/>
-          <p:nvPr/>
-        </p:nvSpPr>
-        <p:spPr>
-          <a:xfrm>
-            <a:off x="6858000" y="1801368"/>
-            <a:ext cx="4663440" cy="411480"/>
-          </a:xfrm>
-          <a:prstGeom prst="rect">
-            <a:avLst/>
-          </a:prstGeom>
-          <a:noFill/>
-        </p:spPr>
-        <p:txBody>
-          <a:bodyPr wrap="none">
-            <a:spAutoFit/>
-          </a:bodyPr>
-          <a:lstStyle/>
-          <a:p>
-            <a:pPr algn="ctr"/>
-            <a:r>
-              <a:rPr sz="2400" i="1">
-                <a:solidFill>
-                  <a:srgbClr val="FFFFFF"/>
-                </a:solidFill>
-                <a:latin typeface="Cambria"/>
-              </a:rPr>
-              <a:t>b  =  A x</a:t>
-            </a:r>
-            <a:r>
-              <a:rPr sz="1700" i="1" baseline="30000">
-                <a:solidFill>
-                  <a:srgbClr val="FFFFFF"/>
-                </a:solidFill>
-                <a:latin typeface="Cambria"/>
-              </a:rPr>
-              <a:t>*</a:t>
-            </a:r>
-            <a:r>
-              <a:rPr sz="2400" i="1">
-                <a:solidFill>
-                  <a:srgbClr val="FFFFFF"/>
-                </a:solidFill>
-                <a:latin typeface="Cambria"/>
-              </a:rPr>
-              <a:t>  +  ε</a:t>
-            </a:r>
-          </a:p>
-        </p:txBody>
-      </p:sp>
+      <p:pic>
+        <p:nvPicPr>
+          <p:cNvPr id="15" name="Picture 14" descr="5bd0038d3d2d57c6.png"/>
+          <p:cNvPicPr>
+            <a:picLocks noChangeAspect="1"/>
+          </p:cNvPicPr>
+          <p:nvPr/>
+        </p:nvPicPr>
+        <p:blipFill>
+          <a:blip r:embed="rId3"/>
+          <a:stretch>
+            <a:fillRect/>
+          </a:stretch>
+        </p:blipFill>
+        <p:spPr>
+          <a:xfrm>
+            <a:off x="8249717" y="1856232"/>
+            <a:ext cx="1880006" cy="373075"/>
+          </a:xfrm>
+          <a:prstGeom prst="rect">
+            <a:avLst/>
+          </a:prstGeom>
+        </p:spPr>
+      </p:pic>
       <p:sp>
         <p:nvSpPr>
           <p:cNvPr id="16" name="TextBox 15"/>
@@ -14496,158 +14402,30 @@
           </a:p>
         </p:txBody>
       </p:sp>
-      <p:sp>
-        <p:nvSpPr>
-          <p:cNvPr id="8" name="TextBox 7"/>
-          <p:cNvSpPr txBox="1"/>
-          <p:nvPr/>
-        </p:nvSpPr>
-        <p:spPr>
-          <a:xfrm>
-            <a:off x="502920" y="1572768"/>
-            <a:ext cx="11185855" cy="411480"/>
-          </a:xfrm>
-          <a:prstGeom prst="rect">
-            <a:avLst/>
-          </a:prstGeom>
-          <a:noFill/>
-        </p:spPr>
-        <p:txBody>
-          <a:bodyPr wrap="none">
-            <a:spAutoFit/>
-          </a:bodyPr>
-          <a:lstStyle/>
-          <a:p>
-            <a:pPr algn="ctr"/>
-            <a:r>
-              <a:rPr sz="2000" i="1">
-                <a:solidFill>
-                  <a:srgbClr val="1A1A2E"/>
-                </a:solidFill>
-                <a:latin typeface="Cambria"/>
-              </a:rPr>
-              <a:t>x</a:t>
-            </a:r>
-            <a:r>
-              <a:rPr sz="1400" i="1" baseline="30000">
-                <a:solidFill>
-                  <a:srgbClr val="1A1A2E"/>
-                </a:solidFill>
-                <a:latin typeface="Cambria"/>
-              </a:rPr>
-              <a:t>(k+1)</a:t>
-            </a:r>
-            <a:r>
-              <a:rPr sz="2000" i="1">
-                <a:solidFill>
-                  <a:srgbClr val="1A1A2E"/>
-                </a:solidFill>
-                <a:latin typeface="Cambria"/>
-              </a:rPr>
-              <a:t> = S</a:t>
-            </a:r>
-            <a:r>
-              <a:rPr sz="1400" i="1" baseline="-25000">
-                <a:solidFill>
-                  <a:srgbClr val="1A1A2E"/>
-                </a:solidFill>
-                <a:latin typeface="Cambria"/>
-              </a:rPr>
-              <a:t>θ</a:t>
-            </a:r>
-            <a:r>
-              <a:rPr sz="2000" i="1">
-                <a:solidFill>
-                  <a:srgbClr val="1A1A2E"/>
-                </a:solidFill>
-                <a:latin typeface="Cambria"/>
-              </a:rPr>
-              <a:t>( x</a:t>
-            </a:r>
-            <a:r>
-              <a:rPr sz="1400" i="1" baseline="30000">
-                <a:solidFill>
-                  <a:srgbClr val="1A1A2E"/>
-                </a:solidFill>
-                <a:latin typeface="Cambria"/>
-              </a:rPr>
-              <a:t>(k)</a:t>
-            </a:r>
-            <a:r>
-              <a:rPr sz="2000" i="1">
-                <a:solidFill>
-                  <a:srgbClr val="1A1A2E"/>
-                </a:solidFill>
-                <a:latin typeface="Cambria"/>
-              </a:rPr>
-              <a:t> + (1/L) A</a:t>
-            </a:r>
-            <a:r>
-              <a:rPr sz="1400" i="1" baseline="30000">
-                <a:solidFill>
-                  <a:srgbClr val="1A1A2E"/>
-                </a:solidFill>
-                <a:latin typeface="Cambria"/>
-              </a:rPr>
-              <a:t>T</a:t>
-            </a:r>
-            <a:r>
-              <a:rPr sz="2000" i="1">
-                <a:solidFill>
-                  <a:srgbClr val="1A1A2E"/>
-                </a:solidFill>
-                <a:latin typeface="Cambria"/>
-              </a:rPr>
-              <a:t>( b − A x</a:t>
-            </a:r>
-            <a:r>
-              <a:rPr sz="1400" i="1" baseline="30000">
-                <a:solidFill>
-                  <a:srgbClr val="1A1A2E"/>
-                </a:solidFill>
-                <a:latin typeface="Cambria"/>
-              </a:rPr>
-              <a:t>(k)</a:t>
-            </a:r>
-            <a:r>
-              <a:rPr sz="2000" i="1">
-                <a:solidFill>
-                  <a:srgbClr val="1A1A2E"/>
-                </a:solidFill>
-                <a:latin typeface="Cambria"/>
-              </a:rPr>
-              <a:t> ) ) ,      L = ‖A‖</a:t>
-            </a:r>
-            <a:r>
-              <a:rPr sz="1400" i="1" baseline="-25000">
-                <a:solidFill>
-                  <a:srgbClr val="1A1A2E"/>
-                </a:solidFill>
-                <a:latin typeface="Cambria"/>
-              </a:rPr>
-              <a:t>2</a:t>
-            </a:r>
-            <a:r>
-              <a:rPr sz="1400" i="1" baseline="30000">
-                <a:solidFill>
-                  <a:srgbClr val="1A1A2E"/>
-                </a:solidFill>
-                <a:latin typeface="Cambria"/>
-              </a:rPr>
-              <a:t>2</a:t>
-            </a:r>
-            <a:r>
-              <a:rPr sz="2000" i="1">
-                <a:solidFill>
-                  <a:srgbClr val="1A1A2E"/>
-                </a:solidFill>
-                <a:latin typeface="Cambria"/>
-              </a:rPr>
-              <a:t> ,      θ = λ / L</a:t>
-            </a:r>
-          </a:p>
-        </p:txBody>
-      </p:sp>
+      <p:pic>
+        <p:nvPicPr>
+          <p:cNvPr id="8" name="Picture 7" descr="ec376716e81011a3.png"/>
+          <p:cNvPicPr>
+            <a:picLocks noChangeAspect="1"/>
+          </p:cNvPicPr>
+          <p:nvPr/>
+        </p:nvPicPr>
+        <p:blipFill>
+          <a:blip r:embed="rId2"/>
+          <a:stretch>
+            <a:fillRect/>
+          </a:stretch>
+        </p:blipFill>
+        <p:spPr>
+          <a:xfrm>
+            <a:off x="2471775" y="1572768"/>
+            <a:ext cx="7248144" cy="557784"/>
+          </a:xfrm>
+          <a:prstGeom prst="rect">
+            <a:avLst/>
+          </a:prstGeom>
+        </p:spPr>
+      </p:pic>
       <p:sp>
         <p:nvSpPr>
           <p:cNvPr id="9" name="TextBox 8"/>
@@ -14683,239 +14461,30 @@
           </a:p>
         </p:txBody>
       </p:sp>
-      <p:sp>
-        <p:nvSpPr>
-          <p:cNvPr id="10" name="TextBox 9"/>
-          <p:cNvSpPr txBox="1"/>
-          <p:nvPr/>
-        </p:nvSpPr>
-        <p:spPr>
-          <a:xfrm>
-            <a:off x="502920" y="2715768"/>
-            <a:ext cx="11185855" cy="411480"/>
-          </a:xfrm>
-          <a:prstGeom prst="rect">
-            <a:avLst/>
-          </a:prstGeom>
-          <a:noFill/>
-        </p:spPr>
-        <p:txBody>
-          <a:bodyPr wrap="none">
-            <a:spAutoFit/>
-          </a:bodyPr>
-          <a:lstStyle/>
-          <a:p>
-            <a:pPr algn="ctr"/>
-            <a:r>
-              <a:rPr sz="2000" i="1">
-                <a:solidFill>
-                  <a:srgbClr val="1A1A2E"/>
-                </a:solidFill>
-                <a:latin typeface="Cambria"/>
-              </a:rPr>
-              <a:t>y</a:t>
-            </a:r>
-            <a:r>
-              <a:rPr sz="1400" i="1" baseline="30000">
-                <a:solidFill>
-                  <a:srgbClr val="1A1A2E"/>
-                </a:solidFill>
-                <a:latin typeface="Cambria"/>
-              </a:rPr>
-              <a:t>(k)</a:t>
-            </a:r>
-            <a:r>
-              <a:rPr sz="2000" i="1">
-                <a:solidFill>
-                  <a:srgbClr val="1A1A2E"/>
-                </a:solidFill>
-                <a:latin typeface="Cambria"/>
-              </a:rPr>
-              <a:t> = x</a:t>
-            </a:r>
-            <a:r>
-              <a:rPr sz="1400" i="1" baseline="30000">
-                <a:solidFill>
-                  <a:srgbClr val="1A1A2E"/>
-                </a:solidFill>
-                <a:latin typeface="Cambria"/>
-              </a:rPr>
-              <a:t>(k)</a:t>
-            </a:r>
-            <a:r>
-              <a:rPr sz="2000" i="1">
-                <a:solidFill>
-                  <a:srgbClr val="1A1A2E"/>
-                </a:solidFill>
-                <a:latin typeface="Cambria"/>
-              </a:rPr>
-              <a:t> + (( t</a:t>
-            </a:r>
-            <a:r>
-              <a:rPr sz="1400" i="1" baseline="-25000">
-                <a:solidFill>
-                  <a:srgbClr val="1A1A2E"/>
-                </a:solidFill>
-                <a:latin typeface="Cambria"/>
-              </a:rPr>
-              <a:t>k</a:t>
-            </a:r>
-            <a:r>
-              <a:rPr sz="2000" i="1">
-                <a:solidFill>
-                  <a:srgbClr val="1A1A2E"/>
-                </a:solidFill>
-                <a:latin typeface="Cambria"/>
-              </a:rPr>
-              <a:t> − 1 ) / t</a:t>
-            </a:r>
-            <a:r>
-              <a:rPr sz="1400" i="1" baseline="-25000">
-                <a:solidFill>
-                  <a:srgbClr val="1A1A2E"/>
-                </a:solidFill>
-                <a:latin typeface="Cambria"/>
-              </a:rPr>
-              <a:t>k+1</a:t>
-            </a:r>
-            <a:r>
-              <a:rPr sz="2000" i="1">
-                <a:solidFill>
-                  <a:srgbClr val="1A1A2E"/>
-                </a:solidFill>
-                <a:latin typeface="Cambria"/>
-              </a:rPr>
-              <a:t> ) ( x</a:t>
-            </a:r>
-            <a:r>
-              <a:rPr sz="1400" i="1" baseline="30000">
-                <a:solidFill>
-                  <a:srgbClr val="1A1A2E"/>
-                </a:solidFill>
-                <a:latin typeface="Cambria"/>
-              </a:rPr>
-              <a:t>(k)</a:t>
-            </a:r>
-            <a:r>
-              <a:rPr sz="2000" i="1">
-                <a:solidFill>
-                  <a:srgbClr val="1A1A2E"/>
-                </a:solidFill>
-                <a:latin typeface="Cambria"/>
-              </a:rPr>
-              <a:t> − x</a:t>
-            </a:r>
-            <a:r>
-              <a:rPr sz="1400" i="1" baseline="30000">
-                <a:solidFill>
-                  <a:srgbClr val="1A1A2E"/>
-                </a:solidFill>
-                <a:latin typeface="Cambria"/>
-              </a:rPr>
-              <a:t>(k−1)</a:t>
-            </a:r>
-            <a:r>
-              <a:rPr sz="2000" i="1">
-                <a:solidFill>
-                  <a:srgbClr val="1A1A2E"/>
-                </a:solidFill>
-                <a:latin typeface="Cambria"/>
-              </a:rPr>
-              <a:t> ) ,      x</a:t>
-            </a:r>
-            <a:r>
-              <a:rPr sz="1400" i="1" baseline="30000">
-                <a:solidFill>
-                  <a:srgbClr val="1A1A2E"/>
-                </a:solidFill>
-                <a:latin typeface="Cambria"/>
-              </a:rPr>
-              <a:t>(k+1)</a:t>
-            </a:r>
-            <a:r>
-              <a:rPr sz="2000" i="1">
-                <a:solidFill>
-                  <a:srgbClr val="1A1A2E"/>
-                </a:solidFill>
-                <a:latin typeface="Cambria"/>
-              </a:rPr>
-              <a:t> = S</a:t>
-            </a:r>
-            <a:r>
-              <a:rPr sz="1400" i="1" baseline="-25000">
-                <a:solidFill>
-                  <a:srgbClr val="1A1A2E"/>
-                </a:solidFill>
-                <a:latin typeface="Cambria"/>
-              </a:rPr>
-              <a:t>θ</a:t>
-            </a:r>
-            <a:r>
-              <a:rPr sz="2000" i="1">
-                <a:solidFill>
-                  <a:srgbClr val="1A1A2E"/>
-                </a:solidFill>
-                <a:latin typeface="Cambria"/>
-              </a:rPr>
-              <a:t>( y</a:t>
-            </a:r>
-            <a:r>
-              <a:rPr sz="1400" i="1" baseline="30000">
-                <a:solidFill>
-                  <a:srgbClr val="1A1A2E"/>
-                </a:solidFill>
-                <a:latin typeface="Cambria"/>
-              </a:rPr>
-              <a:t>(k)</a:t>
-            </a:r>
-            <a:r>
-              <a:rPr sz="2000" i="1">
-                <a:solidFill>
-                  <a:srgbClr val="1A1A2E"/>
-                </a:solidFill>
-                <a:latin typeface="Cambria"/>
-              </a:rPr>
-              <a:t> + (1/L) A</a:t>
-            </a:r>
-            <a:r>
-              <a:rPr sz="1400" i="1" baseline="30000">
-                <a:solidFill>
-                  <a:srgbClr val="1A1A2E"/>
-                </a:solidFill>
-                <a:latin typeface="Cambria"/>
-              </a:rPr>
-              <a:t>T</a:t>
-            </a:r>
-            <a:r>
-              <a:rPr sz="2000" i="1">
-                <a:solidFill>
-                  <a:srgbClr val="1A1A2E"/>
-                </a:solidFill>
-                <a:latin typeface="Cambria"/>
-              </a:rPr>
-              <a:t>( b − A y</a:t>
-            </a:r>
-            <a:r>
-              <a:rPr sz="1400" i="1" baseline="30000">
-                <a:solidFill>
-                  <a:srgbClr val="1A1A2E"/>
-                </a:solidFill>
-                <a:latin typeface="Cambria"/>
-              </a:rPr>
-              <a:t>(k)</a:t>
-            </a:r>
-            <a:r>
-              <a:rPr sz="2000" i="1">
-                <a:solidFill>
-                  <a:srgbClr val="1A1A2E"/>
-                </a:solidFill>
-                <a:latin typeface="Cambria"/>
-              </a:rPr>
-              <a:t> ) )</a:t>
-            </a:r>
-          </a:p>
-        </p:txBody>
-      </p:sp>
+      <p:pic>
+        <p:nvPicPr>
+          <p:cNvPr id="10" name="Picture 9" descr="8deed43022a899f2.png"/>
+          <p:cNvPicPr>
+            <a:picLocks noChangeAspect="1"/>
+          </p:cNvPicPr>
+          <p:nvPr/>
+        </p:nvPicPr>
+        <p:blipFill>
+          <a:blip r:embed="rId3"/>
+          <a:stretch>
+            <a:fillRect/>
+          </a:stretch>
+        </p:blipFill>
+        <p:spPr>
+          <a:xfrm>
+            <a:off x="1849983" y="2715768"/>
+            <a:ext cx="8491728" cy="557784"/>
+          </a:xfrm>
+          <a:prstGeom prst="rect">
+            <a:avLst/>
+          </a:prstGeom>
+        </p:spPr>
+      </p:pic>
       <p:graphicFrame>
         <p:nvGraphicFramePr>
           <p:cNvPr id="11" name="Table 10"/>
@@ -15757,202 +15326,54 @@
           </a:p>
         </p:txBody>
       </p:sp>
-      <p:sp>
-        <p:nvSpPr>
-          <p:cNvPr id="10" name="TextBox 9"/>
-          <p:cNvSpPr txBox="1"/>
-          <p:nvPr/>
-        </p:nvSpPr>
-        <p:spPr>
-          <a:xfrm>
-            <a:off x="502920" y="2331720"/>
-            <a:ext cx="5478627" cy="411480"/>
-          </a:xfrm>
-          <a:prstGeom prst="rect">
-            <a:avLst/>
-          </a:prstGeom>
-          <a:noFill/>
-        </p:spPr>
-        <p:txBody>
-          <a:bodyPr wrap="none">
-            <a:spAutoFit/>
-          </a:bodyPr>
-          <a:lstStyle/>
-          <a:p>
-            <a:pPr algn="ctr"/>
-            <a:r>
-              <a:rPr sz="2000" i="1">
-                <a:solidFill>
-                  <a:srgbClr val="1A1A2E"/>
-                </a:solidFill>
-                <a:latin typeface="Cambria"/>
-              </a:rPr>
-              <a:t>z</a:t>
-            </a:r>
-            <a:r>
-              <a:rPr sz="1400" i="1" baseline="30000">
-                <a:solidFill>
-                  <a:srgbClr val="1A1A2E"/>
-                </a:solidFill>
-                <a:latin typeface="Cambria"/>
-              </a:rPr>
-              <a:t>(k)</a:t>
-            </a:r>
-            <a:r>
-              <a:rPr sz="2000" i="1">
-                <a:solidFill>
-                  <a:srgbClr val="1A1A2E"/>
-                </a:solidFill>
-                <a:latin typeface="Cambria"/>
-              </a:rPr>
-              <a:t> = x</a:t>
-            </a:r>
-            <a:r>
-              <a:rPr sz="1400" i="1" baseline="30000">
-                <a:solidFill>
-                  <a:srgbClr val="1A1A2E"/>
-                </a:solidFill>
-                <a:latin typeface="Cambria"/>
-              </a:rPr>
-              <a:t>(k)</a:t>
-            </a:r>
-            <a:r>
-              <a:rPr sz="2000" i="1">
-                <a:solidFill>
-                  <a:srgbClr val="1A1A2E"/>
-                </a:solidFill>
-                <a:latin typeface="Cambria"/>
-              </a:rPr>
-              <a:t> + (1/L) A</a:t>
-            </a:r>
-            <a:r>
-              <a:rPr sz="1400" i="1" baseline="30000">
-                <a:solidFill>
-                  <a:srgbClr val="1A1A2E"/>
-                </a:solidFill>
-                <a:latin typeface="Cambria"/>
-              </a:rPr>
-              <a:t>T</a:t>
-            </a:r>
-            <a:r>
-              <a:rPr sz="2000" i="1">
-                <a:solidFill>
-                  <a:srgbClr val="1A1A2E"/>
-                </a:solidFill>
-                <a:latin typeface="Cambria"/>
-              </a:rPr>
-              <a:t>( b − A x</a:t>
-            </a:r>
-            <a:r>
-              <a:rPr sz="1400" i="1" baseline="30000">
-                <a:solidFill>
-                  <a:srgbClr val="1A1A2E"/>
-                </a:solidFill>
-                <a:latin typeface="Cambria"/>
-              </a:rPr>
-              <a:t>(k)</a:t>
-            </a:r>
-            <a:r>
-              <a:rPr sz="2000" i="1">
-                <a:solidFill>
-                  <a:srgbClr val="1A1A2E"/>
-                </a:solidFill>
-                <a:latin typeface="Cambria"/>
-              </a:rPr>
-              <a:t> )</a:t>
-            </a:r>
-          </a:p>
-        </p:txBody>
-      </p:sp>
-      <p:sp>
-        <p:nvSpPr>
-          <p:cNvPr id="11" name="TextBox 10"/>
-          <p:cNvSpPr txBox="1"/>
-          <p:nvPr/>
-        </p:nvSpPr>
-        <p:spPr>
-          <a:xfrm>
-            <a:off x="502920" y="2971800"/>
-            <a:ext cx="5478627" cy="411480"/>
-          </a:xfrm>
-          <a:prstGeom prst="rect">
-            <a:avLst/>
-          </a:prstGeom>
-          <a:noFill/>
-        </p:spPr>
-        <p:txBody>
-          <a:bodyPr wrap="none">
-            <a:spAutoFit/>
-          </a:bodyPr>
-          <a:lstStyle/>
-          <a:p>
-            <a:pPr algn="ctr"/>
-            <a:r>
-              <a:rPr sz="2000" i="1">
-                <a:solidFill>
-                  <a:srgbClr val="1A1A2E"/>
-                </a:solidFill>
-                <a:latin typeface="Cambria"/>
-              </a:rPr>
-              <a:t>x</a:t>
-            </a:r>
-            <a:r>
-              <a:rPr sz="1400" i="1" baseline="30000">
-                <a:solidFill>
-                  <a:srgbClr val="1A1A2E"/>
-                </a:solidFill>
-                <a:latin typeface="Cambria"/>
-              </a:rPr>
-              <a:t>(k+1)</a:t>
-            </a:r>
-            <a:r>
-              <a:rPr sz="2000" i="1">
-                <a:solidFill>
-                  <a:srgbClr val="1A1A2E"/>
-                </a:solidFill>
-                <a:latin typeface="Cambria"/>
-              </a:rPr>
-              <a:t> = S</a:t>
-            </a:r>
-            <a:r>
-              <a:rPr sz="1400" i="1" baseline="-25000">
-                <a:solidFill>
-                  <a:srgbClr val="1A1A2E"/>
-                </a:solidFill>
-                <a:latin typeface="Cambria"/>
-              </a:rPr>
-              <a:t>θ</a:t>
-            </a:r>
-            <a:r>
-              <a:rPr sz="2000" i="1">
-                <a:solidFill>
-                  <a:srgbClr val="1A1A2E"/>
-                </a:solidFill>
-                <a:latin typeface="Cambria"/>
-              </a:rPr>
-              <a:t>( z</a:t>
-            </a:r>
-            <a:r>
-              <a:rPr sz="1400" i="1" baseline="30000">
-                <a:solidFill>
-                  <a:srgbClr val="1A1A2E"/>
-                </a:solidFill>
-                <a:latin typeface="Cambria"/>
-              </a:rPr>
-              <a:t>(k)</a:t>
-            </a:r>
-            <a:r>
-              <a:rPr sz="2000" i="1">
-                <a:solidFill>
-                  <a:srgbClr val="1A1A2E"/>
-                </a:solidFill>
-                <a:latin typeface="Cambria"/>
-              </a:rPr>
-              <a:t> )</a:t>
-            </a:r>
-          </a:p>
-        </p:txBody>
-      </p:sp>
+      <p:pic>
+        <p:nvPicPr>
+          <p:cNvPr id="10" name="Picture 9" descr="da2601d1aad8fa19.png"/>
+          <p:cNvPicPr>
+            <a:picLocks noChangeAspect="1"/>
+          </p:cNvPicPr>
+          <p:nvPr/>
+        </p:nvPicPr>
+        <p:blipFill>
+          <a:blip r:embed="rId2"/>
+          <a:stretch>
+            <a:fillRect/>
+          </a:stretch>
+        </p:blipFill>
+        <p:spPr>
+          <a:xfrm>
+            <a:off x="1539925" y="2350008"/>
+            <a:ext cx="3404616" cy="429768"/>
+          </a:xfrm>
+          <a:prstGeom prst="rect">
+            <a:avLst/>
+          </a:prstGeom>
+        </p:spPr>
+      </p:pic>
+      <p:pic>
+        <p:nvPicPr>
+          <p:cNvPr id="11" name="Picture 10" descr="73d90c265a8832d4.png"/>
+          <p:cNvPicPr>
+            <a:picLocks noChangeAspect="1"/>
+          </p:cNvPicPr>
+          <p:nvPr/>
+        </p:nvPicPr>
+        <p:blipFill>
+          <a:blip r:embed="rId3"/>
+          <a:stretch>
+            <a:fillRect/>
+          </a:stretch>
+        </p:blipFill>
+        <p:spPr>
+          <a:xfrm>
+            <a:off x="2224201" y="2990088"/>
+            <a:ext cx="2036064" cy="429768"/>
+          </a:xfrm>
+          <a:prstGeom prst="rect">
+            <a:avLst/>
+          </a:prstGeom>
+        </p:spPr>
+      </p:pic>
       <p:sp>
         <p:nvSpPr>
           <p:cNvPr id="12" name="TextBox 11"/>
@@ -16146,220 +15567,54 @@
           </a:p>
         </p:txBody>
       </p:sp>
-      <p:sp>
-        <p:nvSpPr>
-          <p:cNvPr id="17" name="TextBox 16"/>
-          <p:cNvSpPr txBox="1"/>
-          <p:nvPr/>
-        </p:nvSpPr>
-        <p:spPr>
-          <a:xfrm>
-            <a:off x="6210147" y="2331720"/>
-            <a:ext cx="5478627" cy="411480"/>
-          </a:xfrm>
-          <a:prstGeom prst="rect">
-            <a:avLst/>
-          </a:prstGeom>
-          <a:noFill/>
-        </p:spPr>
-        <p:txBody>
-          <a:bodyPr wrap="none">
-            <a:spAutoFit/>
-          </a:bodyPr>
-          <a:lstStyle/>
-          <a:p>
-            <a:pPr algn="ctr"/>
-            <a:r>
-              <a:rPr sz="2000" i="1">
-                <a:solidFill>
-                  <a:srgbClr val="1A1A2E"/>
-                </a:solidFill>
-                <a:latin typeface="Cambria"/>
-              </a:rPr>
-              <a:t>z</a:t>
-            </a:r>
-            <a:r>
-              <a:rPr sz="1400" i="1" baseline="30000">
-                <a:solidFill>
-                  <a:srgbClr val="1A1A2E"/>
-                </a:solidFill>
-                <a:latin typeface="Cambria"/>
-              </a:rPr>
-              <a:t>(k)</a:t>
-            </a:r>
-            <a:r>
-              <a:rPr sz="2000" i="1">
-                <a:solidFill>
-                  <a:srgbClr val="1A1A2E"/>
-                </a:solidFill>
-                <a:latin typeface="Cambria"/>
-              </a:rPr>
-              <a:t> = W</a:t>
-            </a:r>
-            <a:r>
-              <a:rPr sz="1400" i="1" baseline="-25000">
-                <a:solidFill>
-                  <a:srgbClr val="1A1A2E"/>
-                </a:solidFill>
-                <a:latin typeface="Cambria"/>
-              </a:rPr>
-              <a:t>x</a:t>
-            </a:r>
-            <a:r>
-              <a:rPr sz="1400" i="1" baseline="30000">
-                <a:solidFill>
-                  <a:srgbClr val="1A1A2E"/>
-                </a:solidFill>
-                <a:latin typeface="Cambria"/>
-              </a:rPr>
-              <a:t>(k)</a:t>
-            </a:r>
-            <a:r>
-              <a:rPr sz="2000" i="1">
-                <a:solidFill>
-                  <a:srgbClr val="1A1A2E"/>
-                </a:solidFill>
-                <a:latin typeface="Cambria"/>
-              </a:rPr>
-              <a:t> x</a:t>
-            </a:r>
-            <a:r>
-              <a:rPr sz="1400" i="1" baseline="30000">
-                <a:solidFill>
-                  <a:srgbClr val="1A1A2E"/>
-                </a:solidFill>
-                <a:latin typeface="Cambria"/>
-              </a:rPr>
-              <a:t>(k)</a:t>
-            </a:r>
-            <a:r>
-              <a:rPr sz="2000" i="1">
-                <a:solidFill>
-                  <a:srgbClr val="1A1A2E"/>
-                </a:solidFill>
-                <a:latin typeface="Cambria"/>
-              </a:rPr>
-              <a:t> + W</a:t>
-            </a:r>
-            <a:r>
-              <a:rPr sz="1400" i="1" baseline="-25000">
-                <a:solidFill>
-                  <a:srgbClr val="1A1A2E"/>
-                </a:solidFill>
-                <a:latin typeface="Cambria"/>
-              </a:rPr>
-              <a:t>y</a:t>
-            </a:r>
-            <a:r>
-              <a:rPr sz="1400" i="1" baseline="30000">
-                <a:solidFill>
-                  <a:srgbClr val="1A1A2E"/>
-                </a:solidFill>
-                <a:latin typeface="Cambria"/>
-              </a:rPr>
-              <a:t>(k)</a:t>
-            </a:r>
-            <a:r>
-              <a:rPr sz="2000" i="1">
-                <a:solidFill>
-                  <a:srgbClr val="1A1A2E"/>
-                </a:solidFill>
-                <a:latin typeface="Cambria"/>
-              </a:rPr>
-              <a:t> b</a:t>
-            </a:r>
-          </a:p>
-        </p:txBody>
-      </p:sp>
-      <p:sp>
-        <p:nvSpPr>
-          <p:cNvPr id="18" name="TextBox 17"/>
-          <p:cNvSpPr txBox="1"/>
-          <p:nvPr/>
-        </p:nvSpPr>
-        <p:spPr>
-          <a:xfrm>
-            <a:off x="6210147" y="2971800"/>
-            <a:ext cx="5478627" cy="411480"/>
-          </a:xfrm>
-          <a:prstGeom prst="rect">
-            <a:avLst/>
-          </a:prstGeom>
-          <a:noFill/>
-        </p:spPr>
-        <p:txBody>
-          <a:bodyPr wrap="none">
-            <a:spAutoFit/>
-          </a:bodyPr>
-          <a:lstStyle/>
-          <a:p>
-            <a:pPr algn="ctr"/>
-            <a:r>
-              <a:rPr sz="2000" i="1">
-                <a:solidFill>
-                  <a:srgbClr val="1A1A2E"/>
-                </a:solidFill>
-                <a:latin typeface="Cambria"/>
-              </a:rPr>
-              <a:t>x</a:t>
-            </a:r>
-            <a:r>
-              <a:rPr sz="1400" i="1" baseline="30000">
-                <a:solidFill>
-                  <a:srgbClr val="1A1A2E"/>
-                </a:solidFill>
-                <a:latin typeface="Cambria"/>
-              </a:rPr>
-              <a:t>(k+1)</a:t>
-            </a:r>
-            <a:r>
-              <a:rPr sz="2000" i="1">
-                <a:solidFill>
-                  <a:srgbClr val="1A1A2E"/>
-                </a:solidFill>
-                <a:latin typeface="Cambria"/>
-              </a:rPr>
-              <a:t> = S</a:t>
-            </a:r>
-            <a:r>
-              <a:rPr sz="1400" i="1" baseline="-25000">
-                <a:solidFill>
-                  <a:srgbClr val="1A1A2E"/>
-                </a:solidFill>
-                <a:latin typeface="Cambria"/>
-              </a:rPr>
-              <a:t>θₖ</a:t>
-            </a:r>
-            <a:r>
-              <a:rPr sz="2000" i="1">
-                <a:solidFill>
-                  <a:srgbClr val="1A1A2E"/>
-                </a:solidFill>
-                <a:latin typeface="Cambria"/>
-              </a:rPr>
-              <a:t>( z</a:t>
-            </a:r>
-            <a:r>
-              <a:rPr sz="1400" i="1" baseline="30000">
-                <a:solidFill>
-                  <a:srgbClr val="1A1A2E"/>
-                </a:solidFill>
-                <a:latin typeface="Cambria"/>
-              </a:rPr>
-              <a:t>(k)</a:t>
-            </a:r>
-            <a:r>
-              <a:rPr sz="2000" i="1">
-                <a:solidFill>
-                  <a:srgbClr val="1A1A2E"/>
-                </a:solidFill>
-                <a:latin typeface="Cambria"/>
-              </a:rPr>
-              <a:t> )</a:t>
-            </a:r>
-          </a:p>
-        </p:txBody>
-      </p:sp>
+      <p:pic>
+        <p:nvPicPr>
+          <p:cNvPr id="17" name="Picture 16" descr="1832ddb15122c01b.png"/>
+          <p:cNvPicPr>
+            <a:picLocks noChangeAspect="1"/>
+          </p:cNvPicPr>
+          <p:nvPr/>
+        </p:nvPicPr>
+        <p:blipFill>
+          <a:blip r:embed="rId4"/>
+          <a:stretch>
+            <a:fillRect/>
+          </a:stretch>
+        </p:blipFill>
+        <p:spPr>
+          <a:xfrm>
+            <a:off x="7544333" y="2350008"/>
+            <a:ext cx="2810256" cy="435864"/>
+          </a:xfrm>
+          <a:prstGeom prst="rect">
+            <a:avLst/>
+          </a:prstGeom>
+        </p:spPr>
+      </p:pic>
+      <p:pic>
+        <p:nvPicPr>
+          <p:cNvPr id="18" name="Picture 17" descr="10a2df3bf92ff791.png"/>
+          <p:cNvPicPr>
+            <a:picLocks noChangeAspect="1"/>
+          </p:cNvPicPr>
+          <p:nvPr/>
+        </p:nvPicPr>
+        <p:blipFill>
+          <a:blip r:embed="rId5"/>
+          <a:stretch>
+            <a:fillRect/>
+          </a:stretch>
+        </p:blipFill>
+        <p:spPr>
+          <a:xfrm>
+            <a:off x="7879613" y="2990088"/>
+            <a:ext cx="2139696" cy="429768"/>
+          </a:xfrm>
+          <a:prstGeom prst="rect">
+            <a:avLst/>
+          </a:prstGeom>
+        </p:spPr>
+      </p:pic>
       <p:sp>
         <p:nvSpPr>
           <p:cNvPr id="19" name="TextBox 18"/>
@@ -16907,149 +16162,30 @@
           </a:p>
         </p:txBody>
       </p:sp>
-      <p:sp>
-        <p:nvSpPr>
-          <p:cNvPr id="8" name="TextBox 7"/>
-          <p:cNvSpPr txBox="1"/>
-          <p:nvPr/>
-        </p:nvSpPr>
-        <p:spPr>
-          <a:xfrm>
-            <a:off x="502920" y="1572768"/>
-            <a:ext cx="6705295" cy="411480"/>
-          </a:xfrm>
-          <a:prstGeom prst="rect">
-            <a:avLst/>
-          </a:prstGeom>
-          <a:noFill/>
-        </p:spPr>
-        <p:txBody>
-          <a:bodyPr wrap="none">
-            <a:spAutoFit/>
-          </a:bodyPr>
-          <a:lstStyle/>
-          <a:p>
-            <a:pPr algn="ctr"/>
-            <a:r>
-              <a:rPr sz="2000" i="1">
-                <a:solidFill>
-                  <a:srgbClr val="1A1A2E"/>
-                </a:solidFill>
-                <a:latin typeface="Cambria"/>
-              </a:rPr>
-              <a:t>x</a:t>
-            </a:r>
-            <a:r>
-              <a:rPr sz="1400" i="1" baseline="30000">
-                <a:solidFill>
-                  <a:srgbClr val="1A1A2E"/>
-                </a:solidFill>
-                <a:latin typeface="Cambria"/>
-              </a:rPr>
-              <a:t>(k+1)</a:t>
-            </a:r>
-            <a:r>
-              <a:rPr sz="2000" i="1">
-                <a:solidFill>
-                  <a:srgbClr val="1A1A2E"/>
-                </a:solidFill>
-                <a:latin typeface="Cambria"/>
-              </a:rPr>
-              <a:t> = S</a:t>
-            </a:r>
-            <a:r>
-              <a:rPr sz="1400" i="1" baseline="-25000">
-                <a:solidFill>
-                  <a:srgbClr val="1A1A2E"/>
-                </a:solidFill>
-                <a:latin typeface="Cambria"/>
-              </a:rPr>
-              <a:t>θₖ</a:t>
-            </a:r>
-            <a:r>
-              <a:rPr sz="2000" i="1">
-                <a:solidFill>
-                  <a:srgbClr val="1A1A2E"/>
-                </a:solidFill>
-                <a:latin typeface="Cambria"/>
-              </a:rPr>
-              <a:t>( W</a:t>
-            </a:r>
-            <a:r>
-              <a:rPr sz="1400" i="1" baseline="-25000">
-                <a:solidFill>
-                  <a:srgbClr val="1A1A2E"/>
-                </a:solidFill>
-                <a:latin typeface="Cambria"/>
-              </a:rPr>
-              <a:t>x</a:t>
-            </a:r>
-            <a:r>
-              <a:rPr sz="1400" i="1" baseline="30000">
-                <a:solidFill>
-                  <a:srgbClr val="1A1A2E"/>
-                </a:solidFill>
-                <a:latin typeface="Cambria"/>
-              </a:rPr>
-              <a:t>(k)</a:t>
-            </a:r>
-            <a:r>
-              <a:rPr sz="2000" i="1">
-                <a:solidFill>
-                  <a:srgbClr val="1A1A2E"/>
-                </a:solidFill>
-                <a:latin typeface="Cambria"/>
-              </a:rPr>
-              <a:t> x</a:t>
-            </a:r>
-            <a:r>
-              <a:rPr sz="1400" i="1" baseline="30000">
-                <a:solidFill>
-                  <a:srgbClr val="1A1A2E"/>
-                </a:solidFill>
-                <a:latin typeface="Cambria"/>
-              </a:rPr>
-              <a:t>(k)</a:t>
-            </a:r>
-            <a:r>
-              <a:rPr sz="2000" i="1">
-                <a:solidFill>
-                  <a:srgbClr val="1A1A2E"/>
-                </a:solidFill>
-                <a:latin typeface="Cambria"/>
-              </a:rPr>
-              <a:t> + W</a:t>
-            </a:r>
-            <a:r>
-              <a:rPr sz="1400" i="1" baseline="-25000">
-                <a:solidFill>
-                  <a:srgbClr val="1A1A2E"/>
-                </a:solidFill>
-                <a:latin typeface="Cambria"/>
-              </a:rPr>
-              <a:t>y</a:t>
-            </a:r>
-            <a:r>
-              <a:rPr sz="1400" i="1" baseline="30000">
-                <a:solidFill>
-                  <a:srgbClr val="1A1A2E"/>
-                </a:solidFill>
-                <a:latin typeface="Cambria"/>
-              </a:rPr>
-              <a:t>(k)</a:t>
-            </a:r>
-            <a:r>
-              <a:rPr sz="2000" i="1">
-                <a:solidFill>
-                  <a:srgbClr val="1A1A2E"/>
-                </a:solidFill>
-                <a:latin typeface="Cambria"/>
-              </a:rPr>
-              <a:t> b )</a:t>
-            </a:r>
-          </a:p>
-        </p:txBody>
-      </p:sp>
+      <p:pic>
+        <p:nvPicPr>
+          <p:cNvPr id="8" name="Picture 7" descr="bb2cdae70b85d303.png"/>
+          <p:cNvPicPr>
+            <a:picLocks noChangeAspect="1"/>
+          </p:cNvPicPr>
+          <p:nvPr/>
+        </p:nvPicPr>
+        <p:blipFill>
+          <a:blip r:embed="rId2"/>
+          <a:stretch>
+            <a:fillRect/>
+          </a:stretch>
+        </p:blipFill>
+        <p:spPr>
+          <a:xfrm>
+            <a:off x="2032863" y="1591056"/>
+            <a:ext cx="3645408" cy="435864"/>
+          </a:xfrm>
+          <a:prstGeom prst="rect">
+            <a:avLst/>
+          </a:prstGeom>
+        </p:spPr>
+      </p:pic>
       <p:sp>
         <p:nvSpPr>
           <p:cNvPr id="9" name="TextBox 8"/>
@@ -17085,238 +16221,54 @@
           </a:p>
         </p:txBody>
       </p:sp>
-      <p:sp>
-        <p:nvSpPr>
-          <p:cNvPr id="10" name="TextBox 9"/>
-          <p:cNvSpPr txBox="1"/>
-          <p:nvPr/>
-        </p:nvSpPr>
-        <p:spPr>
-          <a:xfrm>
-            <a:off x="502920" y="2715768"/>
-            <a:ext cx="6705295" cy="411480"/>
-          </a:xfrm>
-          <a:prstGeom prst="rect">
-            <a:avLst/>
-          </a:prstGeom>
-          <a:noFill/>
-        </p:spPr>
-        <p:txBody>
-          <a:bodyPr wrap="none">
-            <a:spAutoFit/>
-          </a:bodyPr>
-          <a:lstStyle/>
-          <a:p>
-            <a:pPr algn="ctr"/>
-            <a:r>
-              <a:rPr sz="2000" i="1">
-                <a:solidFill>
-                  <a:srgbClr val="1A1A2E"/>
-                </a:solidFill>
-                <a:latin typeface="Cambria"/>
-              </a:rPr>
-              <a:t>W</a:t>
-            </a:r>
-            <a:r>
-              <a:rPr sz="1400" i="1" baseline="30000">
-                <a:solidFill>
-                  <a:srgbClr val="1A1A2E"/>
-                </a:solidFill>
-                <a:latin typeface="Cambria"/>
-              </a:rPr>
-              <a:t>*</a:t>
-            </a:r>
-            <a:r>
-              <a:rPr sz="2000" i="1">
-                <a:solidFill>
-                  <a:srgbClr val="1A1A2E"/>
-                </a:solidFill>
-                <a:latin typeface="Cambria"/>
-              </a:rPr>
-              <a:t> = ( A A</a:t>
-            </a:r>
-            <a:r>
-              <a:rPr sz="1400" i="1" baseline="30000">
-                <a:solidFill>
-                  <a:srgbClr val="1A1A2E"/>
-                </a:solidFill>
-                <a:latin typeface="Cambria"/>
-              </a:rPr>
-              <a:t>T</a:t>
-            </a:r>
-            <a:r>
-              <a:rPr sz="2000" i="1">
-                <a:solidFill>
-                  <a:srgbClr val="1A1A2E"/>
-                </a:solidFill>
-                <a:latin typeface="Cambria"/>
-              </a:rPr>
-              <a:t> )</a:t>
-            </a:r>
-            <a:r>
-              <a:rPr sz="1400" i="1" baseline="30000">
-                <a:solidFill>
-                  <a:srgbClr val="1A1A2E"/>
-                </a:solidFill>
-                <a:latin typeface="Cambria"/>
-              </a:rPr>
-              <a:t>−1</a:t>
-            </a:r>
-            <a:r>
-              <a:rPr sz="2000" i="1">
-                <a:solidFill>
-                  <a:srgbClr val="1A1A2E"/>
-                </a:solidFill>
-                <a:latin typeface="Cambria"/>
-              </a:rPr>
-              <a:t> A      (column-normalized)</a:t>
-            </a:r>
-          </a:p>
-        </p:txBody>
-      </p:sp>
-      <p:sp>
-        <p:nvSpPr>
-          <p:cNvPr id="11" name="TextBox 10"/>
-          <p:cNvSpPr txBox="1"/>
-          <p:nvPr/>
-        </p:nvSpPr>
-        <p:spPr>
-          <a:xfrm>
-            <a:off x="502920" y="3145536"/>
-            <a:ext cx="6705295" cy="411480"/>
-          </a:xfrm>
-          <a:prstGeom prst="rect">
-            <a:avLst/>
-          </a:prstGeom>
-          <a:noFill/>
-        </p:spPr>
-        <p:txBody>
-          <a:bodyPr wrap="none">
-            <a:spAutoFit/>
-          </a:bodyPr>
-          <a:lstStyle/>
-          <a:p>
-            <a:pPr algn="ctr"/>
-            <a:r>
-              <a:rPr sz="2000" i="1">
-                <a:solidFill>
-                  <a:srgbClr val="1A1A2E"/>
-                </a:solidFill>
-                <a:latin typeface="Cambria"/>
-              </a:rPr>
-              <a:t>x</a:t>
-            </a:r>
-            <a:r>
-              <a:rPr sz="1400" i="1" baseline="30000">
-                <a:solidFill>
-                  <a:srgbClr val="1A1A2E"/>
-                </a:solidFill>
-                <a:latin typeface="Cambria"/>
-              </a:rPr>
-              <a:t>(k+1)</a:t>
-            </a:r>
-            <a:r>
-              <a:rPr sz="2000" i="1">
-                <a:solidFill>
-                  <a:srgbClr val="1A1A2E"/>
-                </a:solidFill>
-                <a:latin typeface="Cambria"/>
-              </a:rPr>
-              <a:t> = S</a:t>
-            </a:r>
-            <a:r>
-              <a:rPr sz="1400" i="1" baseline="-25000">
-                <a:solidFill>
-                  <a:srgbClr val="1A1A2E"/>
-                </a:solidFill>
-                <a:latin typeface="Cambria"/>
-              </a:rPr>
-              <a:t>θₖ</a:t>
-            </a:r>
-            <a:r>
-              <a:rPr sz="2000" i="1">
-                <a:solidFill>
-                  <a:srgbClr val="1A1A2E"/>
-                </a:solidFill>
-                <a:latin typeface="Cambria"/>
-              </a:rPr>
-              <a:t>( x</a:t>
-            </a:r>
-            <a:r>
-              <a:rPr sz="1400" i="1" baseline="30000">
-                <a:solidFill>
-                  <a:srgbClr val="1A1A2E"/>
-                </a:solidFill>
-                <a:latin typeface="Cambria"/>
-              </a:rPr>
-              <a:t>(k)</a:t>
-            </a:r>
-            <a:r>
-              <a:rPr sz="2000" i="1">
-                <a:solidFill>
-                  <a:srgbClr val="1A1A2E"/>
-                </a:solidFill>
-                <a:latin typeface="Cambria"/>
-              </a:rPr>
-              <a:t> + γ</a:t>
-            </a:r>
-            <a:r>
-              <a:rPr sz="1400" i="1" baseline="-25000">
-                <a:solidFill>
-                  <a:srgbClr val="1A1A2E"/>
-                </a:solidFill>
-                <a:latin typeface="Cambria"/>
-              </a:rPr>
-              <a:t>k</a:t>
-            </a:r>
-            <a:r>
-              <a:rPr sz="2000" i="1">
-                <a:solidFill>
-                  <a:srgbClr val="1A1A2E"/>
-                </a:solidFill>
-                <a:latin typeface="Cambria"/>
-              </a:rPr>
-              <a:t> W</a:t>
-            </a:r>
-            <a:r>
-              <a:rPr sz="1400" i="1" baseline="30000">
-                <a:solidFill>
-                  <a:srgbClr val="1A1A2E"/>
-                </a:solidFill>
-                <a:latin typeface="Cambria"/>
-              </a:rPr>
-              <a:t>*T</a:t>
-            </a:r>
-            <a:r>
-              <a:rPr sz="2000" i="1">
-                <a:solidFill>
-                  <a:srgbClr val="1A1A2E"/>
-                </a:solidFill>
-                <a:latin typeface="Cambria"/>
-              </a:rPr>
-              <a:t>( b − A x</a:t>
-            </a:r>
-            <a:r>
-              <a:rPr sz="1400" i="1" baseline="30000">
-                <a:solidFill>
-                  <a:srgbClr val="1A1A2E"/>
-                </a:solidFill>
-                <a:latin typeface="Cambria"/>
-              </a:rPr>
-              <a:t>(k)</a:t>
-            </a:r>
-            <a:r>
-              <a:rPr sz="2000" i="1">
-                <a:solidFill>
-                  <a:srgbClr val="1A1A2E"/>
-                </a:solidFill>
-                <a:latin typeface="Cambria"/>
-              </a:rPr>
-              <a:t> ) )</a:t>
-            </a:r>
-          </a:p>
-        </p:txBody>
-      </p:sp>
+      <p:pic>
+        <p:nvPicPr>
+          <p:cNvPr id="10" name="Picture 9" descr="5034ec6801d0cb74.png"/>
+          <p:cNvPicPr>
+            <a:picLocks noChangeAspect="1"/>
+          </p:cNvPicPr>
+          <p:nvPr/>
+        </p:nvPicPr>
+        <p:blipFill>
+          <a:blip r:embed="rId3"/>
+          <a:stretch>
+            <a:fillRect/>
+          </a:stretch>
+        </p:blipFill>
+        <p:spPr>
+          <a:xfrm>
+            <a:off x="1569567" y="2734056"/>
+            <a:ext cx="4572000" cy="390144"/>
+          </a:xfrm>
+          <a:prstGeom prst="rect">
+            <a:avLst/>
+          </a:prstGeom>
+        </p:spPr>
+      </p:pic>
+      <p:pic>
+        <p:nvPicPr>
+          <p:cNvPr id="11" name="Picture 10" descr="1c3ab517067c9973.png"/>
+          <p:cNvPicPr>
+            <a:picLocks noChangeAspect="1"/>
+          </p:cNvPicPr>
+          <p:nvPr/>
+        </p:nvPicPr>
+        <p:blipFill>
+          <a:blip r:embed="rId4"/>
+          <a:stretch>
+            <a:fillRect/>
+          </a:stretch>
+        </p:blipFill>
+        <p:spPr>
+          <a:xfrm>
+            <a:off x="1632051" y="3163824"/>
+            <a:ext cx="4447032" cy="429768"/>
+          </a:xfrm>
+          <a:prstGeom prst="rect">
+            <a:avLst/>
+          </a:prstGeom>
+        </p:spPr>
+      </p:pic>
       <p:sp>
         <p:nvSpPr>
           <p:cNvPr id="12" name="TextBox 11"/>
@@ -17352,355 +16304,54 @@
           </a:p>
         </p:txBody>
       </p:sp>
-      <p:sp>
-        <p:nvSpPr>
-          <p:cNvPr id="13" name="TextBox 12"/>
-          <p:cNvSpPr txBox="1"/>
-          <p:nvPr/>
-        </p:nvSpPr>
-        <p:spPr>
-          <a:xfrm>
-            <a:off x="502920" y="4407408"/>
-            <a:ext cx="6705295" cy="411480"/>
-          </a:xfrm>
-          <a:prstGeom prst="rect">
-            <a:avLst/>
-          </a:prstGeom>
-          <a:noFill/>
-        </p:spPr>
-        <p:txBody>
-          <a:bodyPr wrap="none">
-            <a:spAutoFit/>
-          </a:bodyPr>
-          <a:lstStyle/>
-          <a:p>
-            <a:pPr algn="ctr"/>
-            <a:r>
-              <a:rPr sz="2000" i="1">
-                <a:solidFill>
-                  <a:srgbClr val="1A1A2E"/>
-                </a:solidFill>
-                <a:latin typeface="Cambria"/>
-              </a:rPr>
-              <a:t>θ</a:t>
-            </a:r>
-            <a:r>
-              <a:rPr sz="1400" i="1" baseline="30000">
-                <a:solidFill>
-                  <a:srgbClr val="1A1A2E"/>
-                </a:solidFill>
-                <a:latin typeface="Cambria"/>
-              </a:rPr>
-              <a:t>(k)</a:t>
-            </a:r>
-            <a:r>
-              <a:rPr sz="2000" i="1">
-                <a:solidFill>
-                  <a:srgbClr val="1A1A2E"/>
-                </a:solidFill>
-                <a:latin typeface="Cambria"/>
-              </a:rPr>
-              <a:t> = c</a:t>
-            </a:r>
-            <a:r>
-              <a:rPr sz="1400" i="1" baseline="-25000">
-                <a:solidFill>
-                  <a:srgbClr val="1A1A2E"/>
-                </a:solidFill>
-                <a:latin typeface="Cambria"/>
-              </a:rPr>
-              <a:t>1</a:t>
-            </a:r>
-            <a:r>
-              <a:rPr sz="2000" i="1">
-                <a:solidFill>
-                  <a:srgbClr val="1A1A2E"/>
-                </a:solidFill>
-                <a:latin typeface="Cambria"/>
-              </a:rPr>
-              <a:t> μ ‖ A</a:t>
-            </a:r>
-            <a:r>
-              <a:rPr sz="1400" i="1" baseline="30000">
-                <a:solidFill>
-                  <a:srgbClr val="1A1A2E"/>
-                </a:solidFill>
-                <a:latin typeface="Cambria"/>
-              </a:rPr>
-              <a:t>+</a:t>
-            </a:r>
-            <a:r>
-              <a:rPr sz="2000" i="1">
-                <a:solidFill>
-                  <a:srgbClr val="1A1A2E"/>
-                </a:solidFill>
-                <a:latin typeface="Cambria"/>
-              </a:rPr>
-              <a:t>( A x</a:t>
-            </a:r>
-            <a:r>
-              <a:rPr sz="1400" i="1" baseline="30000">
-                <a:solidFill>
-                  <a:srgbClr val="1A1A2E"/>
-                </a:solidFill>
-                <a:latin typeface="Cambria"/>
-              </a:rPr>
-              <a:t>(k)</a:t>
-            </a:r>
-            <a:r>
-              <a:rPr sz="2000" i="1">
-                <a:solidFill>
-                  <a:srgbClr val="1A1A2E"/>
-                </a:solidFill>
-                <a:latin typeface="Cambria"/>
-              </a:rPr>
-              <a:t> − b ) ‖</a:t>
-            </a:r>
-            <a:r>
-              <a:rPr sz="1400" i="1" baseline="-25000">
-                <a:solidFill>
-                  <a:srgbClr val="1A1A2E"/>
-                </a:solidFill>
-                <a:latin typeface="Cambria"/>
-              </a:rPr>
-              <a:t>1</a:t>
-            </a:r>
-            <a:r>
-              <a:rPr sz="2000" i="1">
-                <a:solidFill>
-                  <a:srgbClr val="1A1A2E"/>
-                </a:solidFill>
-                <a:latin typeface="Cambria"/>
-              </a:rPr>
-              <a:t> ,     β</a:t>
-            </a:r>
-            <a:r>
-              <a:rPr sz="1400" i="1" baseline="30000">
-                <a:solidFill>
-                  <a:srgbClr val="1A1A2E"/>
-                </a:solidFill>
-                <a:latin typeface="Cambria"/>
-              </a:rPr>
-              <a:t>(k)</a:t>
-            </a:r>
-            <a:r>
-              <a:rPr sz="2000" i="1">
-                <a:solidFill>
-                  <a:srgbClr val="1A1A2E"/>
-                </a:solidFill>
-                <a:latin typeface="Cambria"/>
-              </a:rPr>
-              <a:t> = c</a:t>
-            </a:r>
-            <a:r>
-              <a:rPr sz="1400" i="1" baseline="-25000">
-                <a:solidFill>
-                  <a:srgbClr val="1A1A2E"/>
-                </a:solidFill>
-                <a:latin typeface="Cambria"/>
-              </a:rPr>
-              <a:t>2</a:t>
-            </a:r>
-            <a:r>
-              <a:rPr sz="2000" i="1">
-                <a:solidFill>
-                  <a:srgbClr val="1A1A2E"/>
-                </a:solidFill>
-                <a:latin typeface="Cambria"/>
-              </a:rPr>
-              <a:t> μ ‖ x</a:t>
-            </a:r>
-            <a:r>
-              <a:rPr sz="1400" i="1" baseline="30000">
-                <a:solidFill>
-                  <a:srgbClr val="1A1A2E"/>
-                </a:solidFill>
-                <a:latin typeface="Cambria"/>
-              </a:rPr>
-              <a:t>(k)</a:t>
-            </a:r>
-            <a:r>
-              <a:rPr sz="2000" i="1">
-                <a:solidFill>
-                  <a:srgbClr val="1A1A2E"/>
-                </a:solidFill>
-                <a:latin typeface="Cambria"/>
-              </a:rPr>
-              <a:t> ‖</a:t>
-            </a:r>
-            <a:r>
-              <a:rPr sz="1400" i="1" baseline="-25000">
-                <a:solidFill>
-                  <a:srgbClr val="1A1A2E"/>
-                </a:solidFill>
-                <a:latin typeface="Cambria"/>
-              </a:rPr>
-              <a:t>0</a:t>
-            </a:r>
-          </a:p>
-        </p:txBody>
-      </p:sp>
-      <p:sp>
-        <p:nvSpPr>
-          <p:cNvPr id="14" name="TextBox 13"/>
-          <p:cNvSpPr txBox="1"/>
-          <p:nvPr/>
-        </p:nvSpPr>
-        <p:spPr>
-          <a:xfrm>
-            <a:off x="502920" y="4864608"/>
-            <a:ext cx="6705295" cy="411480"/>
-          </a:xfrm>
-          <a:prstGeom prst="rect">
-            <a:avLst/>
-          </a:prstGeom>
-          <a:noFill/>
-        </p:spPr>
-        <p:txBody>
-          <a:bodyPr wrap="none">
-            <a:spAutoFit/>
-          </a:bodyPr>
-          <a:lstStyle/>
-          <a:p>
-            <a:pPr algn="ctr"/>
-            <a:r>
-              <a:rPr sz="2000" i="1">
-                <a:solidFill>
-                  <a:srgbClr val="1A1A2E"/>
-                </a:solidFill>
-                <a:latin typeface="Cambria"/>
-              </a:rPr>
-              <a:t>p</a:t>
-            </a:r>
-            <a:r>
-              <a:rPr sz="1400" i="1" baseline="30000">
-                <a:solidFill>
-                  <a:srgbClr val="1A1A2E"/>
-                </a:solidFill>
-                <a:latin typeface="Cambria"/>
-              </a:rPr>
-              <a:t>(k)</a:t>
-            </a:r>
-            <a:r>
-              <a:rPr sz="2000" i="1">
-                <a:solidFill>
-                  <a:srgbClr val="1A1A2E"/>
-                </a:solidFill>
-                <a:latin typeface="Cambria"/>
-              </a:rPr>
-              <a:t> = c</a:t>
-            </a:r>
-            <a:r>
-              <a:rPr sz="1400" i="1" baseline="-25000">
-                <a:solidFill>
-                  <a:srgbClr val="1A1A2E"/>
-                </a:solidFill>
-                <a:latin typeface="Cambria"/>
-              </a:rPr>
-              <a:t>3</a:t>
-            </a:r>
-            <a:r>
-              <a:rPr sz="2000" i="1">
-                <a:solidFill>
-                  <a:srgbClr val="1A1A2E"/>
-                </a:solidFill>
-                <a:latin typeface="Cambria"/>
-              </a:rPr>
-              <a:t> log (  ‖ A</a:t>
-            </a:r>
-            <a:r>
-              <a:rPr sz="1400" i="1" baseline="30000">
-                <a:solidFill>
-                  <a:srgbClr val="1A1A2E"/>
-                </a:solidFill>
-                <a:latin typeface="Cambria"/>
-              </a:rPr>
-              <a:t>+</a:t>
-            </a:r>
-            <a:r>
-              <a:rPr sz="2000" i="1">
-                <a:solidFill>
-                  <a:srgbClr val="1A1A2E"/>
-                </a:solidFill>
-                <a:latin typeface="Cambria"/>
-              </a:rPr>
-              <a:t> b ‖</a:t>
-            </a:r>
-            <a:r>
-              <a:rPr sz="1400" i="1" baseline="-25000">
-                <a:solidFill>
-                  <a:srgbClr val="1A1A2E"/>
-                </a:solidFill>
-                <a:latin typeface="Cambria"/>
-              </a:rPr>
-              <a:t>1</a:t>
-            </a:r>
-            <a:r>
-              <a:rPr sz="2000" i="1">
-                <a:solidFill>
-                  <a:srgbClr val="1A1A2E"/>
-                </a:solidFill>
-                <a:latin typeface="Cambria"/>
-              </a:rPr>
-              <a:t>  /  ‖ A</a:t>
-            </a:r>
-            <a:r>
-              <a:rPr sz="1400" i="1" baseline="30000">
-                <a:solidFill>
-                  <a:srgbClr val="1A1A2E"/>
-                </a:solidFill>
-                <a:latin typeface="Cambria"/>
-              </a:rPr>
-              <a:t>+</a:t>
-            </a:r>
-            <a:r>
-              <a:rPr sz="2000" i="1">
-                <a:solidFill>
-                  <a:srgbClr val="1A1A2E"/>
-                </a:solidFill>
-                <a:latin typeface="Cambria"/>
-              </a:rPr>
-              <a:t>( A x</a:t>
-            </a:r>
-            <a:r>
-              <a:rPr sz="1400" i="1" baseline="30000">
-                <a:solidFill>
-                  <a:srgbClr val="1A1A2E"/>
-                </a:solidFill>
-                <a:latin typeface="Cambria"/>
-              </a:rPr>
-              <a:t>(k)</a:t>
-            </a:r>
-            <a:r>
-              <a:rPr sz="2000" i="1">
-                <a:solidFill>
-                  <a:srgbClr val="1A1A2E"/>
-                </a:solidFill>
-                <a:latin typeface="Cambria"/>
-              </a:rPr>
-              <a:t> − b ) ‖</a:t>
-            </a:r>
-            <a:r>
-              <a:rPr sz="1400" i="1" baseline="-25000">
-                <a:solidFill>
-                  <a:srgbClr val="1A1A2E"/>
-                </a:solidFill>
-                <a:latin typeface="Cambria"/>
-              </a:rPr>
-              <a:t>1</a:t>
-            </a:r>
-            <a:r>
-              <a:rPr sz="2000" i="1">
-                <a:solidFill>
-                  <a:srgbClr val="1A1A2E"/>
-                </a:solidFill>
-                <a:latin typeface="Cambria"/>
-              </a:rPr>
-              <a:t>  )</a:t>
-            </a:r>
-          </a:p>
-        </p:txBody>
-      </p:sp>
+      <p:pic>
+        <p:nvPicPr>
+          <p:cNvPr id="13" name="Picture 12" descr="1865d34b0371d61a.png"/>
+          <p:cNvPicPr>
+            <a:picLocks noChangeAspect="1"/>
+          </p:cNvPicPr>
+          <p:nvPr/>
+        </p:nvPicPr>
+        <p:blipFill>
+          <a:blip r:embed="rId5"/>
+          <a:stretch>
+            <a:fillRect/>
+          </a:stretch>
+        </p:blipFill>
+        <p:spPr>
+          <a:xfrm>
+            <a:off x="982827" y="4425696"/>
+            <a:ext cx="5745480" cy="402336"/>
+          </a:xfrm>
+          <a:prstGeom prst="rect">
+            <a:avLst/>
+          </a:prstGeom>
+        </p:spPr>
+      </p:pic>
+      <p:pic>
+        <p:nvPicPr>
+          <p:cNvPr id="14" name="Picture 13" descr="a4a39126b67fa50c.png"/>
+          <p:cNvPicPr>
+            <a:picLocks noChangeAspect="1"/>
+          </p:cNvPicPr>
+          <p:nvPr/>
+        </p:nvPicPr>
+        <p:blipFill>
+          <a:blip r:embed="rId6"/>
+          <a:stretch>
+            <a:fillRect/>
+          </a:stretch>
+        </p:blipFill>
+        <p:spPr>
+          <a:xfrm>
+            <a:off x="2104491" y="4864608"/>
+            <a:ext cx="3502152" cy="716280"/>
+          </a:xfrm>
+          <a:prstGeom prst="rect">
+            <a:avLst/>
+          </a:prstGeom>
+        </p:spPr>
+      </p:pic>
       <p:graphicFrame>
         <p:nvGraphicFramePr>
           <p:cNvPr id="15" name="Table 14"/>
@@ -18686,149 +17337,30 @@
           </a:p>
         </p:txBody>
       </p:sp>
-      <p:sp>
-        <p:nvSpPr>
-          <p:cNvPr id="9" name="TextBox 8"/>
-          <p:cNvSpPr txBox="1"/>
-          <p:nvPr/>
-        </p:nvSpPr>
-        <p:spPr>
-          <a:xfrm>
-            <a:off x="502920" y="2084831"/>
-            <a:ext cx="11185855" cy="411480"/>
-          </a:xfrm>
-          <a:prstGeom prst="rect">
-            <a:avLst/>
-          </a:prstGeom>
-          <a:noFill/>
-        </p:spPr>
-        <p:txBody>
-          <a:bodyPr wrap="none">
-            <a:spAutoFit/>
-          </a:bodyPr>
-          <a:lstStyle/>
-          <a:p>
-            <a:pPr algn="ctr"/>
-            <a:r>
-              <a:rPr sz="2000" i="1">
-                <a:solidFill>
-                  <a:srgbClr val="1A1A2E"/>
-                </a:solidFill>
-                <a:latin typeface="Cambria"/>
-              </a:rPr>
-              <a:t>x</a:t>
-            </a:r>
-            <a:r>
-              <a:rPr sz="1400" i="1" baseline="30000">
-                <a:solidFill>
-                  <a:srgbClr val="1A1A2E"/>
-                </a:solidFill>
-                <a:latin typeface="Cambria"/>
-              </a:rPr>
-              <a:t>(k+1)</a:t>
-            </a:r>
-            <a:r>
-              <a:rPr sz="2000" i="1">
-                <a:solidFill>
-                  <a:srgbClr val="1A1A2E"/>
-                </a:solidFill>
-                <a:latin typeface="Cambria"/>
-              </a:rPr>
-              <a:t> = S</a:t>
-            </a:r>
-            <a:r>
-              <a:rPr sz="1400" i="1" baseline="-25000">
-                <a:solidFill>
-                  <a:srgbClr val="1A1A2E"/>
-                </a:solidFill>
-                <a:latin typeface="Cambria"/>
-              </a:rPr>
-              <a:t>θₖ</a:t>
-            </a:r>
-            <a:r>
-              <a:rPr sz="2000" i="1">
-                <a:solidFill>
-                  <a:srgbClr val="1A1A2E"/>
-                </a:solidFill>
-                <a:latin typeface="Cambria"/>
-              </a:rPr>
-              <a:t>( x</a:t>
-            </a:r>
-            <a:r>
-              <a:rPr sz="1400" i="1" baseline="30000">
-                <a:solidFill>
-                  <a:srgbClr val="1A1A2E"/>
-                </a:solidFill>
-                <a:latin typeface="Cambria"/>
-              </a:rPr>
-              <a:t>(k)</a:t>
-            </a:r>
-            <a:r>
-              <a:rPr sz="2000" i="1">
-                <a:solidFill>
-                  <a:srgbClr val="1A1A2E"/>
-                </a:solidFill>
-                <a:latin typeface="Cambria"/>
-              </a:rPr>
-              <a:t> + γ</a:t>
-            </a:r>
-            <a:r>
-              <a:rPr sz="1400" i="1" baseline="-25000">
-                <a:solidFill>
-                  <a:srgbClr val="1A1A2E"/>
-                </a:solidFill>
-                <a:latin typeface="Cambria"/>
-              </a:rPr>
-              <a:t>k</a:t>
-            </a:r>
-            <a:r>
-              <a:rPr sz="2000" i="1">
-                <a:solidFill>
-                  <a:srgbClr val="1A1A2E"/>
-                </a:solidFill>
-                <a:latin typeface="Cambria"/>
-              </a:rPr>
-              <a:t> A</a:t>
-            </a:r>
-            <a:r>
-              <a:rPr sz="1400" i="1" baseline="30000">
-                <a:solidFill>
-                  <a:srgbClr val="1A1A2E"/>
-                </a:solidFill>
-                <a:latin typeface="Cambria"/>
-              </a:rPr>
-              <a:t>T</a:t>
-            </a:r>
-            <a:r>
-              <a:rPr sz="2000" i="1">
-                <a:solidFill>
-                  <a:srgbClr val="1A1A2E"/>
-                </a:solidFill>
-                <a:latin typeface="Cambria"/>
-              </a:rPr>
-              <a:t>( b − A x</a:t>
-            </a:r>
-            <a:r>
-              <a:rPr sz="1400" i="1" baseline="30000">
-                <a:solidFill>
-                  <a:srgbClr val="1A1A2E"/>
-                </a:solidFill>
-                <a:latin typeface="Cambria"/>
-              </a:rPr>
-              <a:t>(k)</a:t>
-            </a:r>
-            <a:r>
-              <a:rPr sz="2000" i="1">
-                <a:solidFill>
-                  <a:srgbClr val="1A1A2E"/>
-                </a:solidFill>
-                <a:latin typeface="Cambria"/>
-              </a:rPr>
-              <a:t> ) )</a:t>
-            </a:r>
-          </a:p>
-        </p:txBody>
-      </p:sp>
+      <p:pic>
+        <p:nvPicPr>
+          <p:cNvPr id="9" name="Picture 8" descr="3e1035065db8020b.png"/>
+          <p:cNvPicPr>
+            <a:picLocks noChangeAspect="1"/>
+          </p:cNvPicPr>
+          <p:nvPr/>
+        </p:nvPicPr>
+        <p:blipFill>
+          <a:blip r:embed="rId2"/>
+          <a:stretch>
+            <a:fillRect/>
+          </a:stretch>
+        </p:blipFill>
+        <p:spPr>
+          <a:xfrm>
+            <a:off x="3966819" y="2084831"/>
+            <a:ext cx="4258056" cy="429768"/>
+          </a:xfrm>
+          <a:prstGeom prst="rect">
+            <a:avLst/>
+          </a:prstGeom>
+        </p:spPr>
+      </p:pic>
       <p:sp>
         <p:nvSpPr>
           <p:cNvPr id="10" name="TextBox 9"/>
@@ -21005,86 +19537,30 @@
           </a:p>
         </p:txBody>
       </p:sp>
-      <p:sp>
-        <p:nvSpPr>
-          <p:cNvPr id="10" name="TextBox 9"/>
-          <p:cNvSpPr txBox="1"/>
-          <p:nvPr/>
-        </p:nvSpPr>
-        <p:spPr>
-          <a:xfrm>
-            <a:off x="502920" y="2240280"/>
-            <a:ext cx="3652418" cy="411480"/>
-          </a:xfrm>
-          <a:prstGeom prst="rect">
-            <a:avLst/>
-          </a:prstGeom>
-          <a:noFill/>
-        </p:spPr>
-        <p:txBody>
-          <a:bodyPr wrap="none">
-            <a:spAutoFit/>
-          </a:bodyPr>
-          <a:lstStyle/>
-          <a:p>
-            <a:pPr algn="ctr"/>
-            <a:r>
-              <a:rPr sz="2000" i="1">
-                <a:solidFill>
-                  <a:srgbClr val="1A1A2E"/>
-                </a:solidFill>
-                <a:latin typeface="Cambria"/>
-              </a:rPr>
-              <a:t>L = ‖ x</a:t>
-            </a:r>
-            <a:r>
-              <a:rPr sz="1400" i="1" baseline="30000">
-                <a:solidFill>
-                  <a:srgbClr val="1A1A2E"/>
-                </a:solidFill>
-                <a:latin typeface="Cambria"/>
-              </a:rPr>
-              <a:t>(K)</a:t>
-            </a:r>
-            <a:r>
-              <a:rPr sz="2000" i="1">
-                <a:solidFill>
-                  <a:srgbClr val="1A1A2E"/>
-                </a:solidFill>
-                <a:latin typeface="Cambria"/>
-              </a:rPr>
-              <a:t> − x</a:t>
-            </a:r>
-            <a:r>
-              <a:rPr sz="1400" i="1" baseline="30000">
-                <a:solidFill>
-                  <a:srgbClr val="1A1A2E"/>
-                </a:solidFill>
-                <a:latin typeface="Cambria"/>
-              </a:rPr>
-              <a:t>*</a:t>
-            </a:r>
-            <a:r>
-              <a:rPr sz="2000" i="1">
-                <a:solidFill>
-                  <a:srgbClr val="1A1A2E"/>
-                </a:solidFill>
-                <a:latin typeface="Cambria"/>
-              </a:rPr>
-              <a:t> ‖</a:t>
-            </a:r>
-            <a:r>
-              <a:rPr sz="1400" i="1" baseline="30000">
-                <a:solidFill>
-                  <a:srgbClr val="1A1A2E"/>
-                </a:solidFill>
-                <a:latin typeface="Cambria"/>
-              </a:rPr>
-              <a:t>2</a:t>
-            </a:r>
-          </a:p>
-        </p:txBody>
-      </p:sp>
+      <p:pic>
+        <p:nvPicPr>
+          <p:cNvPr id="10" name="Picture 9" descr="d25ef180049c1210.png"/>
+          <p:cNvPicPr>
+            <a:picLocks noChangeAspect="1"/>
+          </p:cNvPicPr>
+          <p:nvPr/>
+        </p:nvPicPr>
+        <p:blipFill>
+          <a:blip r:embed="rId2"/>
+          <a:stretch>
+            <a:fillRect/>
+          </a:stretch>
+        </p:blipFill>
+        <p:spPr>
+          <a:xfrm>
+            <a:off x="1407414" y="2176272"/>
+            <a:ext cx="1843430" cy="362102"/>
+          </a:xfrm>
+          <a:prstGeom prst="rect">
+            <a:avLst/>
+          </a:prstGeom>
+        </p:spPr>
+      </p:pic>
       <p:sp>
         <p:nvSpPr>
           <p:cNvPr id="11" name="TextBox 10"/>
@@ -21201,122 +19677,30 @@
           </a:p>
         </p:txBody>
       </p:sp>
-      <p:sp>
-        <p:nvSpPr>
-          <p:cNvPr id="14" name="TextBox 13"/>
-          <p:cNvSpPr txBox="1"/>
-          <p:nvPr/>
-        </p:nvSpPr>
-        <p:spPr>
-          <a:xfrm>
-            <a:off x="4223918" y="2240280"/>
-            <a:ext cx="3652418" cy="411480"/>
-          </a:xfrm>
-          <a:prstGeom prst="rect">
-            <a:avLst/>
-          </a:prstGeom>
-          <a:noFill/>
-        </p:spPr>
-        <p:txBody>
-          <a:bodyPr wrap="none">
-            <a:spAutoFit/>
-          </a:bodyPr>
-          <a:lstStyle/>
-          <a:p>
-            <a:pPr algn="ctr"/>
-            <a:r>
-              <a:rPr sz="2000" i="1">
-                <a:solidFill>
-                  <a:srgbClr val="1A1A2E"/>
-                </a:solidFill>
-                <a:latin typeface="Cambria"/>
-              </a:rPr>
-              <a:t>L = Σ</a:t>
-            </a:r>
-            <a:r>
-              <a:rPr sz="1400" i="1" baseline="-25000">
-                <a:solidFill>
-                  <a:srgbClr val="1A1A2E"/>
-                </a:solidFill>
-                <a:latin typeface="Cambria"/>
-              </a:rPr>
-              <a:t>k</a:t>
-            </a:r>
-            <a:r>
-              <a:rPr sz="2000" i="1">
-                <a:solidFill>
-                  <a:srgbClr val="1A1A2E"/>
-                </a:solidFill>
-                <a:latin typeface="Cambria"/>
-              </a:rPr>
-              <a:t> w</a:t>
-            </a:r>
-            <a:r>
-              <a:rPr sz="1400" i="1" baseline="-25000">
-                <a:solidFill>
-                  <a:srgbClr val="1A1A2E"/>
-                </a:solidFill>
-                <a:latin typeface="Cambria"/>
-              </a:rPr>
-              <a:t>k</a:t>
-            </a:r>
-            <a:r>
-              <a:rPr sz="2000" i="1">
-                <a:solidFill>
-                  <a:srgbClr val="1A1A2E"/>
-                </a:solidFill>
-                <a:latin typeface="Cambria"/>
-              </a:rPr>
-              <a:t> ‖ x</a:t>
-            </a:r>
-            <a:r>
-              <a:rPr sz="1400" i="1" baseline="30000">
-                <a:solidFill>
-                  <a:srgbClr val="1A1A2E"/>
-                </a:solidFill>
-                <a:latin typeface="Cambria"/>
-              </a:rPr>
-              <a:t>(k)</a:t>
-            </a:r>
-            <a:r>
-              <a:rPr sz="2000" i="1">
-                <a:solidFill>
-                  <a:srgbClr val="1A1A2E"/>
-                </a:solidFill>
-                <a:latin typeface="Cambria"/>
-              </a:rPr>
-              <a:t> − x</a:t>
-            </a:r>
-            <a:r>
-              <a:rPr sz="1400" i="1" baseline="30000">
-                <a:solidFill>
-                  <a:srgbClr val="1A1A2E"/>
-                </a:solidFill>
-                <a:latin typeface="Cambria"/>
-              </a:rPr>
-              <a:t>*</a:t>
-            </a:r>
-            <a:r>
-              <a:rPr sz="2000" i="1">
-                <a:solidFill>
-                  <a:srgbClr val="1A1A2E"/>
-                </a:solidFill>
-                <a:latin typeface="Cambria"/>
-              </a:rPr>
-              <a:t> ‖</a:t>
-            </a:r>
-            <a:r>
-              <a:rPr sz="1400" i="1" baseline="30000">
-                <a:solidFill>
-                  <a:srgbClr val="1A1A2E"/>
-                </a:solidFill>
-                <a:latin typeface="Cambria"/>
-              </a:rPr>
-              <a:t>2</a:t>
-            </a:r>
-          </a:p>
-        </p:txBody>
-      </p:sp>
+      <p:pic>
+        <p:nvPicPr>
+          <p:cNvPr id="14" name="Picture 13" descr="48cfcd04f3cb2912.png"/>
+          <p:cNvPicPr>
+            <a:picLocks noChangeAspect="1"/>
+          </p:cNvPicPr>
+          <p:nvPr/>
+        </p:nvPicPr>
+        <p:blipFill>
+          <a:blip r:embed="rId3"/>
+          <a:stretch>
+            <a:fillRect/>
+          </a:stretch>
+        </p:blipFill>
+        <p:spPr>
+          <a:xfrm>
+            <a:off x="4826660" y="2176272"/>
+            <a:ext cx="2446934" cy="362102"/>
+          </a:xfrm>
+          <a:prstGeom prst="rect">
+            <a:avLst/>
+          </a:prstGeom>
+        </p:spPr>
+      </p:pic>
       <p:sp>
         <p:nvSpPr>
           <p:cNvPr id="15" name="TextBox 14"/>
@@ -21433,104 +19817,30 @@
           </a:p>
         </p:txBody>
       </p:sp>
-      <p:sp>
-        <p:nvSpPr>
-          <p:cNvPr id="18" name="TextBox 17"/>
-          <p:cNvSpPr txBox="1"/>
-          <p:nvPr/>
-        </p:nvSpPr>
-        <p:spPr>
-          <a:xfrm>
-            <a:off x="7944916" y="2240280"/>
-            <a:ext cx="3652418" cy="411480"/>
-          </a:xfrm>
-          <a:prstGeom prst="rect">
-            <a:avLst/>
-          </a:prstGeom>
-          <a:noFill/>
-        </p:spPr>
-        <p:txBody>
-          <a:bodyPr wrap="none">
-            <a:spAutoFit/>
-          </a:bodyPr>
-          <a:lstStyle/>
-          <a:p>
-            <a:pPr algn="ctr"/>
-            <a:r>
-              <a:rPr sz="2000" i="1">
-                <a:solidFill>
-                  <a:srgbClr val="1A1A2E"/>
-                </a:solidFill>
-                <a:latin typeface="Cambria"/>
-              </a:rPr>
-              <a:t>min</a:t>
-            </a:r>
-            <a:r>
-              <a:rPr sz="1400" i="1" baseline="-25000">
-                <a:solidFill>
-                  <a:srgbClr val="1A1A2E"/>
-                </a:solidFill>
-                <a:latin typeface="Cambria"/>
-              </a:rPr>
-              <a:t>θₖ</a:t>
-            </a:r>
-            <a:r>
-              <a:rPr sz="2000" i="1">
-                <a:solidFill>
-                  <a:srgbClr val="1A1A2E"/>
-                </a:solidFill>
-                <a:latin typeface="Cambria"/>
-              </a:rPr>
-              <a:t> ‖ x</a:t>
-            </a:r>
-            <a:r>
-              <a:rPr sz="1400" i="1" baseline="30000">
-                <a:solidFill>
-                  <a:srgbClr val="1A1A2E"/>
-                </a:solidFill>
-                <a:latin typeface="Cambria"/>
-              </a:rPr>
-              <a:t>(k)</a:t>
-            </a:r>
-            <a:r>
-              <a:rPr sz="2000" i="1">
-                <a:solidFill>
-                  <a:srgbClr val="1A1A2E"/>
-                </a:solidFill>
-                <a:latin typeface="Cambria"/>
-              </a:rPr>
-              <a:t> − x</a:t>
-            </a:r>
-            <a:r>
-              <a:rPr sz="1400" i="1" baseline="30000">
-                <a:solidFill>
-                  <a:srgbClr val="1A1A2E"/>
-                </a:solidFill>
-                <a:latin typeface="Cambria"/>
-              </a:rPr>
-              <a:t>*</a:t>
-            </a:r>
-            <a:r>
-              <a:rPr sz="2000" i="1">
-                <a:solidFill>
-                  <a:srgbClr val="1A1A2E"/>
-                </a:solidFill>
-                <a:latin typeface="Cambria"/>
-              </a:rPr>
-              <a:t> ‖</a:t>
-            </a:r>
-            <a:r>
-              <a:rPr sz="1400" i="1" baseline="30000">
-                <a:solidFill>
-                  <a:srgbClr val="1A1A2E"/>
-                </a:solidFill>
-                <a:latin typeface="Cambria"/>
-              </a:rPr>
-              <a:t>2</a:t>
-            </a:r>
-          </a:p>
-        </p:txBody>
-      </p:sp>
+      <p:pic>
+        <p:nvPicPr>
+          <p:cNvPr id="18" name="Picture 17" descr="7c386acad099310c.png"/>
+          <p:cNvPicPr>
+            <a:picLocks noChangeAspect="1"/>
+          </p:cNvPicPr>
+          <p:nvPr/>
+        </p:nvPicPr>
+        <p:blipFill>
+          <a:blip r:embed="rId4"/>
+          <a:stretch>
+            <a:fillRect/>
+          </a:stretch>
+        </p:blipFill>
+        <p:spPr>
+          <a:xfrm>
+            <a:off x="8883700" y="2176272"/>
+            <a:ext cx="1774850" cy="502005"/>
+          </a:xfrm>
+          <a:prstGeom prst="rect">
+            <a:avLst/>
+          </a:prstGeom>
+        </p:spPr>
+      </p:pic>
       <p:sp>
         <p:nvSpPr>
           <p:cNvPr id="19" name="TextBox 18"/>
@@ -21576,7 +19886,7 @@
           <p:nvPr/>
         </p:nvPicPr>
         <p:blipFill>
-          <a:blip r:embed="rId2"/>
+          <a:blip r:embed="rId5"/>
           <a:stretch>
             <a:fillRect/>
           </a:stretch>

</xml_diff>

<commit_message>
Polish math notation in cards/tables and fix crowding on slides 7 and 12
- slide 5 card captions and slide 7 card body lines rendered as LaTeX
  (no more underscore notation like theta_k / W_x)
- slides 8, 11, 15: proper subscript glyphs in card and table text
- slide 7: spaced out the three intro lines
- slide 12: setup split into two lines, table and cards moved down

Co-Authored-By: Claude Fable 5 <noreply@anthropic.com>
</commit_message>
<xml_diff>
--- a/submission/MBDL_Seminar_Presentation.pptx
+++ b/submission/MBDL_Seminar_Presentation.pptx
@@ -6376,7 +6376,7 @@
                         </a:defRPr>
                       </a:pPr>
                       <a:r>
-                        <a:t>learned θ_k</a:t>
+                        <a:t>learned θₖ</a:t>
                       </a:r>
                     </a:p>
                   </a:txBody>
@@ -6462,7 +6462,7 @@
                         </a:defRPr>
                       </a:pPr>
                       <a:r>
-                        <a:t>learned γ_k</a:t>
+                        <a:t>learned γₖ</a:t>
                       </a:r>
                     </a:p>
                   </a:txBody>
@@ -6560,7 +6560,7 @@
                         </a:defRPr>
                       </a:pPr>
                       <a:r>
-                        <a:t>γ_k + θ_k</a:t>
+                        <a:t>γₖ + θₖ</a:t>
                       </a:r>
                     </a:p>
                   </a:txBody>
@@ -6939,7 +6939,7 @@
                 </a:solidFill>
                 <a:latin typeface="Calibri"/>
               </a:rPr>
-              <a:t>The step-size schedule γ_k is the bottleneck.</a:t>
+              <a:t>The step-size schedule γₖ is the bottleneck.</a:t>
             </a:r>
           </a:p>
         </p:txBody>
@@ -7176,8 +7176,8 @@
         </p:nvSpPr>
         <p:spPr>
           <a:xfrm>
-            <a:off x="502920" y="1188720"/>
-            <a:ext cx="11185855" cy="347472"/>
+            <a:off x="502920" y="1143000"/>
+            <a:ext cx="11185855" cy="685800"/>
           </a:xfrm>
           <a:prstGeom prst="rect">
             <a:avLst/>
@@ -7198,7 +7198,8 @@
                 </a:solidFill>
                 <a:latin typeface="Calibri"/>
               </a:rPr>
-              <a:t>Setup:  flatten 28×28 image to x ∈ [0,1]^{784},  measure  b = Ax,  ratio m/784 ∈ {0.25, 0.5}.  FashionMNIST: ~51.5% of pixels exactly zero.</a:t>
+              <a:t>Setup:  flatten 28×28 image to x ∈ [0,1]^784,  measure  b = Ax,  ratio m/784 ∈ {0.25, 0.5}.
+FashionMNIST: ~51.5% of pixels exactly zero.</a:t>
             </a:r>
           </a:p>
         </p:txBody>
@@ -7212,7 +7213,7 @@
           <p:nvPr/>
         </p:nvGraphicFramePr>
         <p:xfrm>
-          <a:off x="502920" y="1691640"/>
+          <a:off x="502920" y="2011680"/>
           <a:ext cx="6126480" cy="2112264"/>
         </p:xfrm>
         <a:graphic>
@@ -8019,7 +8020,7 @@
         </p:nvSpPr>
         <p:spPr>
           <a:xfrm>
-            <a:off x="502920" y="4572000"/>
+            <a:off x="502920" y="4343400"/>
             <a:ext cx="6400800" cy="274320"/>
           </a:xfrm>
           <a:prstGeom prst="rect">
@@ -8054,7 +8055,7 @@
         </p:nvSpPr>
         <p:spPr>
           <a:xfrm>
-            <a:off x="7086600" y="1691640"/>
+            <a:off x="7086600" y="2011680"/>
             <a:ext cx="4754880" cy="1600200"/>
           </a:xfrm>
           <a:prstGeom prst="rect">
@@ -8099,7 +8100,7 @@
         </p:nvSpPr>
         <p:spPr>
           <a:xfrm>
-            <a:off x="7086600" y="1691640"/>
+            <a:off x="7086600" y="2011680"/>
             <a:ext cx="50292" cy="1600200"/>
           </a:xfrm>
           <a:prstGeom prst="rect">
@@ -8142,7 +8143,7 @@
         </p:nvSpPr>
         <p:spPr>
           <a:xfrm>
-            <a:off x="7278624" y="1801368"/>
+            <a:off x="7278624" y="2121408"/>
             <a:ext cx="4425696" cy="1380744"/>
           </a:xfrm>
           <a:prstGeom prst="rect">
@@ -8242,7 +8243,7 @@
         </p:nvSpPr>
         <p:spPr>
           <a:xfrm>
-            <a:off x="7086600" y="3429000"/>
+            <a:off x="7086600" y="3749039"/>
             <a:ext cx="4754880" cy="1600200"/>
           </a:xfrm>
           <a:prstGeom prst="rect">
@@ -8287,7 +8288,7 @@
         </p:nvSpPr>
         <p:spPr>
           <a:xfrm>
-            <a:off x="7086600" y="3429000"/>
+            <a:off x="7086600" y="3749039"/>
             <a:ext cx="50292" cy="1600200"/>
           </a:xfrm>
           <a:prstGeom prst="rect">
@@ -8330,7 +8331,7 @@
         </p:nvSpPr>
         <p:spPr>
           <a:xfrm>
-            <a:off x="7278624" y="3538728"/>
+            <a:off x="7278624" y="3858767"/>
             <a:ext cx="4425696" cy="1380744"/>
           </a:xfrm>
           <a:prstGeom prst="rect">
@@ -10039,7 +10040,7 @@
                 </a:solidFill>
                 <a:latin typeface="Calibri"/>
               </a:rPr>
-              <a:t>StepISTA (16 scalars) matches LISTA. Decoupling θ_k adds 3 dB. Matrix learning is largely redundant.</a:t>
+              <a:t>StepISTA (16 scalars) matches LISTA. Decoupling θₖ adds 3 dB. Matrix learning is largely redundant.</a:t>
             </a:r>
           </a:p>
         </p:txBody>
@@ -15374,41 +15375,30 @@
           </a:prstGeom>
         </p:spPr>
       </p:pic>
-      <p:sp>
-        <p:nvSpPr>
-          <p:cNvPr id="12" name="TextBox 11"/>
-          <p:cNvSpPr txBox="1"/>
-          <p:nvPr/>
-        </p:nvSpPr>
-        <p:spPr>
-          <a:xfrm>
-            <a:off x="685800" y="3611880"/>
-            <a:ext cx="5112867" cy="365760"/>
-          </a:xfrm>
-          <a:prstGeom prst="rect">
-            <a:avLst/>
-          </a:prstGeom>
-          <a:noFill/>
-        </p:spPr>
-        <p:txBody>
-          <a:bodyPr wrap="square">
-            <a:spAutoFit/>
-          </a:bodyPr>
-          <a:lstStyle/>
-          <a:p>
-            <a:pPr algn="l"/>
-            <a:r>
-              <a:rPr sz="1400" b="0" i="0">
-                <a:solidFill>
-                  <a:srgbClr val="4A5568"/>
-                </a:solidFill>
-                <a:latin typeface="Calibri"/>
-              </a:rPr>
-              <a:t>Parameters 1/L and θ = λ/L  are fixed constants.</a:t>
-            </a:r>
-          </a:p>
-        </p:txBody>
-      </p:sp>
+      <p:pic>
+        <p:nvPicPr>
+          <p:cNvPr id="12" name="Picture 11" descr="a9e9803a04e5fa49.png"/>
+          <p:cNvPicPr>
+            <a:picLocks noChangeAspect="1"/>
+          </p:cNvPicPr>
+          <p:nvPr/>
+        </p:nvPicPr>
+        <p:blipFill>
+          <a:blip r:embed="rId4"/>
+          <a:stretch>
+            <a:fillRect/>
+          </a:stretch>
+        </p:blipFill>
+        <p:spPr>
+          <a:xfrm>
+            <a:off x="685800" y="3630168"/>
+            <a:ext cx="3623614" cy="231800"/>
+          </a:xfrm>
+          <a:prstGeom prst="rect">
+            <a:avLst/>
+          </a:prstGeom>
+        </p:spPr>
+      </p:pic>
       <p:sp>
         <p:nvSpPr>
           <p:cNvPr id="13" name="Rectangle 12"/>
@@ -15576,7 +15566,7 @@
           <p:nvPr/>
         </p:nvPicPr>
         <p:blipFill>
-          <a:blip r:embed="rId4"/>
+          <a:blip r:embed="rId5"/>
           <a:stretch>
             <a:fillRect/>
           </a:stretch>
@@ -15600,7 +15590,7 @@
           <p:nvPr/>
         </p:nvPicPr>
         <p:blipFill>
-          <a:blip r:embed="rId5"/>
+          <a:blip r:embed="rId6"/>
           <a:stretch>
             <a:fillRect/>
           </a:stretch>
@@ -15615,41 +15605,30 @@
           </a:prstGeom>
         </p:spPr>
       </p:pic>
-      <p:sp>
-        <p:nvSpPr>
-          <p:cNvPr id="19" name="TextBox 18"/>
-          <p:cNvSpPr txBox="1"/>
-          <p:nvPr/>
-        </p:nvSpPr>
-        <p:spPr>
-          <a:xfrm>
-            <a:off x="6393027" y="3611880"/>
-            <a:ext cx="5112867" cy="365760"/>
-          </a:xfrm>
-          <a:prstGeom prst="rect">
-            <a:avLst/>
-          </a:prstGeom>
-          <a:noFill/>
-        </p:spPr>
-        <p:txBody>
-          <a:bodyPr wrap="square">
-            <a:spAutoFit/>
-          </a:bodyPr>
-          <a:lstStyle/>
-          <a:p>
-            <a:pPr algn="l"/>
-            <a:r>
-              <a:rPr sz="1400" b="0" i="0">
-                <a:solidFill>
-                  <a:srgbClr val="4A5568"/>
-                </a:solidFill>
-                <a:latin typeface="Calibri"/>
-              </a:rPr>
-              <a:t>W_x(k), W_y(k), θ_k  are learned per layer via BPTT.</a:t>
-            </a:r>
-          </a:p>
-        </p:txBody>
-      </p:sp>
+      <p:pic>
+        <p:nvPicPr>
+          <p:cNvPr id="19" name="Picture 18" descr="28a978e09305310a.png"/>
+          <p:cNvPicPr>
+            <a:picLocks noChangeAspect="1"/>
+          </p:cNvPicPr>
+          <p:nvPr/>
+        </p:nvPicPr>
+        <p:blipFill>
+          <a:blip r:embed="rId7"/>
+          <a:stretch>
+            <a:fillRect/>
+          </a:stretch>
+        </p:blipFill>
+        <p:spPr>
+          <a:xfrm>
+            <a:off x="6393027" y="3593592"/>
+            <a:ext cx="3578047" cy="283311"/>
+          </a:xfrm>
+          <a:prstGeom prst="rect">
+            <a:avLst/>
+          </a:prstGeom>
+        </p:spPr>
+      </p:pic>
       <p:sp>
         <p:nvSpPr>
           <p:cNvPr id="20" name="Rectangle 19"/>
@@ -17310,7 +17289,7 @@
         </p:nvSpPr>
         <p:spPr>
           <a:xfrm>
-            <a:off x="502920" y="1627632"/>
+            <a:off x="502920" y="1828800"/>
             <a:ext cx="11185855" cy="320040"/>
           </a:xfrm>
           <a:prstGeom prst="rect">
@@ -17353,7 +17332,7 @@
         </p:blipFill>
         <p:spPr>
           <a:xfrm>
-            <a:off x="3966819" y="2084831"/>
+            <a:off x="3966819" y="2267712"/>
             <a:ext cx="4258056" cy="429768"/>
           </a:xfrm>
           <a:prstGeom prst="rect">
@@ -17369,7 +17348,7 @@
         </p:nvSpPr>
         <p:spPr>
           <a:xfrm>
-            <a:off x="502920" y="2788920"/>
+            <a:off x="502920" y="2852928"/>
             <a:ext cx="11185855" cy="320040"/>
           </a:xfrm>
           <a:prstGeom prst="rect">
@@ -17554,111 +17533,78 @@
           </a:p>
         </p:txBody>
       </p:sp>
-      <p:sp>
-        <p:nvSpPr>
-          <p:cNvPr id="15" name="TextBox 14"/>
-          <p:cNvSpPr txBox="1"/>
-          <p:nvPr/>
-        </p:nvSpPr>
-        <p:spPr>
-          <a:xfrm>
-            <a:off x="640080" y="4069080"/>
-            <a:ext cx="3378098" cy="329184"/>
-          </a:xfrm>
-          <a:prstGeom prst="rect">
-            <a:avLst/>
-          </a:prstGeom>
-          <a:noFill/>
-        </p:spPr>
-        <p:txBody>
-          <a:bodyPr wrap="square">
-            <a:spAutoFit/>
-          </a:bodyPr>
-          <a:lstStyle/>
-          <a:p>
-            <a:pPr algn="l"/>
-            <a:r>
-              <a:rPr sz="1400" b="0" i="0">
-                <a:solidFill>
-                  <a:srgbClr val="1A1A2E"/>
-                </a:solidFill>
-                <a:latin typeface="Calibri"/>
-              </a:rPr>
-              <a:t>Learns  θ₁, …, θ_K  only</a:t>
-            </a:r>
-          </a:p>
-        </p:txBody>
-      </p:sp>
-      <p:sp>
-        <p:nvSpPr>
-          <p:cNvPr id="16" name="TextBox 15"/>
-          <p:cNvSpPr txBox="1"/>
-          <p:nvPr/>
-        </p:nvSpPr>
-        <p:spPr>
-          <a:xfrm>
-            <a:off x="640080" y="4416552"/>
-            <a:ext cx="3378098" cy="329184"/>
-          </a:xfrm>
-          <a:prstGeom prst="rect">
-            <a:avLst/>
-          </a:prstGeom>
-          <a:noFill/>
-        </p:spPr>
-        <p:txBody>
-          <a:bodyPr wrap="square">
-            <a:spAutoFit/>
-          </a:bodyPr>
-          <a:lstStyle/>
-          <a:p>
-            <a:pPr algn="l"/>
-            <a:r>
-              <a:rPr sz="1400" b="0" i="0">
-                <a:solidFill>
-                  <a:srgbClr val="1A1A2E"/>
-                </a:solidFill>
-                <a:latin typeface="Calibri"/>
-              </a:rPr>
-              <a:t>Step fixed at  γ = 1/L</a:t>
-            </a:r>
-          </a:p>
-        </p:txBody>
-      </p:sp>
-      <p:sp>
-        <p:nvSpPr>
-          <p:cNvPr id="17" name="TextBox 16"/>
-          <p:cNvSpPr txBox="1"/>
-          <p:nvPr/>
-        </p:nvSpPr>
-        <p:spPr>
-          <a:xfrm>
-            <a:off x="640080" y="4764024"/>
-            <a:ext cx="3378098" cy="329184"/>
-          </a:xfrm>
-          <a:prstGeom prst="rect">
-            <a:avLst/>
-          </a:prstGeom>
-          <a:noFill/>
-        </p:spPr>
-        <p:txBody>
-          <a:bodyPr wrap="square">
-            <a:spAutoFit/>
-          </a:bodyPr>
-          <a:lstStyle/>
-          <a:p>
-            <a:pPr algn="l"/>
-            <a:r>
-              <a:rPr sz="1400" b="0" i="0">
-                <a:solidFill>
-                  <a:srgbClr val="1A1A2E"/>
-                </a:solidFill>
-                <a:latin typeface="Calibri"/>
-              </a:rPr>
-              <a:t>Init:  θ₀ = λ/L</a:t>
-            </a:r>
-          </a:p>
-        </p:txBody>
-      </p:sp>
+      <p:pic>
+        <p:nvPicPr>
+          <p:cNvPr id="15" name="Picture 14" descr="b6f3c172e92fbdfb.png"/>
+          <p:cNvPicPr>
+            <a:picLocks noChangeAspect="1"/>
+          </p:cNvPicPr>
+          <p:nvPr/>
+        </p:nvPicPr>
+        <p:blipFill>
+          <a:blip r:embed="rId3"/>
+          <a:stretch>
+            <a:fillRect/>
+          </a:stretch>
+        </p:blipFill>
+        <p:spPr>
+          <a:xfrm>
+            <a:off x="640080" y="4114800"/>
+            <a:ext cx="1682038" cy="213969"/>
+          </a:xfrm>
+          <a:prstGeom prst="rect">
+            <a:avLst/>
+          </a:prstGeom>
+        </p:spPr>
+      </p:pic>
+      <p:pic>
+        <p:nvPicPr>
+          <p:cNvPr id="16" name="Picture 15" descr="1da6f78521b455de.png"/>
+          <p:cNvPicPr>
+            <a:picLocks noChangeAspect="1"/>
+          </p:cNvPicPr>
+          <p:nvPr/>
+        </p:nvPicPr>
+        <p:blipFill>
+          <a:blip r:embed="rId4"/>
+          <a:stretch>
+            <a:fillRect/>
+          </a:stretch>
+        </p:blipFill>
+        <p:spPr>
+          <a:xfrm>
+            <a:off x="640080" y="4517136"/>
+            <a:ext cx="1630527" cy="231800"/>
+          </a:xfrm>
+          <a:prstGeom prst="rect">
+            <a:avLst/>
+          </a:prstGeom>
+        </p:spPr>
+      </p:pic>
+      <p:pic>
+        <p:nvPicPr>
+          <p:cNvPr id="17" name="Picture 16" descr="cf050c777f11679f.png"/>
+          <p:cNvPicPr>
+            <a:picLocks noChangeAspect="1"/>
+          </p:cNvPicPr>
+          <p:nvPr/>
+        </p:nvPicPr>
+        <p:blipFill>
+          <a:blip r:embed="rId5"/>
+          <a:stretch>
+            <a:fillRect/>
+          </a:stretch>
+        </p:blipFill>
+        <p:spPr>
+          <a:xfrm>
+            <a:off x="640080" y="4919472"/>
+            <a:ext cx="1105509" cy="231800"/>
+          </a:xfrm>
+          <a:prstGeom prst="rect">
+            <a:avLst/>
+          </a:prstGeom>
+        </p:spPr>
+      </p:pic>
       <p:sp>
         <p:nvSpPr>
           <p:cNvPr id="18" name="Rectangle 17"/>
@@ -17817,111 +17763,78 @@
           </a:p>
         </p:txBody>
       </p:sp>
-      <p:sp>
-        <p:nvSpPr>
-          <p:cNvPr id="22" name="TextBox 21"/>
-          <p:cNvSpPr txBox="1"/>
-          <p:nvPr/>
-        </p:nvSpPr>
-        <p:spPr>
-          <a:xfrm>
-            <a:off x="4361078" y="4069080"/>
-            <a:ext cx="3378098" cy="329184"/>
-          </a:xfrm>
-          <a:prstGeom prst="rect">
-            <a:avLst/>
-          </a:prstGeom>
-          <a:noFill/>
-        </p:spPr>
-        <p:txBody>
-          <a:bodyPr wrap="square">
-            <a:spAutoFit/>
-          </a:bodyPr>
-          <a:lstStyle/>
-          <a:p>
-            <a:pPr algn="l"/>
-            <a:r>
-              <a:rPr sz="1400" b="0" i="0">
-                <a:solidFill>
-                  <a:srgbClr val="1A1A2E"/>
-                </a:solidFill>
-                <a:latin typeface="Calibri"/>
-              </a:rPr>
-              <a:t>Learns  γ₁, …, γ_K  only</a:t>
-            </a:r>
-          </a:p>
-        </p:txBody>
-      </p:sp>
-      <p:sp>
-        <p:nvSpPr>
-          <p:cNvPr id="23" name="TextBox 22"/>
-          <p:cNvSpPr txBox="1"/>
-          <p:nvPr/>
-        </p:nvSpPr>
-        <p:spPr>
-          <a:xfrm>
-            <a:off x="4361078" y="4416552"/>
-            <a:ext cx="3378098" cy="329184"/>
-          </a:xfrm>
-          <a:prstGeom prst="rect">
-            <a:avLst/>
-          </a:prstGeom>
-          <a:noFill/>
-        </p:spPr>
-        <p:txBody>
-          <a:bodyPr wrap="square">
-            <a:spAutoFit/>
-          </a:bodyPr>
-          <a:lstStyle/>
-          <a:p>
-            <a:pPr algn="l"/>
-            <a:r>
-              <a:rPr sz="1400" b="0" i="0">
-                <a:solidFill>
-                  <a:srgbClr val="1A1A2E"/>
-                </a:solidFill>
-                <a:latin typeface="Calibri"/>
-              </a:rPr>
-              <a:t>Threshold coupled:  θ_k = λγ_k</a:t>
-            </a:r>
-          </a:p>
-        </p:txBody>
-      </p:sp>
-      <p:sp>
-        <p:nvSpPr>
-          <p:cNvPr id="24" name="TextBox 23"/>
-          <p:cNvSpPr txBox="1"/>
-          <p:nvPr/>
-        </p:nvSpPr>
-        <p:spPr>
-          <a:xfrm>
-            <a:off x="4361078" y="4764024"/>
-            <a:ext cx="3378098" cy="329184"/>
-          </a:xfrm>
-          <a:prstGeom prst="rect">
-            <a:avLst/>
-          </a:prstGeom>
-          <a:noFill/>
-        </p:spPr>
-        <p:txBody>
-          <a:bodyPr wrap="square">
-            <a:spAutoFit/>
-          </a:bodyPr>
-          <a:lstStyle/>
-          <a:p>
-            <a:pPr algn="l"/>
-            <a:r>
-              <a:rPr sz="1400" b="0" i="0">
-                <a:solidFill>
-                  <a:srgbClr val="1A1A2E"/>
-                </a:solidFill>
-                <a:latin typeface="Calibri"/>
-              </a:rPr>
-              <a:t>Init:  γ₀ = 1/L</a:t>
-            </a:r>
-          </a:p>
-        </p:txBody>
-      </p:sp>
+      <p:pic>
+        <p:nvPicPr>
+          <p:cNvPr id="22" name="Picture 21" descr="3c9f4b211736acd6.png"/>
+          <p:cNvPicPr>
+            <a:picLocks noChangeAspect="1"/>
+          </p:cNvPicPr>
+          <p:nvPr/>
+        </p:nvPicPr>
+        <p:blipFill>
+          <a:blip r:embed="rId6"/>
+          <a:stretch>
+            <a:fillRect/>
+          </a:stretch>
+        </p:blipFill>
+        <p:spPr>
+          <a:xfrm>
+            <a:off x="4361078" y="4114800"/>
+            <a:ext cx="1697888" cy="213969"/>
+          </a:xfrm>
+          <a:prstGeom prst="rect">
+            <a:avLst/>
+          </a:prstGeom>
+        </p:spPr>
+      </p:pic>
+      <p:pic>
+        <p:nvPicPr>
+          <p:cNvPr id="23" name="Picture 22" descr="4cb5d07eb104900d.png"/>
+          <p:cNvPicPr>
+            <a:picLocks noChangeAspect="1"/>
+          </p:cNvPicPr>
+          <p:nvPr/>
+        </p:nvPicPr>
+        <p:blipFill>
+          <a:blip r:embed="rId7"/>
+          <a:stretch>
+            <a:fillRect/>
+          </a:stretch>
+        </p:blipFill>
+        <p:spPr>
+          <a:xfrm>
+            <a:off x="4361078" y="4517136"/>
+            <a:ext cx="2151583" cy="213969"/>
+          </a:xfrm>
+          <a:prstGeom prst="rect">
+            <a:avLst/>
+          </a:prstGeom>
+        </p:spPr>
+      </p:pic>
+      <p:pic>
+        <p:nvPicPr>
+          <p:cNvPr id="24" name="Picture 23" descr="2c252a19a37b9640.png"/>
+          <p:cNvPicPr>
+            <a:picLocks noChangeAspect="1"/>
+          </p:cNvPicPr>
+          <p:nvPr/>
+        </p:nvPicPr>
+        <p:blipFill>
+          <a:blip r:embed="rId8"/>
+          <a:stretch>
+            <a:fillRect/>
+          </a:stretch>
+        </p:blipFill>
+        <p:spPr>
+          <a:xfrm>
+            <a:off x="4361078" y="4919472"/>
+            <a:ext cx="1101547" cy="231800"/>
+          </a:xfrm>
+          <a:prstGeom prst="rect">
+            <a:avLst/>
+          </a:prstGeom>
+        </p:spPr>
+      </p:pic>
       <p:sp>
         <p:nvSpPr>
           <p:cNvPr id="25" name="Rectangle 24"/>
@@ -18080,41 +17993,30 @@
           </a:p>
         </p:txBody>
       </p:sp>
-      <p:sp>
-        <p:nvSpPr>
-          <p:cNvPr id="29" name="TextBox 28"/>
-          <p:cNvSpPr txBox="1"/>
-          <p:nvPr/>
-        </p:nvSpPr>
-        <p:spPr>
-          <a:xfrm>
-            <a:off x="8082076" y="4069080"/>
-            <a:ext cx="3378098" cy="329184"/>
-          </a:xfrm>
-          <a:prstGeom prst="rect">
-            <a:avLst/>
-          </a:prstGeom>
-          <a:noFill/>
-        </p:spPr>
-        <p:txBody>
-          <a:bodyPr wrap="square">
-            <a:spAutoFit/>
-          </a:bodyPr>
-          <a:lstStyle/>
-          <a:p>
-            <a:pPr algn="l"/>
-            <a:r>
-              <a:rPr sz="1400" b="0" i="0">
-                <a:solidFill>
-                  <a:srgbClr val="1A1A2E"/>
-                </a:solidFill>
-                <a:latin typeface="Calibri"/>
-              </a:rPr>
-              <a:t>Learns both  γ_k  and  θ_k</a:t>
-            </a:r>
-          </a:p>
-        </p:txBody>
-      </p:sp>
+      <p:pic>
+        <p:nvPicPr>
+          <p:cNvPr id="29" name="Picture 28" descr="ee5733e0f8333b8f.png"/>
+          <p:cNvPicPr>
+            <a:picLocks noChangeAspect="1"/>
+          </p:cNvPicPr>
+          <p:nvPr/>
+        </p:nvPicPr>
+        <p:blipFill>
+          <a:blip r:embed="rId9"/>
+          <a:stretch>
+            <a:fillRect/>
+          </a:stretch>
+        </p:blipFill>
+        <p:spPr>
+          <a:xfrm>
+            <a:off x="8082076" y="4114800"/>
+            <a:ext cx="1687982" cy="213969"/>
+          </a:xfrm>
+          <a:prstGeom prst="rect">
+            <a:avLst/>
+          </a:prstGeom>
+        </p:spPr>
+      </p:pic>
       <p:sp>
         <p:nvSpPr>
           <p:cNvPr id="30" name="TextBox 29"/>
@@ -18123,7 +18025,7 @@
         </p:nvSpPr>
         <p:spPr>
           <a:xfrm>
-            <a:off x="8082076" y="4416552"/>
+            <a:off x="8082076" y="4480560"/>
             <a:ext cx="3378098" cy="329184"/>
           </a:xfrm>
           <a:prstGeom prst="rect">
@@ -18158,7 +18060,7 @@
         </p:nvSpPr>
         <p:spPr>
           <a:xfrm>
-            <a:off x="8082076" y="4764024"/>
+            <a:off x="8082076" y="4882896"/>
             <a:ext cx="3378098" cy="329184"/>
           </a:xfrm>
           <a:prstGeom prst="rect">
@@ -19103,7 +19005,7 @@
               </a:defRPr>
             </a:pPr>
             <a:r>
-              <a:t>Learning γ_k alone (16 scalars) already</a:t>
+              <a:t>Learning γₖ alone (16 scalars) already</a:t>
             </a:r>
           </a:p>
           <a:p>
@@ -19148,7 +19050,7 @@
               </a:defRPr>
             </a:pPr>
             <a:r>
-              <a:t>Decoupling θ_k adds 3 dB at zero extra cost.</a:t>
+              <a:t>Decoupling θₖ adds 3 dB at zero extra cost.</a:t>
             </a:r>
           </a:p>
           <a:p>

</xml_diff>